<commit_message>
Finalizing diploma and presentation. ToDo write new presentation script
</commit_message>
<xml_diff>
--- a/Presentation/NMSTU_Presentation.pptx
+++ b/Presentation/NMSTU_Presentation.pptx
@@ -5,10 +5,10 @@
     <p:sldMasterId id="2147483648" r:id="rId1"/>
   </p:sldMasterIdLst>
   <p:notesMasterIdLst>
-    <p:notesMasterId r:id="rId14"/>
+    <p:notesMasterId r:id="rId15"/>
   </p:notesMasterIdLst>
   <p:handoutMasterIdLst>
-    <p:handoutMasterId r:id="rId15"/>
+    <p:handoutMasterId r:id="rId16"/>
   </p:handoutMasterIdLst>
   <p:sldIdLst>
     <p:sldId id="256" r:id="rId2"/>
@@ -21,8 +21,9 @@
     <p:sldId id="261" r:id="rId9"/>
     <p:sldId id="275" r:id="rId10"/>
     <p:sldId id="271" r:id="rId11"/>
-    <p:sldId id="272" r:id="rId12"/>
-    <p:sldId id="265" r:id="rId13"/>
+    <p:sldId id="277" r:id="rId12"/>
+    <p:sldId id="272" r:id="rId13"/>
+    <p:sldId id="265" r:id="rId14"/>
   </p:sldIdLst>
   <p:sldSz cx="12192000" cy="6858000"/>
   <p:notesSz cx="6888163" cy="10020300"/>
@@ -226,7 +227,7 @@
           <a:p>
             <a:fld id="{1E26F5DA-879A-4326-91CA-0B965521B3A2}" type="datetimeFigureOut">
               <a:rPr lang="ru-RU" smtClean="0"/>
-              <a:t>13.06.2025</a:t>
+              <a:t>14.06.2025</a:t>
             </a:fld>
             <a:endParaRPr lang="ru-RU"/>
           </a:p>
@@ -403,7 +404,7 @@
           <a:p>
             <a:fld id="{536AE87B-970E-4FB6-80B1-2A90D9E8F8EA}" type="datetimeFigureOut">
               <a:rPr lang="en-US" smtClean="0"/>
-              <a:t>6/13/2025</a:t>
+              <a:t>6/14/2025</a:t>
             </a:fld>
             <a:endParaRPr lang="en-US"/>
           </a:p>
@@ -914,7 +915,13 @@
   <p:cSld>
     <p:spTree>
       <p:nvGrpSpPr>
-        <p:cNvPr id="1" name=""/>
+        <p:cNvPr id="1" name="">
+          <a:extLst>
+            <a:ext uri="{FF2B5EF4-FFF2-40B4-BE49-F238E27FC236}">
+              <a16:creationId xmlns:a16="http://schemas.microsoft.com/office/drawing/2014/main" id="{BFE73211-DE71-5E26-1C70-5F6526FFE3B3}"/>
+            </a:ext>
+          </a:extLst>
+        </p:cNvPr>
         <p:cNvGrpSpPr/>
         <p:nvPr/>
       </p:nvGrpSpPr>
@@ -928,7 +935,13 @@
       </p:grpSpPr>
       <p:sp>
         <p:nvSpPr>
-          <p:cNvPr id="2" name="Slide Image Placeholder 1"/>
+          <p:cNvPr id="2" name="Slide Image Placeholder 1">
+            <a:extLst>
+              <a:ext uri="{FF2B5EF4-FFF2-40B4-BE49-F238E27FC236}">
+                <a16:creationId xmlns:a16="http://schemas.microsoft.com/office/drawing/2014/main" id="{7DA65255-6538-44E6-FD74-B8121AFF84E3}"/>
+              </a:ext>
+            </a:extLst>
+          </p:cNvPr>
           <p:cNvSpPr>
             <a:spLocks noGrp="1" noRot="1" noChangeAspect="1"/>
           </p:cNvSpPr>
@@ -940,7 +953,13 @@
       </p:sp>
       <p:sp>
         <p:nvSpPr>
-          <p:cNvPr id="3" name="Notes Placeholder 2"/>
+          <p:cNvPr id="3" name="Notes Placeholder 2">
+            <a:extLst>
+              <a:ext uri="{FF2B5EF4-FFF2-40B4-BE49-F238E27FC236}">
+                <a16:creationId xmlns:a16="http://schemas.microsoft.com/office/drawing/2014/main" id="{BF62D79F-2378-EE38-1237-390D4EC47AD8}"/>
+              </a:ext>
+            </a:extLst>
+          </p:cNvPr>
           <p:cNvSpPr>
             <a:spLocks noGrp="1"/>
           </p:cNvSpPr>
@@ -955,46 +974,118 @@
           <a:p>
             <a:r>
               <a:rPr lang="ru-RU" dirty="0"/>
-              <a:t>По итогам, поставленная цель исследования была достигнута. Полученное проектное решение даст клиентам компании Компас плюс такие преимущества, как:</a:t>
-            </a:r>
-          </a:p>
-          <a:p>
-            <a:endParaRPr lang="ru-RU" dirty="0"/>
-          </a:p>
-          <a:p>
-            <a:r>
-              <a:rPr lang="ru-RU" dirty="0"/>
-              <a:t>-Повышение скорости выпуска карт</a:t>
-            </a:r>
-          </a:p>
-          <a:p>
-            <a:r>
-              <a:rPr lang="ru-RU" dirty="0"/>
-              <a:t>-Отсутствие необходимости прерывать процесс персонализации карты для записи чипа карт, весь процесс будет происходить непрерывно</a:t>
-            </a:r>
-          </a:p>
-          <a:p>
-            <a:r>
-              <a:rPr lang="ru-RU" dirty="0"/>
-              <a:t>-Возможность удаленной работы с кардридерным модулем</a:t>
-            </a:r>
-          </a:p>
-          <a:p>
-            <a:r>
-              <a:rPr lang="ru-RU" dirty="0"/>
-              <a:t>-Возможность настройки кардридерного модуля внутри собственного продукта</a:t>
-            </a:r>
+              <a:t>Конечно, существуют и текущие решения по персонализации банковских карт с помощью эмбоссеров </a:t>
+            </a:r>
+            <a:r>
+              <a:rPr lang="en-US" dirty="0"/>
+              <a:t>MATICA.</a:t>
+            </a:r>
+            <a:r>
+              <a:rPr lang="en-US" baseline="0" dirty="0"/>
+              <a:t> </a:t>
+            </a:r>
+            <a:r>
+              <a:rPr lang="ru-RU" baseline="0" dirty="0"/>
+              <a:t>На данной схеме вы можете видеть такой процесс. Карты загружаются в эмбоссер</a:t>
+            </a:r>
+            <a:r>
+              <a:rPr lang="en-US" baseline="0" dirty="0"/>
+              <a:t>,</a:t>
+            </a:r>
+            <a:r>
+              <a:rPr lang="ru-RU" baseline="0" dirty="0"/>
+              <a:t> после чего запускается специализированное ПО </a:t>
+            </a:r>
+            <a:r>
+              <a:rPr lang="en-US" baseline="0" dirty="0" err="1"/>
+              <a:t>Matcard</a:t>
+            </a:r>
+            <a:r>
+              <a:rPr lang="en-US" baseline="0" dirty="0"/>
+              <a:t> PRO, </a:t>
+            </a:r>
+            <a:r>
+              <a:rPr lang="ru-RU" baseline="0" dirty="0"/>
+              <a:t>которое подключается к эмбоссеру, и </a:t>
+            </a:r>
+            <a:r>
+              <a:rPr lang="en-US" baseline="0" dirty="0" err="1"/>
+              <a:t>TranzWare</a:t>
+            </a:r>
+            <a:r>
+              <a:rPr lang="en-US" baseline="0" dirty="0"/>
+              <a:t> </a:t>
+            </a:r>
+            <a:r>
+              <a:rPr lang="en-US" baseline="0" dirty="0" err="1"/>
+              <a:t>CardFactory</a:t>
+            </a:r>
+            <a:r>
+              <a:rPr lang="en-US" baseline="0" dirty="0"/>
+              <a:t>, </a:t>
+            </a:r>
+            <a:r>
+              <a:rPr lang="ru-RU" baseline="0" dirty="0"/>
+              <a:t>которое передает данные для эмбоссирования в </a:t>
+            </a:r>
+            <a:r>
+              <a:rPr lang="en-US" baseline="0" dirty="0" err="1"/>
+              <a:t>Maticard</a:t>
+            </a:r>
+            <a:r>
+              <a:rPr lang="en-US" baseline="0" dirty="0"/>
+              <a:t> PRO</a:t>
+            </a:r>
+            <a:r>
+              <a:rPr lang="ru-RU" baseline="0" dirty="0"/>
+              <a:t>. После завершения </a:t>
+            </a:r>
+            <a:r>
+              <a:rPr lang="en-US" baseline="0" dirty="0" err="1"/>
+              <a:t>Maticard</a:t>
+            </a:r>
+            <a:r>
+              <a:rPr lang="ru-RU" baseline="0" dirty="0"/>
+              <a:t> эмбоссирует карту и</a:t>
+            </a:r>
+            <a:r>
+              <a:rPr lang="en-US" baseline="0" dirty="0"/>
+              <a:t> </a:t>
+            </a:r>
+            <a:r>
+              <a:rPr lang="ru-RU" baseline="0" dirty="0"/>
+              <a:t>передает команду </a:t>
+            </a:r>
+            <a:r>
+              <a:rPr lang="en-US" baseline="0" dirty="0" err="1"/>
+              <a:t>CardFactory</a:t>
+            </a:r>
+            <a:r>
+              <a:rPr lang="en-US" baseline="0" dirty="0"/>
+              <a:t> </a:t>
+            </a:r>
+            <a:r>
+              <a:rPr lang="ru-RU" baseline="0" dirty="0"/>
+              <a:t>о том, что процесс был завершен, но так как вариантов связи с кардридерным модулем нету, он был пропущен в эмбоссере и необходимо загрузить карты в отдельный кардридер для записи после завершения эмбоссирования, что замедляет процесс выпуска карт.</a:t>
+            </a:r>
+            <a:endParaRPr lang="en-US" dirty="0"/>
           </a:p>
         </p:txBody>
       </p:sp>
       <p:sp>
         <p:nvSpPr>
-          <p:cNvPr id="4" name="Slide Number Placeholder 3"/>
+          <p:cNvPr id="4" name="Slide Number Placeholder 3">
+            <a:extLst>
+              <a:ext uri="{FF2B5EF4-FFF2-40B4-BE49-F238E27FC236}">
+                <a16:creationId xmlns:a16="http://schemas.microsoft.com/office/drawing/2014/main" id="{F740FFB1-FF7B-77FA-AF50-985EBDBF3B11}"/>
+              </a:ext>
+            </a:extLst>
+          </p:cNvPr>
           <p:cNvSpPr>
             <a:spLocks noGrp="1"/>
           </p:cNvSpPr>
           <p:nvPr>
-            <p:ph type="sldNum" sz="quarter" idx="5"/>
+            <p:ph type="sldNum" sz="quarter" idx="10"/>
           </p:nvPr>
         </p:nvSpPr>
         <p:spPr/>
@@ -1013,7 +1104,7 @@
     </p:spTree>
     <p:extLst>
       <p:ext uri="{BB962C8B-B14F-4D97-AF65-F5344CB8AC3E}">
-        <p14:creationId xmlns:p14="http://schemas.microsoft.com/office/powerpoint/2010/main" val="2940804552"/>
+        <p14:creationId xmlns:p14="http://schemas.microsoft.com/office/powerpoint/2010/main" val="1205131858"/>
       </p:ext>
     </p:extLst>
   </p:cSld>
@@ -1067,7 +1158,37 @@
           <a:bodyPr/>
           <a:lstStyle/>
           <a:p>
+            <a:r>
+              <a:rPr lang="ru-RU" dirty="0"/>
+              <a:t>По итогам, поставленная цель исследования была достигнута. Полученное проектное решение даст клиентам компании Компас плюс такие преимущества, как:</a:t>
+            </a:r>
+          </a:p>
+          <a:p>
             <a:endParaRPr lang="ru-RU" dirty="0"/>
+          </a:p>
+          <a:p>
+            <a:r>
+              <a:rPr lang="ru-RU" dirty="0"/>
+              <a:t>-Повышение скорости выпуска карт</a:t>
+            </a:r>
+          </a:p>
+          <a:p>
+            <a:r>
+              <a:rPr lang="ru-RU" dirty="0"/>
+              <a:t>-Отсутствие необходимости прерывать процесс персонализации карты для записи чипа карт, весь процесс будет происходить непрерывно</a:t>
+            </a:r>
+          </a:p>
+          <a:p>
+            <a:r>
+              <a:rPr lang="ru-RU" dirty="0"/>
+              <a:t>-Возможность удаленной работы с кардридерным модулем</a:t>
+            </a:r>
+          </a:p>
+          <a:p>
+            <a:r>
+              <a:rPr lang="ru-RU" dirty="0"/>
+              <a:t>-Возможность настройки кардридерного модуля внутри собственного продукта</a:t>
+            </a:r>
           </a:p>
         </p:txBody>
       </p:sp>
@@ -1089,6 +1210,90 @@
             <a:fld id="{98286526-F0ED-4506-B36C-96EAE6EA1894}" type="slidenum">
               <a:rPr lang="en-US" smtClean="0"/>
               <a:t>12</a:t>
+            </a:fld>
+            <a:endParaRPr lang="en-US"/>
+          </a:p>
+        </p:txBody>
+      </p:sp>
+    </p:spTree>
+    <p:extLst>
+      <p:ext uri="{BB962C8B-B14F-4D97-AF65-F5344CB8AC3E}">
+        <p14:creationId xmlns:p14="http://schemas.microsoft.com/office/powerpoint/2010/main" val="2940804552"/>
+      </p:ext>
+    </p:extLst>
+  </p:cSld>
+  <p:clrMapOvr>
+    <a:masterClrMapping/>
+  </p:clrMapOvr>
+</p:notes>
+</file>
+
+<file path=ppt/notesSlides/notesSlide13.xml><?xml version="1.0" encoding="utf-8"?>
+<p:notes xmlns:a="http://schemas.openxmlformats.org/drawingml/2006/main" xmlns:r="http://schemas.openxmlformats.org/officeDocument/2006/relationships" xmlns:p="http://schemas.openxmlformats.org/presentationml/2006/main">
+  <p:cSld>
+    <p:spTree>
+      <p:nvGrpSpPr>
+        <p:cNvPr id="1" name=""/>
+        <p:cNvGrpSpPr/>
+        <p:nvPr/>
+      </p:nvGrpSpPr>
+      <p:grpSpPr>
+        <a:xfrm>
+          <a:off x="0" y="0"/>
+          <a:ext cx="0" cy="0"/>
+          <a:chOff x="0" y="0"/>
+          <a:chExt cx="0" cy="0"/>
+        </a:xfrm>
+      </p:grpSpPr>
+      <p:sp>
+        <p:nvSpPr>
+          <p:cNvPr id="2" name="Slide Image Placeholder 1"/>
+          <p:cNvSpPr>
+            <a:spLocks noGrp="1" noRot="1" noChangeAspect="1"/>
+          </p:cNvSpPr>
+          <p:nvPr>
+            <p:ph type="sldImg"/>
+          </p:nvPr>
+        </p:nvSpPr>
+        <p:spPr/>
+      </p:sp>
+      <p:sp>
+        <p:nvSpPr>
+          <p:cNvPr id="3" name="Notes Placeholder 2"/>
+          <p:cNvSpPr>
+            <a:spLocks noGrp="1"/>
+          </p:cNvSpPr>
+          <p:nvPr>
+            <p:ph type="body" idx="1"/>
+          </p:nvPr>
+        </p:nvSpPr>
+        <p:spPr/>
+        <p:txBody>
+          <a:bodyPr/>
+          <a:lstStyle/>
+          <a:p>
+            <a:endParaRPr lang="ru-RU" dirty="0"/>
+          </a:p>
+        </p:txBody>
+      </p:sp>
+      <p:sp>
+        <p:nvSpPr>
+          <p:cNvPr id="4" name="Slide Number Placeholder 3"/>
+          <p:cNvSpPr>
+            <a:spLocks noGrp="1"/>
+          </p:cNvSpPr>
+          <p:nvPr>
+            <p:ph type="sldNum" sz="quarter" idx="5"/>
+          </p:nvPr>
+        </p:nvSpPr>
+        <p:spPr/>
+        <p:txBody>
+          <a:bodyPr/>
+          <a:lstStyle/>
+          <a:p>
+            <a:fld id="{98286526-F0ED-4506-B36C-96EAE6EA1894}" type="slidenum">
+              <a:rPr lang="en-US" smtClean="0"/>
+              <a:t>13</a:t>
             </a:fld>
             <a:endParaRPr lang="en-US"/>
           </a:p>
@@ -2468,7 +2673,7 @@
           <a:p>
             <a:fld id="{2BA16B55-A083-400A-A53D-83CD673D7AB5}" type="datetime1">
               <a:rPr lang="ru-RU" smtClean="0"/>
-              <a:t>13.06.2025</a:t>
+              <a:t>14.06.2025</a:t>
             </a:fld>
             <a:endParaRPr lang="ru-RU"/>
           </a:p>
@@ -2641,7 +2846,7 @@
           <a:p>
             <a:fld id="{E2DC6F81-D76A-46BC-82B2-E452FF2CA9C5}" type="datetime1">
               <a:rPr lang="ru-RU" smtClean="0"/>
-              <a:t>13.06.2025</a:t>
+              <a:t>14.06.2025</a:t>
             </a:fld>
             <a:endParaRPr lang="ru-RU"/>
           </a:p>
@@ -2819,7 +3024,7 @@
           <a:p>
             <a:fld id="{48484A5D-C6EA-476C-B204-F5D11ADE9E0C}" type="datetime1">
               <a:rPr lang="ru-RU" smtClean="0"/>
-              <a:t>13.06.2025</a:t>
+              <a:t>14.06.2025</a:t>
             </a:fld>
             <a:endParaRPr lang="ru-RU"/>
           </a:p>
@@ -2987,7 +3192,7 @@
           <a:p>
             <a:fld id="{EB2C1C20-8488-406D-BEC1-3EBBFF7F0C88}" type="datetime1">
               <a:rPr lang="ru-RU" smtClean="0"/>
-              <a:t>13.06.2025</a:t>
+              <a:t>14.06.2025</a:t>
             </a:fld>
             <a:endParaRPr lang="ru-RU"/>
           </a:p>
@@ -3237,7 +3442,7 @@
           <a:p>
             <a:fld id="{B64FA3E3-1B09-48E4-B3AA-C803D5E16A77}" type="datetime1">
               <a:rPr lang="ru-RU" smtClean="0"/>
-              <a:t>13.06.2025</a:t>
+              <a:t>14.06.2025</a:t>
             </a:fld>
             <a:endParaRPr lang="ru-RU"/>
           </a:p>
@@ -3466,7 +3671,7 @@
           <a:p>
             <a:fld id="{62A63F76-3CA2-4748-A29D-2AB22D0BEB5B}" type="datetime1">
               <a:rPr lang="ru-RU" smtClean="0"/>
-              <a:t>13.06.2025</a:t>
+              <a:t>14.06.2025</a:t>
             </a:fld>
             <a:endParaRPr lang="ru-RU"/>
           </a:p>
@@ -3830,7 +4035,7 @@
           <a:p>
             <a:fld id="{A544ED6F-8BE4-4669-B0A3-175B5B131B11}" type="datetime1">
               <a:rPr lang="ru-RU" smtClean="0"/>
-              <a:t>13.06.2025</a:t>
+              <a:t>14.06.2025</a:t>
             </a:fld>
             <a:endParaRPr lang="ru-RU"/>
           </a:p>
@@ -3952,7 +4157,7 @@
           <a:p>
             <a:fld id="{4737DC02-F460-4FDC-95DB-DC6352A1EE94}" type="datetime1">
               <a:rPr lang="ru-RU" smtClean="0"/>
-              <a:t>13.06.2025</a:t>
+              <a:t>14.06.2025</a:t>
             </a:fld>
             <a:endParaRPr lang="ru-RU"/>
           </a:p>
@@ -4052,7 +4257,7 @@
           <a:p>
             <a:fld id="{6EB7CF50-D4ED-4F06-9251-EFB3C02E6C46}" type="datetime1">
               <a:rPr lang="ru-RU" smtClean="0"/>
-              <a:t>13.06.2025</a:t>
+              <a:t>14.06.2025</a:t>
             </a:fld>
             <a:endParaRPr lang="ru-RU"/>
           </a:p>
@@ -4332,7 +4537,7 @@
           <a:p>
             <a:fld id="{FA48FBA7-1AD2-4D2B-BCA1-27950A33E466}" type="datetime1">
               <a:rPr lang="ru-RU" smtClean="0"/>
-              <a:t>13.06.2025</a:t>
+              <a:t>14.06.2025</a:t>
             </a:fld>
             <a:endParaRPr lang="ru-RU"/>
           </a:p>
@@ -4584,7 +4789,7 @@
           <a:p>
             <a:fld id="{E233C2C1-A2CA-49E6-9101-CA7FFB180E53}" type="datetime1">
               <a:rPr lang="ru-RU" smtClean="0"/>
-              <a:t>13.06.2025</a:t>
+              <a:t>14.06.2025</a:t>
             </a:fld>
             <a:endParaRPr lang="ru-RU"/>
           </a:p>
@@ -4795,7 +5000,7 @@
           <a:p>
             <a:fld id="{642239AA-F603-409E-949B-21A349D872FF}" type="datetime1">
               <a:rPr lang="ru-RU" smtClean="0"/>
-              <a:t>13.06.2025</a:t>
+              <a:t>14.06.2025</a:t>
             </a:fld>
             <a:endParaRPr lang="ru-RU"/>
           </a:p>
@@ -6040,8 +6245,8 @@
         </p:nvSpPr>
         <p:spPr>
           <a:xfrm>
-            <a:off x="2812894" y="144340"/>
-            <a:ext cx="6700873" cy="584775"/>
+            <a:off x="1985027" y="114240"/>
+            <a:ext cx="8331127" cy="707886"/>
           </a:xfrm>
           <a:prstGeom prst="rect">
             <a:avLst/>
@@ -6056,7 +6261,7 @@
           <a:p>
             <a:pPr algn="ctr"/>
             <a:r>
-              <a:rPr lang="ru-RU" sz="3200" dirty="0">
+              <a:rPr lang="ru-RU" sz="4000" dirty="0">
                 <a:solidFill>
                   <a:schemeClr val="bg1">
                     <a:lumMod val="95000"/>
@@ -6132,7 +6337,7 @@
         </p:nvSpPr>
         <p:spPr>
           <a:xfrm>
-            <a:off x="4069111" y="1237759"/>
+            <a:off x="4049612" y="1718977"/>
             <a:ext cx="2862929" cy="461665"/>
           </a:xfrm>
           <a:prstGeom prst="rect">
@@ -6411,8 +6616,8 @@
         </p:nvSpPr>
         <p:spPr>
           <a:xfrm>
-            <a:off x="3444942" y="1830415"/>
-            <a:ext cx="4072270" cy="4828654"/>
+            <a:off x="3444942" y="2328529"/>
+            <a:ext cx="4072270" cy="3636335"/>
           </a:xfrm>
           <a:prstGeom prst="rect">
             <a:avLst/>
@@ -6598,8 +6803,8 @@
         </p:nvSpPr>
         <p:spPr>
           <a:xfrm>
-            <a:off x="3631104" y="2060041"/>
-            <a:ext cx="3738941" cy="4143891"/>
+            <a:off x="3631104" y="2457916"/>
+            <a:ext cx="3738941" cy="3359061"/>
           </a:xfrm>
           <a:prstGeom prst="rect">
             <a:avLst/>
@@ -6614,7 +6819,7 @@
           <a:p>
             <a:pPr marL="285750" indent="-285750">
               <a:lnSpc>
-                <a:spcPct val="200000"/>
+                <a:spcPct val="150000"/>
               </a:lnSpc>
               <a:buFont typeface="Calibri" panose="020F0502020204030204" pitchFamily="34" charset="0"/>
               <a:buChar char="‒"/>
@@ -6635,86 +6840,86 @@
           <a:p>
             <a:pPr marL="285750" indent="-285750">
               <a:lnSpc>
-                <a:spcPct val="200000"/>
-              </a:lnSpc>
-              <a:spcAft>
-                <a:spcPts val="2400"/>
-              </a:spcAft>
-              <a:buFont typeface="Calibri" panose="020F0502020204030204" pitchFamily="34" charset="0"/>
-              <a:buChar char="‒"/>
-            </a:pPr>
-            <a:r>
-              <a:rPr lang="en-US" sz="2400" dirty="0"/>
-              <a:t>void </a:t>
-            </a:r>
-            <a:r>
-              <a:rPr lang="en-US" sz="2400" dirty="0" err="1"/>
-              <a:t>WaitCard</a:t>
-            </a:r>
-            <a:r>
-              <a:rPr lang="en-US" sz="2400" dirty="0"/>
-              <a:t>()</a:t>
-            </a:r>
-          </a:p>
-          <a:p>
-            <a:pPr marL="285750" indent="-285750">
-              <a:buFont typeface="Calibri" panose="020F0502020204030204" pitchFamily="34" charset="0"/>
-              <a:buChar char="‒"/>
-            </a:pPr>
-            <a:r>
-              <a:rPr lang="en-US" sz="2400" dirty="0"/>
-              <a:t>int Transfer(</a:t>
-            </a:r>
-            <a:r>
-              <a:rPr lang="en-US" sz="2400" dirty="0" err="1"/>
-              <a:t>RStr</a:t>
-            </a:r>
-            <a:r>
-              <a:rPr lang="en-US" sz="2400" dirty="0"/>
-              <a:t> </a:t>
-            </a:r>
-            <a:r>
-              <a:rPr lang="en-US" sz="2400" dirty="0" err="1"/>
-              <a:t>sendData</a:t>
-            </a:r>
-            <a:r>
-              <a:rPr lang="en-US" sz="2400" dirty="0"/>
-              <a:t>, </a:t>
-            </a:r>
-            <a:r>
-              <a:rPr lang="en-US" sz="2400" dirty="0" err="1"/>
-              <a:t>LStr</a:t>
-            </a:r>
-            <a:r>
-              <a:rPr lang="en-US" sz="2400" dirty="0"/>
-              <a:t> </a:t>
-            </a:r>
-            <a:r>
-              <a:rPr lang="en-US" sz="2400" dirty="0" err="1"/>
-              <a:t>recvData</a:t>
-            </a:r>
-            <a:r>
-              <a:rPr lang="en-US" sz="2400" dirty="0"/>
-              <a:t>)</a:t>
-            </a:r>
-          </a:p>
-          <a:p>
-            <a:pPr marL="285750" indent="-285750">
-              <a:lnSpc>
-                <a:spcPct val="200000"/>
+                <a:spcPct val="150000"/>
               </a:lnSpc>
               <a:buFont typeface="Calibri" panose="020F0502020204030204" pitchFamily="34" charset="0"/>
               <a:buChar char="‒"/>
             </a:pPr>
             <a:r>
               <a:rPr lang="en-US" sz="2400" dirty="0"/>
-              <a:t>void Restart()</a:t>
+              <a:t>void </a:t>
+            </a:r>
+            <a:r>
+              <a:rPr lang="en-US" sz="2400" dirty="0" err="1"/>
+              <a:t>WaitCard</a:t>
+            </a:r>
+            <a:r>
+              <a:rPr lang="en-US" sz="2400" dirty="0"/>
+              <a:t>()</a:t>
             </a:r>
           </a:p>
           <a:p>
             <a:pPr marL="285750" indent="-285750">
               <a:lnSpc>
-                <a:spcPct val="200000"/>
+                <a:spcPct val="150000"/>
+              </a:lnSpc>
+              <a:buFont typeface="Calibri" panose="020F0502020204030204" pitchFamily="34" charset="0"/>
+              <a:buChar char="‒"/>
+            </a:pPr>
+            <a:r>
+              <a:rPr lang="en-US" sz="2400" dirty="0"/>
+              <a:t>int Transfer(</a:t>
+            </a:r>
+            <a:r>
+              <a:rPr lang="en-US" sz="2400" dirty="0" err="1"/>
+              <a:t>RStr</a:t>
+            </a:r>
+            <a:r>
+              <a:rPr lang="en-US" sz="2400" dirty="0"/>
+              <a:t> </a:t>
+            </a:r>
+            <a:r>
+              <a:rPr lang="en-US" sz="2400" dirty="0" err="1"/>
+              <a:t>sendData</a:t>
+            </a:r>
+            <a:r>
+              <a:rPr lang="en-US" sz="2400" dirty="0"/>
+              <a:t>, </a:t>
+            </a:r>
+            <a:r>
+              <a:rPr lang="en-US" sz="2400" dirty="0" err="1"/>
+              <a:t>LStr</a:t>
+            </a:r>
+            <a:r>
+              <a:rPr lang="en-US" sz="2400" dirty="0"/>
+              <a:t> </a:t>
+            </a:r>
+            <a:r>
+              <a:rPr lang="en-US" sz="2400" dirty="0" err="1"/>
+              <a:t>recvData</a:t>
+            </a:r>
+            <a:r>
+              <a:rPr lang="en-US" sz="2400" dirty="0"/>
+              <a:t>)</a:t>
+            </a:r>
+          </a:p>
+          <a:p>
+            <a:pPr marL="285750" indent="-285750">
+              <a:lnSpc>
+                <a:spcPct val="150000"/>
+              </a:lnSpc>
+              <a:buFont typeface="Calibri" panose="020F0502020204030204" pitchFamily="34" charset="0"/>
+              <a:buChar char="‒"/>
+            </a:pPr>
+            <a:r>
+              <a:rPr lang="en-US" sz="2400" dirty="0"/>
+              <a:t>void Restart()</a:t>
+            </a:r>
+          </a:p>
+          <a:p>
+            <a:pPr marL="285750" indent="-285750">
+              <a:lnSpc>
+                <a:spcPct val="150000"/>
               </a:lnSpc>
               <a:buFont typeface="Calibri" panose="020F0502020204030204" pitchFamily="34" charset="0"/>
               <a:buChar char="‒"/>
@@ -6959,6 +7164,1124 @@
         <p:cNvPr id="1" name="">
           <a:extLst>
             <a:ext uri="{FF2B5EF4-FFF2-40B4-BE49-F238E27FC236}">
+              <a16:creationId xmlns:a16="http://schemas.microsoft.com/office/drawing/2014/main" id="{7575A32A-B847-9EEC-1332-E852FF7F88DC}"/>
+            </a:ext>
+          </a:extLst>
+        </p:cNvPr>
+        <p:cNvGrpSpPr/>
+        <p:nvPr/>
+      </p:nvGrpSpPr>
+      <p:grpSpPr>
+        <a:xfrm>
+          <a:off x="0" y="0"/>
+          <a:ext cx="0" cy="0"/>
+          <a:chOff x="0" y="0"/>
+          <a:chExt cx="0" cy="0"/>
+        </a:xfrm>
+      </p:grpSpPr>
+      <p:pic>
+        <p:nvPicPr>
+          <p:cNvPr id="2" name="Picture 2" descr="C:\Users\Андрей\Desktop\1\Безымянный-1.png">
+            <a:extLst>
+              <a:ext uri="{FF2B5EF4-FFF2-40B4-BE49-F238E27FC236}">
+                <a16:creationId xmlns:a16="http://schemas.microsoft.com/office/drawing/2014/main" id="{25AD3CD8-2F47-BA57-F157-82A11F645722}"/>
+              </a:ext>
+            </a:extLst>
+          </p:cNvPr>
+          <p:cNvPicPr>
+            <a:picLocks noChangeAspect="1" noChangeArrowheads="1"/>
+          </p:cNvPicPr>
+          <p:nvPr/>
+        </p:nvPicPr>
+        <p:blipFill>
+          <a:blip r:embed="rId3">
+            <a:extLst>
+              <a:ext uri="{28A0092B-C50C-407E-A947-70E740481C1C}">
+                <a14:useLocalDpi xmlns:a14="http://schemas.microsoft.com/office/drawing/2010/main" val="0"/>
+              </a:ext>
+            </a:extLst>
+          </a:blip>
+          <a:srcRect/>
+          <a:stretch>
+            <a:fillRect/>
+          </a:stretch>
+        </p:blipFill>
+        <p:spPr bwMode="auto">
+          <a:xfrm>
+            <a:off x="0" y="0"/>
+            <a:ext cx="12192000" cy="982639"/>
+          </a:xfrm>
+          <a:prstGeom prst="rect">
+            <a:avLst/>
+          </a:prstGeom>
+          <a:noFill/>
+          <a:ln>
+            <a:noFill/>
+          </a:ln>
+          <a:extLst>
+            <a:ext uri="{909E8E84-426E-40DD-AFC4-6F175D3DCCD1}">
+              <a14:hiddenFill xmlns:a14="http://schemas.microsoft.com/office/drawing/2010/main">
+                <a:solidFill>
+                  <a:srgbClr val="FFFFFF"/>
+                </a:solidFill>
+              </a14:hiddenFill>
+            </a:ext>
+            <a:ext uri="{91240B29-F687-4F45-9708-019B960494DF}">
+              <a14:hiddenLine xmlns:a14="http://schemas.microsoft.com/office/drawing/2010/main" w="9525">
+                <a:solidFill>
+                  <a:srgbClr val="000000"/>
+                </a:solidFill>
+                <a:miter lim="800000"/>
+                <a:headEnd/>
+                <a:tailEnd/>
+              </a14:hiddenLine>
+            </a:ext>
+          </a:extLst>
+        </p:spPr>
+      </p:pic>
+      <p:sp>
+        <p:nvSpPr>
+          <p:cNvPr id="5" name="TextBox 4">
+            <a:extLst>
+              <a:ext uri="{FF2B5EF4-FFF2-40B4-BE49-F238E27FC236}">
+                <a16:creationId xmlns:a16="http://schemas.microsoft.com/office/drawing/2014/main" id="{E311015E-D3B6-2969-3514-0780B99258FA}"/>
+              </a:ext>
+            </a:extLst>
+          </p:cNvPr>
+          <p:cNvSpPr txBox="1"/>
+          <p:nvPr/>
+        </p:nvSpPr>
+        <p:spPr>
+          <a:xfrm>
+            <a:off x="3534770" y="450376"/>
+            <a:ext cx="184731" cy="369332"/>
+          </a:xfrm>
+          <a:prstGeom prst="rect">
+            <a:avLst/>
+          </a:prstGeom>
+          <a:noFill/>
+        </p:spPr>
+        <p:txBody>
+          <a:bodyPr wrap="none" rtlCol="0">
+            <a:spAutoFit/>
+          </a:bodyPr>
+          <a:lstStyle/>
+          <a:p>
+            <a:endParaRPr lang="ru-RU" dirty="0"/>
+          </a:p>
+        </p:txBody>
+      </p:sp>
+      <p:sp>
+        <p:nvSpPr>
+          <p:cNvPr id="7" name="TextBox 6">
+            <a:extLst>
+              <a:ext uri="{FF2B5EF4-FFF2-40B4-BE49-F238E27FC236}">
+                <a16:creationId xmlns:a16="http://schemas.microsoft.com/office/drawing/2014/main" id="{C9A55057-2BA1-06D8-1DC2-A5C118F15A01}"/>
+              </a:ext>
+            </a:extLst>
+          </p:cNvPr>
+          <p:cNvSpPr txBox="1"/>
+          <p:nvPr/>
+        </p:nvSpPr>
+        <p:spPr>
+          <a:xfrm>
+            <a:off x="3164749" y="137376"/>
+            <a:ext cx="5862502" cy="707886"/>
+          </a:xfrm>
+          <a:prstGeom prst="rect">
+            <a:avLst/>
+          </a:prstGeom>
+          <a:noFill/>
+        </p:spPr>
+        <p:txBody>
+          <a:bodyPr wrap="none" rtlCol="0">
+            <a:spAutoFit/>
+          </a:bodyPr>
+          <a:lstStyle/>
+          <a:p>
+            <a:pPr algn="ctr"/>
+            <a:r>
+              <a:rPr lang="ru-RU" sz="4000" dirty="0">
+                <a:solidFill>
+                  <a:schemeClr val="bg1">
+                    <a:lumMod val="95000"/>
+                  </a:schemeClr>
+                </a:solidFill>
+                <a:effectLst>
+                  <a:outerShdw blurRad="38100" dist="38100" dir="2700000" algn="tl">
+                    <a:srgbClr val="000000">
+                      <a:alpha val="43137"/>
+                    </a:srgbClr>
+                  </a:outerShdw>
+                </a:effectLst>
+                <a:latin typeface="Century Gothic" panose="020B0502020202020204" pitchFamily="34" charset="0"/>
+              </a:rPr>
+              <a:t>Полученный результат</a:t>
+            </a:r>
+          </a:p>
+        </p:txBody>
+      </p:sp>
+      <p:grpSp>
+        <p:nvGrpSpPr>
+          <p:cNvPr id="3" name="Group 2">
+            <a:extLst>
+              <a:ext uri="{FF2B5EF4-FFF2-40B4-BE49-F238E27FC236}">
+                <a16:creationId xmlns:a16="http://schemas.microsoft.com/office/drawing/2014/main" id="{A66347E3-5E3B-981D-5BEE-4C258D764B3C}"/>
+              </a:ext>
+            </a:extLst>
+          </p:cNvPr>
+          <p:cNvGrpSpPr/>
+          <p:nvPr/>
+        </p:nvGrpSpPr>
+        <p:grpSpPr>
+          <a:xfrm>
+            <a:off x="2192404" y="1368318"/>
+            <a:ext cx="1785431" cy="2270345"/>
+            <a:chOff x="848488" y="2995177"/>
+            <a:chExt cx="1785431" cy="2270345"/>
+          </a:xfrm>
+        </p:grpSpPr>
+        <p:sp>
+          <p:nvSpPr>
+            <p:cNvPr id="4" name="TextBox 3">
+              <a:extLst>
+                <a:ext uri="{FF2B5EF4-FFF2-40B4-BE49-F238E27FC236}">
+                  <a16:creationId xmlns:a16="http://schemas.microsoft.com/office/drawing/2014/main" id="{B6F68803-8B80-7A3C-CC40-38A98DB10B2F}"/>
+                </a:ext>
+              </a:extLst>
+            </p:cNvPr>
+            <p:cNvSpPr txBox="1"/>
+            <p:nvPr/>
+          </p:nvSpPr>
+          <p:spPr>
+            <a:xfrm>
+              <a:off x="848488" y="4557636"/>
+              <a:ext cx="1785431" cy="707886"/>
+            </a:xfrm>
+            <a:prstGeom prst="rect">
+              <a:avLst/>
+            </a:prstGeom>
+            <a:noFill/>
+          </p:spPr>
+          <p:txBody>
+            <a:bodyPr wrap="square" rtlCol="0">
+              <a:spAutoFit/>
+            </a:bodyPr>
+            <a:lstStyle/>
+            <a:p>
+              <a:pPr algn="ctr"/>
+              <a:r>
+                <a:rPr lang="en-US" sz="2000" dirty="0" err="1">
+                  <a:latin typeface="Century Gothic" panose="020B0502020202020204" pitchFamily="34" charset="0"/>
+                </a:rPr>
+                <a:t>TranzWare</a:t>
+              </a:r>
+              <a:r>
+                <a:rPr lang="en-US" sz="2000" dirty="0">
+                  <a:latin typeface="Century Gothic" panose="020B0502020202020204" pitchFamily="34" charset="0"/>
+                </a:rPr>
+                <a:t> </a:t>
+              </a:r>
+              <a:r>
+                <a:rPr lang="en-US" sz="2000" dirty="0" err="1">
+                  <a:latin typeface="Century Gothic" panose="020B0502020202020204" pitchFamily="34" charset="0"/>
+                </a:rPr>
+                <a:t>CardFactory</a:t>
+              </a:r>
+              <a:endParaRPr lang="ru-RU" sz="2000" dirty="0">
+                <a:latin typeface="Century Gothic" panose="020B0502020202020204" pitchFamily="34" charset="0"/>
+              </a:endParaRPr>
+            </a:p>
+          </p:txBody>
+        </p:sp>
+        <p:pic>
+          <p:nvPicPr>
+            <p:cNvPr id="8" name="Picture 7">
+              <a:extLst>
+                <a:ext uri="{FF2B5EF4-FFF2-40B4-BE49-F238E27FC236}">
+                  <a16:creationId xmlns:a16="http://schemas.microsoft.com/office/drawing/2014/main" id="{84150CA6-F809-C224-716F-3C7FE197F8EC}"/>
+                </a:ext>
+              </a:extLst>
+            </p:cNvPr>
+            <p:cNvPicPr>
+              <a:picLocks noChangeAspect="1"/>
+            </p:cNvPicPr>
+            <p:nvPr/>
+          </p:nvPicPr>
+          <p:blipFill>
+            <a:blip r:embed="rId4">
+              <a:extLst>
+                <a:ext uri="{28A0092B-C50C-407E-A947-70E740481C1C}">
+                  <a14:useLocalDpi xmlns:a14="http://schemas.microsoft.com/office/drawing/2010/main" val="0"/>
+                </a:ext>
+              </a:extLst>
+            </a:blip>
+            <a:stretch>
+              <a:fillRect/>
+            </a:stretch>
+          </p:blipFill>
+          <p:spPr>
+            <a:xfrm>
+              <a:off x="992936" y="2995177"/>
+              <a:ext cx="1496533" cy="1562459"/>
+            </a:xfrm>
+            <a:prstGeom prst="rect">
+              <a:avLst/>
+            </a:prstGeom>
+          </p:spPr>
+        </p:pic>
+      </p:grpSp>
+      <p:grpSp>
+        <p:nvGrpSpPr>
+          <p:cNvPr id="11" name="Group 10">
+            <a:extLst>
+              <a:ext uri="{FF2B5EF4-FFF2-40B4-BE49-F238E27FC236}">
+                <a16:creationId xmlns:a16="http://schemas.microsoft.com/office/drawing/2014/main" id="{66D96036-E80B-98FA-6ADF-8C252134FE2B}"/>
+              </a:ext>
+            </a:extLst>
+          </p:cNvPr>
+          <p:cNvGrpSpPr/>
+          <p:nvPr/>
+        </p:nvGrpSpPr>
+        <p:grpSpPr>
+          <a:xfrm>
+            <a:off x="5116020" y="4821403"/>
+            <a:ext cx="1959959" cy="1849381"/>
+            <a:chOff x="8567446" y="2815761"/>
+            <a:chExt cx="1959959" cy="1849381"/>
+          </a:xfrm>
+        </p:grpSpPr>
+        <p:pic>
+          <p:nvPicPr>
+            <p:cNvPr id="9" name="Picture 8">
+              <a:extLst>
+                <a:ext uri="{FF2B5EF4-FFF2-40B4-BE49-F238E27FC236}">
+                  <a16:creationId xmlns:a16="http://schemas.microsoft.com/office/drawing/2014/main" id="{D28DAD5F-0607-CBCF-0BB6-55824DBF87CB}"/>
+                </a:ext>
+              </a:extLst>
+            </p:cNvPr>
+            <p:cNvPicPr>
+              <a:picLocks noChangeAspect="1"/>
+            </p:cNvPicPr>
+            <p:nvPr/>
+          </p:nvPicPr>
+          <p:blipFill>
+            <a:blip r:embed="rId5">
+              <a:extLst>
+                <a:ext uri="{28A0092B-C50C-407E-A947-70E740481C1C}">
+                  <a14:useLocalDpi xmlns:a14="http://schemas.microsoft.com/office/drawing/2010/main" val="0"/>
+                </a:ext>
+              </a:extLst>
+            </a:blip>
+            <a:stretch>
+              <a:fillRect/>
+            </a:stretch>
+          </p:blipFill>
+          <p:spPr>
+            <a:xfrm>
+              <a:off x="8567446" y="2815761"/>
+              <a:ext cx="1959959" cy="1068152"/>
+            </a:xfrm>
+            <a:prstGeom prst="rect">
+              <a:avLst/>
+            </a:prstGeom>
+          </p:spPr>
+        </p:pic>
+        <p:sp>
+          <p:nvSpPr>
+            <p:cNvPr id="10" name="TextBox 9">
+              <a:extLst>
+                <a:ext uri="{FF2B5EF4-FFF2-40B4-BE49-F238E27FC236}">
+                  <a16:creationId xmlns:a16="http://schemas.microsoft.com/office/drawing/2014/main" id="{F5C771F6-641E-A9B0-3DDF-AD9D484A5F8A}"/>
+                </a:ext>
+              </a:extLst>
+            </p:cNvPr>
+            <p:cNvSpPr txBox="1"/>
+            <p:nvPr/>
+          </p:nvSpPr>
+          <p:spPr>
+            <a:xfrm>
+              <a:off x="8654709" y="3957256"/>
+              <a:ext cx="1785431" cy="707886"/>
+            </a:xfrm>
+            <a:prstGeom prst="rect">
+              <a:avLst/>
+            </a:prstGeom>
+            <a:noFill/>
+          </p:spPr>
+          <p:txBody>
+            <a:bodyPr wrap="square" rtlCol="0">
+              <a:spAutoFit/>
+            </a:bodyPr>
+            <a:lstStyle/>
+            <a:p>
+              <a:pPr algn="ctr"/>
+              <a:r>
+                <a:rPr lang="ru-RU" sz="2000" dirty="0">
+                  <a:latin typeface="Century Gothic" panose="020B0502020202020204" pitchFamily="34" charset="0"/>
+                </a:rPr>
+                <a:t>Эмбоссер </a:t>
+              </a:r>
+              <a:r>
+                <a:rPr lang="en-US" sz="2000" dirty="0" err="1">
+                  <a:latin typeface="Century Gothic" panose="020B0502020202020204" pitchFamily="34" charset="0"/>
+                </a:rPr>
+                <a:t>SmartWare</a:t>
+              </a:r>
+              <a:endParaRPr lang="ru-RU" sz="2000" dirty="0">
+                <a:latin typeface="Century Gothic" panose="020B0502020202020204" pitchFamily="34" charset="0"/>
+              </a:endParaRPr>
+            </a:p>
+          </p:txBody>
+        </p:sp>
+      </p:grpSp>
+      <p:grpSp>
+        <p:nvGrpSpPr>
+          <p:cNvPr id="12" name="Group 11">
+            <a:extLst>
+              <a:ext uri="{FF2B5EF4-FFF2-40B4-BE49-F238E27FC236}">
+                <a16:creationId xmlns:a16="http://schemas.microsoft.com/office/drawing/2014/main" id="{D8C7D89F-5C7F-6203-214C-B6B277DA89E8}"/>
+              </a:ext>
+            </a:extLst>
+          </p:cNvPr>
+          <p:cNvGrpSpPr/>
+          <p:nvPr/>
+        </p:nvGrpSpPr>
+        <p:grpSpPr>
+          <a:xfrm>
+            <a:off x="7891293" y="1251472"/>
+            <a:ext cx="2144831" cy="1931791"/>
+            <a:chOff x="9355402" y="2946927"/>
+            <a:chExt cx="2144831" cy="1931791"/>
+          </a:xfrm>
+        </p:grpSpPr>
+        <p:pic>
+          <p:nvPicPr>
+            <p:cNvPr id="13" name="Picture 12">
+              <a:extLst>
+                <a:ext uri="{FF2B5EF4-FFF2-40B4-BE49-F238E27FC236}">
+                  <a16:creationId xmlns:a16="http://schemas.microsoft.com/office/drawing/2014/main" id="{80FAA1B6-1561-3B29-D482-2C2572DDA0A1}"/>
+                </a:ext>
+              </a:extLst>
+            </p:cNvPr>
+            <p:cNvPicPr>
+              <a:picLocks noChangeAspect="1"/>
+            </p:cNvPicPr>
+            <p:nvPr/>
+          </p:nvPicPr>
+          <p:blipFill>
+            <a:blip r:embed="rId6">
+              <a:extLst>
+                <a:ext uri="{28A0092B-C50C-407E-A947-70E740481C1C}">
+                  <a14:useLocalDpi xmlns:a14="http://schemas.microsoft.com/office/drawing/2010/main" val="0"/>
+                </a:ext>
+              </a:extLst>
+            </a:blip>
+            <a:stretch>
+              <a:fillRect/>
+            </a:stretch>
+          </p:blipFill>
+          <p:spPr>
+            <a:xfrm>
+              <a:off x="9355402" y="2946927"/>
+              <a:ext cx="2144831" cy="1562459"/>
+            </a:xfrm>
+            <a:prstGeom prst="rect">
+              <a:avLst/>
+            </a:prstGeom>
+          </p:spPr>
+        </p:pic>
+        <p:sp>
+          <p:nvSpPr>
+            <p:cNvPr id="14" name="TextBox 13">
+              <a:extLst>
+                <a:ext uri="{FF2B5EF4-FFF2-40B4-BE49-F238E27FC236}">
+                  <a16:creationId xmlns:a16="http://schemas.microsoft.com/office/drawing/2014/main" id="{D0D2CC07-1782-E0E4-4916-9CCBFB0E1D10}"/>
+                </a:ext>
+              </a:extLst>
+            </p:cNvPr>
+            <p:cNvSpPr txBox="1"/>
+            <p:nvPr/>
+          </p:nvSpPr>
+          <p:spPr>
+            <a:xfrm>
+              <a:off x="9540257" y="4509386"/>
+              <a:ext cx="1775120" cy="369332"/>
+            </a:xfrm>
+            <a:prstGeom prst="rect">
+              <a:avLst/>
+            </a:prstGeom>
+            <a:noFill/>
+          </p:spPr>
+          <p:txBody>
+            <a:bodyPr wrap="square" rtlCol="0">
+              <a:spAutoFit/>
+            </a:bodyPr>
+            <a:lstStyle/>
+            <a:p>
+              <a:r>
+                <a:rPr lang="en-US" dirty="0" err="1">
+                  <a:latin typeface="Century Gothic" panose="020B0502020202020204" pitchFamily="34" charset="0"/>
+                </a:rPr>
+                <a:t>Maticard</a:t>
+              </a:r>
+              <a:r>
+                <a:rPr lang="en-US" dirty="0">
+                  <a:latin typeface="Century Gothic" panose="020B0502020202020204" pitchFamily="34" charset="0"/>
+                </a:rPr>
+                <a:t> PRO</a:t>
+              </a:r>
+            </a:p>
+          </p:txBody>
+        </p:sp>
+      </p:grpSp>
+      <p:grpSp>
+        <p:nvGrpSpPr>
+          <p:cNvPr id="30" name="Group 29">
+            <a:extLst>
+              <a:ext uri="{FF2B5EF4-FFF2-40B4-BE49-F238E27FC236}">
+                <a16:creationId xmlns:a16="http://schemas.microsoft.com/office/drawing/2014/main" id="{778D3DC5-FC2C-2E58-475B-AB377F1DEAE5}"/>
+              </a:ext>
+            </a:extLst>
+          </p:cNvPr>
+          <p:cNvGrpSpPr/>
+          <p:nvPr/>
+        </p:nvGrpSpPr>
+        <p:grpSpPr>
+          <a:xfrm>
+            <a:off x="4134526" y="3159894"/>
+            <a:ext cx="1250190" cy="744867"/>
+            <a:chOff x="3051580" y="2997200"/>
+            <a:chExt cx="1486171" cy="885465"/>
+          </a:xfrm>
+        </p:grpSpPr>
+        <p:pic>
+          <p:nvPicPr>
+            <p:cNvPr id="15" name="Picture 14">
+              <a:extLst>
+                <a:ext uri="{FF2B5EF4-FFF2-40B4-BE49-F238E27FC236}">
+                  <a16:creationId xmlns:a16="http://schemas.microsoft.com/office/drawing/2014/main" id="{25401375-6B3A-A832-6805-C919C62460FB}"/>
+                </a:ext>
+              </a:extLst>
+            </p:cNvPr>
+            <p:cNvPicPr>
+              <a:picLocks noChangeAspect="1"/>
+            </p:cNvPicPr>
+            <p:nvPr/>
+          </p:nvPicPr>
+          <p:blipFill>
+            <a:blip r:embed="rId7"/>
+            <a:stretch>
+              <a:fillRect/>
+            </a:stretch>
+          </p:blipFill>
+          <p:spPr>
+            <a:xfrm rot="10800000">
+              <a:off x="3051580" y="2997200"/>
+              <a:ext cx="1475297" cy="440190"/>
+            </a:xfrm>
+            <a:prstGeom prst="rect">
+              <a:avLst/>
+            </a:prstGeom>
+          </p:spPr>
+        </p:pic>
+        <p:pic>
+          <p:nvPicPr>
+            <p:cNvPr id="16" name="Picture 15">
+              <a:extLst>
+                <a:ext uri="{FF2B5EF4-FFF2-40B4-BE49-F238E27FC236}">
+                  <a16:creationId xmlns:a16="http://schemas.microsoft.com/office/drawing/2014/main" id="{421A3874-6C9B-752B-1B31-5546587F790E}"/>
+                </a:ext>
+              </a:extLst>
+            </p:cNvPr>
+            <p:cNvPicPr>
+              <a:picLocks noChangeAspect="1"/>
+            </p:cNvPicPr>
+            <p:nvPr/>
+          </p:nvPicPr>
+          <p:blipFill>
+            <a:blip r:embed="rId7"/>
+            <a:stretch>
+              <a:fillRect/>
+            </a:stretch>
+          </p:blipFill>
+          <p:spPr>
+            <a:xfrm rot="10800000" flipH="1">
+              <a:off x="3062454" y="3442475"/>
+              <a:ext cx="1475297" cy="440190"/>
+            </a:xfrm>
+            <a:prstGeom prst="rect">
+              <a:avLst/>
+            </a:prstGeom>
+          </p:spPr>
+        </p:pic>
+      </p:grpSp>
+      <p:grpSp>
+        <p:nvGrpSpPr>
+          <p:cNvPr id="32" name="Group 31">
+            <a:extLst>
+              <a:ext uri="{FF2B5EF4-FFF2-40B4-BE49-F238E27FC236}">
+                <a16:creationId xmlns:a16="http://schemas.microsoft.com/office/drawing/2014/main" id="{4B469F37-80B1-DB06-5F60-D1F07695E31F}"/>
+              </a:ext>
+            </a:extLst>
+          </p:cNvPr>
+          <p:cNvGrpSpPr/>
+          <p:nvPr/>
+        </p:nvGrpSpPr>
+        <p:grpSpPr>
+          <a:xfrm rot="18994099">
+            <a:off x="6937248" y="3677414"/>
+            <a:ext cx="1860339" cy="993213"/>
+            <a:chOff x="6743121" y="2762420"/>
+            <a:chExt cx="1486171" cy="885465"/>
+          </a:xfrm>
+        </p:grpSpPr>
+        <p:pic>
+          <p:nvPicPr>
+            <p:cNvPr id="17" name="Picture 16">
+              <a:extLst>
+                <a:ext uri="{FF2B5EF4-FFF2-40B4-BE49-F238E27FC236}">
+                  <a16:creationId xmlns:a16="http://schemas.microsoft.com/office/drawing/2014/main" id="{6A685DFE-FB4D-4EE7-4A84-911F703F1318}"/>
+                </a:ext>
+              </a:extLst>
+            </p:cNvPr>
+            <p:cNvPicPr>
+              <a:picLocks noChangeAspect="1"/>
+            </p:cNvPicPr>
+            <p:nvPr/>
+          </p:nvPicPr>
+          <p:blipFill>
+            <a:blip r:embed="rId7"/>
+            <a:stretch>
+              <a:fillRect/>
+            </a:stretch>
+          </p:blipFill>
+          <p:spPr>
+            <a:xfrm rot="10800000">
+              <a:off x="6743121" y="2762420"/>
+              <a:ext cx="1475297" cy="440190"/>
+            </a:xfrm>
+            <a:prstGeom prst="rect">
+              <a:avLst/>
+            </a:prstGeom>
+          </p:spPr>
+        </p:pic>
+        <p:pic>
+          <p:nvPicPr>
+            <p:cNvPr id="18" name="Picture 17">
+              <a:extLst>
+                <a:ext uri="{FF2B5EF4-FFF2-40B4-BE49-F238E27FC236}">
+                  <a16:creationId xmlns:a16="http://schemas.microsoft.com/office/drawing/2014/main" id="{55E88F04-3D18-0261-429A-930D0E17F431}"/>
+                </a:ext>
+              </a:extLst>
+            </p:cNvPr>
+            <p:cNvPicPr>
+              <a:picLocks noChangeAspect="1"/>
+            </p:cNvPicPr>
+            <p:nvPr/>
+          </p:nvPicPr>
+          <p:blipFill>
+            <a:blip r:embed="rId7"/>
+            <a:stretch>
+              <a:fillRect/>
+            </a:stretch>
+          </p:blipFill>
+          <p:spPr>
+            <a:xfrm rot="10800000" flipH="1">
+              <a:off x="6753995" y="3207695"/>
+              <a:ext cx="1475297" cy="440190"/>
+            </a:xfrm>
+            <a:prstGeom prst="rect">
+              <a:avLst/>
+            </a:prstGeom>
+          </p:spPr>
+        </p:pic>
+      </p:grpSp>
+      <p:pic>
+        <p:nvPicPr>
+          <p:cNvPr id="19" name="Picture 18">
+            <a:extLst>
+              <a:ext uri="{FF2B5EF4-FFF2-40B4-BE49-F238E27FC236}">
+                <a16:creationId xmlns:a16="http://schemas.microsoft.com/office/drawing/2014/main" id="{E4793CAE-88A6-7906-4A2C-7B006B12D6E3}"/>
+              </a:ext>
+            </a:extLst>
+          </p:cNvPr>
+          <p:cNvPicPr>
+            <a:picLocks noChangeAspect="1"/>
+          </p:cNvPicPr>
+          <p:nvPr/>
+        </p:nvPicPr>
+        <p:blipFill>
+          <a:blip r:embed="rId8">
+            <a:extLst>
+              <a:ext uri="{28A0092B-C50C-407E-A947-70E740481C1C}">
+                <a14:useLocalDpi xmlns:a14="http://schemas.microsoft.com/office/drawing/2010/main" val="0"/>
+              </a:ext>
+            </a:extLst>
+          </a:blip>
+          <a:stretch>
+            <a:fillRect/>
+          </a:stretch>
+        </p:blipFill>
+        <p:spPr>
+          <a:xfrm>
+            <a:off x="1215226" y="5080571"/>
+            <a:ext cx="1810669" cy="1085182"/>
+          </a:xfrm>
+          <a:prstGeom prst="rect">
+            <a:avLst/>
+          </a:prstGeom>
+        </p:spPr>
+      </p:pic>
+      <p:grpSp>
+        <p:nvGrpSpPr>
+          <p:cNvPr id="27" name="Group 26">
+            <a:extLst>
+              <a:ext uri="{FF2B5EF4-FFF2-40B4-BE49-F238E27FC236}">
+                <a16:creationId xmlns:a16="http://schemas.microsoft.com/office/drawing/2014/main" id="{3D6BF4B3-441C-FF17-2555-CD6E50C18946}"/>
+              </a:ext>
+            </a:extLst>
+          </p:cNvPr>
+          <p:cNvGrpSpPr/>
+          <p:nvPr/>
+        </p:nvGrpSpPr>
+        <p:grpSpPr>
+          <a:xfrm rot="10800000">
+            <a:off x="4937098" y="1688513"/>
+            <a:ext cx="1959959" cy="800421"/>
+            <a:chOff x="2071940" y="4941171"/>
+            <a:chExt cx="1486171" cy="885465"/>
+          </a:xfrm>
+        </p:grpSpPr>
+        <p:pic>
+          <p:nvPicPr>
+            <p:cNvPr id="25" name="Picture 24">
+              <a:extLst>
+                <a:ext uri="{FF2B5EF4-FFF2-40B4-BE49-F238E27FC236}">
+                  <a16:creationId xmlns:a16="http://schemas.microsoft.com/office/drawing/2014/main" id="{ADC03664-4CC0-C642-F3DA-25A8281D12AA}"/>
+                </a:ext>
+              </a:extLst>
+            </p:cNvPr>
+            <p:cNvPicPr>
+              <a:picLocks noChangeAspect="1"/>
+            </p:cNvPicPr>
+            <p:nvPr/>
+          </p:nvPicPr>
+          <p:blipFill>
+            <a:blip r:embed="rId7"/>
+            <a:stretch>
+              <a:fillRect/>
+            </a:stretch>
+          </p:blipFill>
+          <p:spPr>
+            <a:xfrm rot="10800000">
+              <a:off x="2071940" y="4941171"/>
+              <a:ext cx="1475297" cy="440190"/>
+            </a:xfrm>
+            <a:prstGeom prst="rect">
+              <a:avLst/>
+            </a:prstGeom>
+          </p:spPr>
+        </p:pic>
+        <p:pic>
+          <p:nvPicPr>
+            <p:cNvPr id="26" name="Picture 25">
+              <a:extLst>
+                <a:ext uri="{FF2B5EF4-FFF2-40B4-BE49-F238E27FC236}">
+                  <a16:creationId xmlns:a16="http://schemas.microsoft.com/office/drawing/2014/main" id="{CDCFED0A-0F27-87E2-FAC1-FBBAFB14AC6D}"/>
+                </a:ext>
+              </a:extLst>
+            </p:cNvPr>
+            <p:cNvPicPr>
+              <a:picLocks noChangeAspect="1"/>
+            </p:cNvPicPr>
+            <p:nvPr/>
+          </p:nvPicPr>
+          <p:blipFill>
+            <a:blip r:embed="rId7"/>
+            <a:stretch>
+              <a:fillRect/>
+            </a:stretch>
+          </p:blipFill>
+          <p:spPr>
+            <a:xfrm rot="10800000" flipH="1">
+              <a:off x="2082814" y="5386446"/>
+              <a:ext cx="1475297" cy="440190"/>
+            </a:xfrm>
+            <a:prstGeom prst="rect">
+              <a:avLst/>
+            </a:prstGeom>
+          </p:spPr>
+        </p:pic>
+      </p:grpSp>
+      <p:pic>
+        <p:nvPicPr>
+          <p:cNvPr id="28" name="Picture 27">
+            <a:extLst>
+              <a:ext uri="{FF2B5EF4-FFF2-40B4-BE49-F238E27FC236}">
+                <a16:creationId xmlns:a16="http://schemas.microsoft.com/office/drawing/2014/main" id="{AF3A5F0D-C1A3-E312-A2DE-B38061EEBCA2}"/>
+              </a:ext>
+            </a:extLst>
+          </p:cNvPr>
+          <p:cNvPicPr>
+            <a:picLocks noChangeAspect="1"/>
+          </p:cNvPicPr>
+          <p:nvPr/>
+        </p:nvPicPr>
+        <p:blipFill>
+          <a:blip r:embed="rId7"/>
+          <a:stretch>
+            <a:fillRect/>
+          </a:stretch>
+        </p:blipFill>
+        <p:spPr>
+          <a:xfrm>
+            <a:off x="7378980" y="5448970"/>
+            <a:ext cx="1584729" cy="428898"/>
+          </a:xfrm>
+          <a:prstGeom prst="rect">
+            <a:avLst/>
+          </a:prstGeom>
+        </p:spPr>
+      </p:pic>
+      <p:pic>
+        <p:nvPicPr>
+          <p:cNvPr id="29" name="Picture 28">
+            <a:extLst>
+              <a:ext uri="{FF2B5EF4-FFF2-40B4-BE49-F238E27FC236}">
+                <a16:creationId xmlns:a16="http://schemas.microsoft.com/office/drawing/2014/main" id="{71CB8E09-38F0-A824-24EA-2EFF96B6A96D}"/>
+              </a:ext>
+            </a:extLst>
+          </p:cNvPr>
+          <p:cNvPicPr>
+            <a:picLocks noChangeAspect="1"/>
+          </p:cNvPicPr>
+          <p:nvPr/>
+        </p:nvPicPr>
+        <p:blipFill>
+          <a:blip r:embed="rId9">
+            <a:extLst>
+              <a:ext uri="{28A0092B-C50C-407E-A947-70E740481C1C}">
+                <a14:useLocalDpi xmlns:a14="http://schemas.microsoft.com/office/drawing/2010/main" val="0"/>
+              </a:ext>
+            </a:extLst>
+          </a:blip>
+          <a:stretch>
+            <a:fillRect/>
+          </a:stretch>
+        </p:blipFill>
+        <p:spPr>
+          <a:xfrm>
+            <a:off x="9266710" y="5300046"/>
+            <a:ext cx="2206943" cy="865707"/>
+          </a:xfrm>
+          <a:prstGeom prst="rect">
+            <a:avLst/>
+          </a:prstGeom>
+        </p:spPr>
+      </p:pic>
+      <p:sp>
+        <p:nvSpPr>
+          <p:cNvPr id="6" name="Slide Number Placeholder 5">
+            <a:extLst>
+              <a:ext uri="{FF2B5EF4-FFF2-40B4-BE49-F238E27FC236}">
+                <a16:creationId xmlns:a16="http://schemas.microsoft.com/office/drawing/2014/main" id="{8CACEEB6-A125-02EB-5E4E-BA036D312A13}"/>
+              </a:ext>
+            </a:extLst>
+          </p:cNvPr>
+          <p:cNvSpPr>
+            <a:spLocks noGrp="1"/>
+          </p:cNvSpPr>
+          <p:nvPr>
+            <p:ph type="sldNum" sz="quarter" idx="12"/>
+          </p:nvPr>
+        </p:nvSpPr>
+        <p:spPr/>
+        <p:txBody>
+          <a:bodyPr/>
+          <a:lstStyle/>
+          <a:p>
+            <a:fld id="{471AB917-4A67-459A-ADEA-E0250FA5C43E}" type="slidenum">
+              <a:rPr lang="ru-RU" smtClean="0"/>
+              <a:t>11</a:t>
+            </a:fld>
+            <a:endParaRPr lang="ru-RU"/>
+          </a:p>
+        </p:txBody>
+      </p:sp>
+      <p:pic>
+        <p:nvPicPr>
+          <p:cNvPr id="31" name="Picture 30">
+            <a:extLst>
+              <a:ext uri="{FF2B5EF4-FFF2-40B4-BE49-F238E27FC236}">
+                <a16:creationId xmlns:a16="http://schemas.microsoft.com/office/drawing/2014/main" id="{7FA28451-37C6-7634-A1E5-0FB9912301A7}"/>
+              </a:ext>
+            </a:extLst>
+          </p:cNvPr>
+          <p:cNvPicPr>
+            <a:picLocks noChangeAspect="1"/>
+          </p:cNvPicPr>
+          <p:nvPr/>
+        </p:nvPicPr>
+        <p:blipFill>
+          <a:blip r:embed="rId7"/>
+          <a:stretch>
+            <a:fillRect/>
+          </a:stretch>
+        </p:blipFill>
+        <p:spPr>
+          <a:xfrm>
+            <a:off x="3328896" y="5425614"/>
+            <a:ext cx="1584729" cy="428898"/>
+          </a:xfrm>
+          <a:prstGeom prst="rect">
+            <a:avLst/>
+          </a:prstGeom>
+        </p:spPr>
+      </p:pic>
+      <p:grpSp>
+        <p:nvGrpSpPr>
+          <p:cNvPr id="33" name="Group 32">
+            <a:extLst>
+              <a:ext uri="{FF2B5EF4-FFF2-40B4-BE49-F238E27FC236}">
+                <a16:creationId xmlns:a16="http://schemas.microsoft.com/office/drawing/2014/main" id="{83397354-AF78-9F5E-5983-9D64A1B441C7}"/>
+              </a:ext>
+            </a:extLst>
+          </p:cNvPr>
+          <p:cNvGrpSpPr/>
+          <p:nvPr/>
+        </p:nvGrpSpPr>
+        <p:grpSpPr>
+          <a:xfrm>
+            <a:off x="5609836" y="2728635"/>
+            <a:ext cx="1321445" cy="1562459"/>
+            <a:chOff x="4459057" y="4591624"/>
+            <a:chExt cx="1321445" cy="1562459"/>
+          </a:xfrm>
+        </p:grpSpPr>
+        <p:pic>
+          <p:nvPicPr>
+            <p:cNvPr id="34" name="Picture 33">
+              <a:extLst>
+                <a:ext uri="{FF2B5EF4-FFF2-40B4-BE49-F238E27FC236}">
+                  <a16:creationId xmlns:a16="http://schemas.microsoft.com/office/drawing/2014/main" id="{766F2B58-F642-D005-C1E4-405635F75D76}"/>
+                </a:ext>
+              </a:extLst>
+            </p:cNvPr>
+            <p:cNvPicPr>
+              <a:picLocks noChangeAspect="1"/>
+            </p:cNvPicPr>
+            <p:nvPr/>
+          </p:nvPicPr>
+          <p:blipFill>
+            <a:blip r:embed="rId10">
+              <a:extLst>
+                <a:ext uri="{28A0092B-C50C-407E-A947-70E740481C1C}">
+                  <a14:useLocalDpi xmlns:a14="http://schemas.microsoft.com/office/drawing/2010/main" val="0"/>
+                </a:ext>
+              </a:extLst>
+            </a:blip>
+            <a:stretch>
+              <a:fillRect/>
+            </a:stretch>
+          </p:blipFill>
+          <p:spPr>
+            <a:xfrm>
+              <a:off x="4459057" y="4591624"/>
+              <a:ext cx="1164942" cy="1562459"/>
+            </a:xfrm>
+            <a:prstGeom prst="rect">
+              <a:avLst/>
+            </a:prstGeom>
+          </p:spPr>
+        </p:pic>
+        <p:pic>
+          <p:nvPicPr>
+            <p:cNvPr id="35" name="Picture 34">
+              <a:extLst>
+                <a:ext uri="{FF2B5EF4-FFF2-40B4-BE49-F238E27FC236}">
+                  <a16:creationId xmlns:a16="http://schemas.microsoft.com/office/drawing/2014/main" id="{75BC1F09-2B02-0C6E-E34D-4CD93CD47B3E}"/>
+                </a:ext>
+              </a:extLst>
+            </p:cNvPr>
+            <p:cNvPicPr>
+              <a:picLocks noChangeAspect="1"/>
+            </p:cNvPicPr>
+            <p:nvPr/>
+          </p:nvPicPr>
+          <p:blipFill>
+            <a:blip r:embed="rId6" cstate="print">
+              <a:extLst>
+                <a:ext uri="{28A0092B-C50C-407E-A947-70E740481C1C}">
+                  <a14:useLocalDpi xmlns:a14="http://schemas.microsoft.com/office/drawing/2010/main" val="0"/>
+                </a:ext>
+              </a:extLst>
+            </a:blip>
+            <a:stretch>
+              <a:fillRect/>
+            </a:stretch>
+          </p:blipFill>
+          <p:spPr>
+            <a:xfrm>
+              <a:off x="4615748" y="4727446"/>
+              <a:ext cx="851560" cy="620342"/>
+            </a:xfrm>
+            <a:prstGeom prst="rect">
+              <a:avLst/>
+            </a:prstGeom>
+          </p:spPr>
+        </p:pic>
+        <p:sp>
+          <p:nvSpPr>
+            <p:cNvPr id="36" name="TextBox 35">
+              <a:extLst>
+                <a:ext uri="{FF2B5EF4-FFF2-40B4-BE49-F238E27FC236}">
+                  <a16:creationId xmlns:a16="http://schemas.microsoft.com/office/drawing/2014/main" id="{DE79FFB8-18C1-25AB-911B-E14F1796DE7D}"/>
+                </a:ext>
+              </a:extLst>
+            </p:cNvPr>
+            <p:cNvSpPr txBox="1"/>
+            <p:nvPr/>
+          </p:nvSpPr>
+          <p:spPr>
+            <a:xfrm>
+              <a:off x="4506434" y="5395317"/>
+              <a:ext cx="1274068" cy="584775"/>
+            </a:xfrm>
+            <a:prstGeom prst="rect">
+              <a:avLst/>
+            </a:prstGeom>
+            <a:noFill/>
+          </p:spPr>
+          <p:txBody>
+            <a:bodyPr wrap="square" rtlCol="0">
+              <a:spAutoFit/>
+            </a:bodyPr>
+            <a:lstStyle/>
+            <a:p>
+              <a:r>
+                <a:rPr lang="ru-RU" sz="1600" dirty="0">
+                  <a:latin typeface="Century Gothic" panose="020B0502020202020204" pitchFamily="34" charset="0"/>
+                </a:rPr>
+                <a:t>Драйвер </a:t>
+              </a:r>
+            </a:p>
+            <a:p>
+              <a:r>
+                <a:rPr lang="en-US" sz="1600" dirty="0">
+                  <a:latin typeface="Century Gothic" panose="020B0502020202020204" pitchFamily="34" charset="0"/>
+                </a:rPr>
+                <a:t>MATICA</a:t>
+              </a:r>
+              <a:endParaRPr lang="ru-RU" sz="1600" dirty="0">
+                <a:latin typeface="Century Gothic" panose="020B0502020202020204" pitchFamily="34" charset="0"/>
+              </a:endParaRPr>
+            </a:p>
+          </p:txBody>
+        </p:sp>
+      </p:grpSp>
+      <p:grpSp>
+        <p:nvGrpSpPr>
+          <p:cNvPr id="37" name="Group 36">
+            <a:extLst>
+              <a:ext uri="{FF2B5EF4-FFF2-40B4-BE49-F238E27FC236}">
+                <a16:creationId xmlns:a16="http://schemas.microsoft.com/office/drawing/2014/main" id="{FBC0659D-63F2-2C70-04DC-C69AC93B3E0C}"/>
+              </a:ext>
+            </a:extLst>
+          </p:cNvPr>
+          <p:cNvGrpSpPr/>
+          <p:nvPr/>
+        </p:nvGrpSpPr>
+        <p:grpSpPr>
+          <a:xfrm rot="5400000">
+            <a:off x="5953048" y="4389403"/>
+            <a:ext cx="478518" cy="333690"/>
+            <a:chOff x="3051580" y="2997200"/>
+            <a:chExt cx="1486171" cy="885465"/>
+          </a:xfrm>
+        </p:grpSpPr>
+        <p:pic>
+          <p:nvPicPr>
+            <p:cNvPr id="38" name="Picture 37">
+              <a:extLst>
+                <a:ext uri="{FF2B5EF4-FFF2-40B4-BE49-F238E27FC236}">
+                  <a16:creationId xmlns:a16="http://schemas.microsoft.com/office/drawing/2014/main" id="{CF4DD96F-D166-215C-71F3-BD4E16574C1D}"/>
+                </a:ext>
+              </a:extLst>
+            </p:cNvPr>
+            <p:cNvPicPr>
+              <a:picLocks noChangeAspect="1"/>
+            </p:cNvPicPr>
+            <p:nvPr/>
+          </p:nvPicPr>
+          <p:blipFill>
+            <a:blip r:embed="rId7"/>
+            <a:stretch>
+              <a:fillRect/>
+            </a:stretch>
+          </p:blipFill>
+          <p:spPr>
+            <a:xfrm rot="10800000">
+              <a:off x="3051580" y="2997200"/>
+              <a:ext cx="1475297" cy="440190"/>
+            </a:xfrm>
+            <a:prstGeom prst="rect">
+              <a:avLst/>
+            </a:prstGeom>
+          </p:spPr>
+        </p:pic>
+        <p:pic>
+          <p:nvPicPr>
+            <p:cNvPr id="39" name="Picture 38">
+              <a:extLst>
+                <a:ext uri="{FF2B5EF4-FFF2-40B4-BE49-F238E27FC236}">
+                  <a16:creationId xmlns:a16="http://schemas.microsoft.com/office/drawing/2014/main" id="{12B37ACB-3A02-A7A8-832A-CBFC2B9F2616}"/>
+                </a:ext>
+              </a:extLst>
+            </p:cNvPr>
+            <p:cNvPicPr>
+              <a:picLocks noChangeAspect="1"/>
+            </p:cNvPicPr>
+            <p:nvPr/>
+          </p:nvPicPr>
+          <p:blipFill>
+            <a:blip r:embed="rId7"/>
+            <a:stretch>
+              <a:fillRect/>
+            </a:stretch>
+          </p:blipFill>
+          <p:spPr>
+            <a:xfrm rot="10800000" flipH="1">
+              <a:off x="3062454" y="3442475"/>
+              <a:ext cx="1475297" cy="440190"/>
+            </a:xfrm>
+            <a:prstGeom prst="rect">
+              <a:avLst/>
+            </a:prstGeom>
+          </p:spPr>
+        </p:pic>
+      </p:grpSp>
+    </p:spTree>
+    <p:extLst>
+      <p:ext uri="{BB962C8B-B14F-4D97-AF65-F5344CB8AC3E}">
+        <p14:creationId xmlns:p14="http://schemas.microsoft.com/office/powerpoint/2010/main" val="2462622865"/>
+      </p:ext>
+    </p:extLst>
+  </p:cSld>
+  <p:clrMapOvr>
+    <a:masterClrMapping/>
+  </p:clrMapOvr>
+</p:sld>
+</file>
+
+<file path=ppt/slides/slide12.xml><?xml version="1.0" encoding="utf-8"?>
+<p:sld xmlns:a="http://schemas.openxmlformats.org/drawingml/2006/main" xmlns:r="http://schemas.openxmlformats.org/officeDocument/2006/relationships" xmlns:p="http://schemas.openxmlformats.org/presentationml/2006/main">
+  <p:cSld>
+    <p:spTree>
+      <p:nvGrpSpPr>
+        <p:cNvPr id="1" name="">
+          <a:extLst>
+            <a:ext uri="{FF2B5EF4-FFF2-40B4-BE49-F238E27FC236}">
               <a16:creationId xmlns:a16="http://schemas.microsoft.com/office/drawing/2014/main" id="{0BDD2122-D42B-935E-28E6-4C6CC005CCC8}"/>
             </a:ext>
           </a:extLst>
@@ -7080,8 +8403,8 @@
         </p:nvSpPr>
         <p:spPr>
           <a:xfrm>
-            <a:off x="3288180" y="168153"/>
-            <a:ext cx="5615640" cy="646331"/>
+            <a:off x="1226726" y="168153"/>
+            <a:ext cx="9738564" cy="646331"/>
           </a:xfrm>
           <a:prstGeom prst="rect">
             <a:avLst/>
@@ -7111,7 +8434,7 @@
                 </a:effectLst>
                 <a:latin typeface="Century Gothic" panose="020B0502020202020204" pitchFamily="34" charset="0"/>
               </a:rPr>
-              <a:t>Полученные результаты</a:t>
+              <a:t>Преимущества программного решения</a:t>
             </a:r>
           </a:p>
         </p:txBody>
@@ -7202,7 +8525,7 @@
                 <a:ea typeface="Calibri" panose="020F0502020204030204" pitchFamily="34" charset="0"/>
                 <a:cs typeface="Times New Roman" panose="02020603050405020304" pitchFamily="18" charset="0"/>
               </a:rPr>
-              <a:t> Обеспечение работы программного продукта </a:t>
+              <a:t> Автоматизация работы программного продукта </a:t>
             </a:r>
             <a:r>
               <a:rPr lang="en-US" altLang="ru-RU" sz="2000" dirty="0" err="1">
@@ -7394,7 +8717,7 @@
           <a:p>
             <a:fld id="{471AB917-4A67-459A-ADEA-E0250FA5C43E}" type="slidenum">
               <a:rPr lang="ru-RU" smtClean="0"/>
-              <a:t>11</a:t>
+              <a:t>12</a:t>
             </a:fld>
             <a:endParaRPr lang="ru-RU"/>
           </a:p>
@@ -7413,7 +8736,7 @@
 </p:sld>
 </file>
 
-<file path=ppt/slides/slide12.xml><?xml version="1.0" encoding="utf-8"?>
+<file path=ppt/slides/slide13.xml><?xml version="1.0" encoding="utf-8"?>
 <p:sld xmlns:a="http://schemas.openxmlformats.org/drawingml/2006/main" xmlns:r="http://schemas.openxmlformats.org/officeDocument/2006/relationships" xmlns:p="http://schemas.openxmlformats.org/presentationml/2006/main">
   <p:cSld>
     <p:spTree>
@@ -7512,7 +8835,7 @@
           <a:p>
             <a:fld id="{471AB917-4A67-459A-ADEA-E0250FA5C43E}" type="slidenum">
               <a:rPr lang="ru-RU" smtClean="0"/>
-              <a:t>12</a:t>
+              <a:t>13</a:t>
             </a:fld>
             <a:endParaRPr lang="ru-RU"/>
           </a:p>
@@ -7636,8 +8959,8 @@
         </p:nvSpPr>
         <p:spPr>
           <a:xfrm>
-            <a:off x="3070973" y="168153"/>
-            <a:ext cx="6050054" cy="646331"/>
+            <a:off x="2743960" y="106406"/>
+            <a:ext cx="6704079" cy="707886"/>
           </a:xfrm>
           <a:prstGeom prst="rect">
             <a:avLst/>
@@ -7651,7 +8974,7 @@
           <a:lstStyle/>
           <a:p>
             <a:r>
-              <a:rPr lang="ru-RU" sz="3600" dirty="0">
+              <a:rPr lang="ru-RU" sz="4000" dirty="0">
                 <a:solidFill>
                   <a:schemeClr val="bg1">
                     <a:lumMod val="95000"/>
@@ -7972,7 +9295,7 @@
         </p:nvSpPr>
         <p:spPr>
           <a:xfrm>
-            <a:off x="2644574" y="137376"/>
+            <a:off x="2649582" y="104186"/>
             <a:ext cx="6902852" cy="707886"/>
           </a:xfrm>
           <a:prstGeom prst="rect">
@@ -8016,7 +9339,7 @@
         </p:nvGrpSpPr>
         <p:grpSpPr>
           <a:xfrm>
-            <a:off x="8764868" y="1979985"/>
+            <a:off x="3474247" y="1062078"/>
             <a:ext cx="1785431" cy="2270345"/>
             <a:chOff x="848488" y="2995177"/>
             <a:chExt cx="1785431" cy="2270345"/>
@@ -8120,7 +9443,7 @@
         </p:nvGrpSpPr>
         <p:grpSpPr>
           <a:xfrm>
-            <a:off x="936026" y="2957974"/>
+            <a:off x="6339265" y="5008619"/>
             <a:ext cx="1959959" cy="1849381"/>
             <a:chOff x="8567446" y="2815761"/>
             <a:chExt cx="1959959" cy="1849381"/>
@@ -8218,7 +9541,7 @@
         </p:nvGrpSpPr>
         <p:grpSpPr>
           <a:xfrm>
-            <a:off x="4768981" y="2425404"/>
+            <a:off x="6940310" y="1389503"/>
             <a:ext cx="2144831" cy="1931791"/>
             <a:chOff x="9355402" y="2946927"/>
             <a:chExt cx="2144831" cy="1931791"/>
@@ -8304,126 +9627,168 @@
           </p:txBody>
         </p:sp>
       </p:grpSp>
-      <p:pic>
-        <p:nvPicPr>
-          <p:cNvPr id="15" name="Picture 14">
+      <p:grpSp>
+        <p:nvGrpSpPr>
+          <p:cNvPr id="30" name="Group 29">
             <a:extLst>
               <a:ext uri="{FF2B5EF4-FFF2-40B4-BE49-F238E27FC236}">
-                <a16:creationId xmlns:a16="http://schemas.microsoft.com/office/drawing/2014/main" id="{6223D05A-6CC1-3BB0-56EC-E48ED1372BC1}"/>
+                <a16:creationId xmlns:a16="http://schemas.microsoft.com/office/drawing/2014/main" id="{92AAD5D6-671F-46D7-FB4F-FA0542AA49AB}"/>
               </a:ext>
             </a:extLst>
           </p:cNvPr>
-          <p:cNvPicPr>
-            <a:picLocks noChangeAspect="1"/>
-          </p:cNvPicPr>
+          <p:cNvGrpSpPr/>
           <p:nvPr/>
-        </p:nvPicPr>
-        <p:blipFill>
-          <a:blip r:embed="rId7"/>
-          <a:stretch>
-            <a:fillRect/>
-          </a:stretch>
-        </p:blipFill>
-        <p:spPr>
-          <a:xfrm rot="10800000">
-            <a:off x="3051580" y="2997200"/>
-            <a:ext cx="1475297" cy="440190"/>
-          </a:xfrm>
-          <a:prstGeom prst="rect">
-            <a:avLst/>
-          </a:prstGeom>
-        </p:spPr>
-      </p:pic>
-      <p:pic>
-        <p:nvPicPr>
-          <p:cNvPr id="16" name="Picture 15">
+        </p:nvGrpSpPr>
+        <p:grpSpPr>
+          <a:xfrm rot="16200000">
+            <a:off x="3869485" y="3645095"/>
+            <a:ext cx="1197406" cy="713418"/>
+            <a:chOff x="3051580" y="2997200"/>
+            <a:chExt cx="1486171" cy="885465"/>
+          </a:xfrm>
+        </p:grpSpPr>
+        <p:pic>
+          <p:nvPicPr>
+            <p:cNvPr id="15" name="Picture 14">
+              <a:extLst>
+                <a:ext uri="{FF2B5EF4-FFF2-40B4-BE49-F238E27FC236}">
+                  <a16:creationId xmlns:a16="http://schemas.microsoft.com/office/drawing/2014/main" id="{6223D05A-6CC1-3BB0-56EC-E48ED1372BC1}"/>
+                </a:ext>
+              </a:extLst>
+            </p:cNvPr>
+            <p:cNvPicPr>
+              <a:picLocks noChangeAspect="1"/>
+            </p:cNvPicPr>
+            <p:nvPr/>
+          </p:nvPicPr>
+          <p:blipFill>
+            <a:blip r:embed="rId7"/>
+            <a:stretch>
+              <a:fillRect/>
+            </a:stretch>
+          </p:blipFill>
+          <p:spPr>
+            <a:xfrm rot="10800000">
+              <a:off x="3051580" y="2997200"/>
+              <a:ext cx="1475297" cy="440190"/>
+            </a:xfrm>
+            <a:prstGeom prst="rect">
+              <a:avLst/>
+            </a:prstGeom>
+          </p:spPr>
+        </p:pic>
+        <p:pic>
+          <p:nvPicPr>
+            <p:cNvPr id="16" name="Picture 15">
+              <a:extLst>
+                <a:ext uri="{FF2B5EF4-FFF2-40B4-BE49-F238E27FC236}">
+                  <a16:creationId xmlns:a16="http://schemas.microsoft.com/office/drawing/2014/main" id="{23FE7613-C3BD-ED6E-0B2C-B1B4C6E9DCA4}"/>
+                </a:ext>
+              </a:extLst>
+            </p:cNvPr>
+            <p:cNvPicPr>
+              <a:picLocks noChangeAspect="1"/>
+            </p:cNvPicPr>
+            <p:nvPr/>
+          </p:nvPicPr>
+          <p:blipFill>
+            <a:blip r:embed="rId7"/>
+            <a:stretch>
+              <a:fillRect/>
+            </a:stretch>
+          </p:blipFill>
+          <p:spPr>
+            <a:xfrm rot="10800000" flipH="1">
+              <a:off x="3062454" y="3442475"/>
+              <a:ext cx="1475297" cy="440190"/>
+            </a:xfrm>
+            <a:prstGeom prst="rect">
+              <a:avLst/>
+            </a:prstGeom>
+          </p:spPr>
+        </p:pic>
+      </p:grpSp>
+      <p:grpSp>
+        <p:nvGrpSpPr>
+          <p:cNvPr id="31" name="Group 30">
             <a:extLst>
               <a:ext uri="{FF2B5EF4-FFF2-40B4-BE49-F238E27FC236}">
-                <a16:creationId xmlns:a16="http://schemas.microsoft.com/office/drawing/2014/main" id="{23FE7613-C3BD-ED6E-0B2C-B1B4C6E9DCA4}"/>
+                <a16:creationId xmlns:a16="http://schemas.microsoft.com/office/drawing/2014/main" id="{1BCDE1F2-4856-DB46-81B0-9741872E5801}"/>
               </a:ext>
             </a:extLst>
           </p:cNvPr>
-          <p:cNvPicPr>
-            <a:picLocks noChangeAspect="1"/>
-          </p:cNvPicPr>
+          <p:cNvGrpSpPr/>
           <p:nvPr/>
-        </p:nvPicPr>
-        <p:blipFill>
-          <a:blip r:embed="rId7"/>
-          <a:stretch>
-            <a:fillRect/>
-          </a:stretch>
-        </p:blipFill>
-        <p:spPr>
-          <a:xfrm rot="10800000" flipH="1">
-            <a:off x="3062454" y="3442475"/>
-            <a:ext cx="1475297" cy="440190"/>
-          </a:xfrm>
-          <a:prstGeom prst="rect">
-            <a:avLst/>
-          </a:prstGeom>
-        </p:spPr>
-      </p:pic>
-      <p:pic>
-        <p:nvPicPr>
-          <p:cNvPr id="17" name="Picture 16">
-            <a:extLst>
-              <a:ext uri="{FF2B5EF4-FFF2-40B4-BE49-F238E27FC236}">
-                <a16:creationId xmlns:a16="http://schemas.microsoft.com/office/drawing/2014/main" id="{6223D05A-6CC1-3BB0-56EC-E48ED1372BC1}"/>
-              </a:ext>
-            </a:extLst>
-          </p:cNvPr>
-          <p:cNvPicPr>
-            <a:picLocks noChangeAspect="1"/>
-          </p:cNvPicPr>
-          <p:nvPr/>
-        </p:nvPicPr>
-        <p:blipFill>
-          <a:blip r:embed="rId7"/>
-          <a:stretch>
-            <a:fillRect/>
-          </a:stretch>
-        </p:blipFill>
-        <p:spPr>
-          <a:xfrm rot="10800000">
-            <a:off x="7133976" y="2997200"/>
-            <a:ext cx="1475297" cy="440190"/>
-          </a:xfrm>
-          <a:prstGeom prst="rect">
-            <a:avLst/>
-          </a:prstGeom>
-        </p:spPr>
-      </p:pic>
-      <p:pic>
-        <p:nvPicPr>
-          <p:cNvPr id="18" name="Picture 17">
-            <a:extLst>
-              <a:ext uri="{FF2B5EF4-FFF2-40B4-BE49-F238E27FC236}">
-                <a16:creationId xmlns:a16="http://schemas.microsoft.com/office/drawing/2014/main" id="{23FE7613-C3BD-ED6E-0B2C-B1B4C6E9DCA4}"/>
-              </a:ext>
-            </a:extLst>
-          </p:cNvPr>
-          <p:cNvPicPr>
-            <a:picLocks noChangeAspect="1"/>
-          </p:cNvPicPr>
-          <p:nvPr/>
-        </p:nvPicPr>
-        <p:blipFill>
-          <a:blip r:embed="rId7"/>
-          <a:stretch>
-            <a:fillRect/>
-          </a:stretch>
-        </p:blipFill>
-        <p:spPr>
-          <a:xfrm rot="10800000" flipH="1">
-            <a:off x="7144850" y="3442475"/>
-            <a:ext cx="1475297" cy="440190"/>
-          </a:xfrm>
-          <a:prstGeom prst="rect">
-            <a:avLst/>
-          </a:prstGeom>
-        </p:spPr>
-      </p:pic>
+        </p:nvGrpSpPr>
+        <p:grpSpPr>
+          <a:xfrm>
+            <a:off x="5411530" y="1895788"/>
+            <a:ext cx="1368940" cy="815619"/>
+            <a:chOff x="6871862" y="1433188"/>
+            <a:chExt cx="1486171" cy="885465"/>
+          </a:xfrm>
+        </p:grpSpPr>
+        <p:pic>
+          <p:nvPicPr>
+            <p:cNvPr id="17" name="Picture 16">
+              <a:extLst>
+                <a:ext uri="{FF2B5EF4-FFF2-40B4-BE49-F238E27FC236}">
+                  <a16:creationId xmlns:a16="http://schemas.microsoft.com/office/drawing/2014/main" id="{6223D05A-6CC1-3BB0-56EC-E48ED1372BC1}"/>
+                </a:ext>
+              </a:extLst>
+            </p:cNvPr>
+            <p:cNvPicPr>
+              <a:picLocks noChangeAspect="1"/>
+            </p:cNvPicPr>
+            <p:nvPr/>
+          </p:nvPicPr>
+          <p:blipFill>
+            <a:blip r:embed="rId7"/>
+            <a:stretch>
+              <a:fillRect/>
+            </a:stretch>
+          </p:blipFill>
+          <p:spPr>
+            <a:xfrm rot="10800000">
+              <a:off x="6871862" y="1433188"/>
+              <a:ext cx="1475297" cy="440190"/>
+            </a:xfrm>
+            <a:prstGeom prst="rect">
+              <a:avLst/>
+            </a:prstGeom>
+          </p:spPr>
+        </p:pic>
+        <p:pic>
+          <p:nvPicPr>
+            <p:cNvPr id="18" name="Picture 17">
+              <a:extLst>
+                <a:ext uri="{FF2B5EF4-FFF2-40B4-BE49-F238E27FC236}">
+                  <a16:creationId xmlns:a16="http://schemas.microsoft.com/office/drawing/2014/main" id="{23FE7613-C3BD-ED6E-0B2C-B1B4C6E9DCA4}"/>
+                </a:ext>
+              </a:extLst>
+            </p:cNvPr>
+            <p:cNvPicPr>
+              <a:picLocks noChangeAspect="1"/>
+            </p:cNvPicPr>
+            <p:nvPr/>
+          </p:nvPicPr>
+          <p:blipFill>
+            <a:blip r:embed="rId7"/>
+            <a:stretch>
+              <a:fillRect/>
+            </a:stretch>
+          </p:blipFill>
+          <p:spPr>
+            <a:xfrm rot="10800000" flipH="1">
+              <a:off x="6882736" y="1878463"/>
+              <a:ext cx="1475297" cy="440190"/>
+            </a:xfrm>
+            <a:prstGeom prst="rect">
+              <a:avLst/>
+            </a:prstGeom>
+          </p:spPr>
+        </p:pic>
+      </p:grpSp>
       <p:pic>
         <p:nvPicPr>
           <p:cNvPr id="19" name="Picture 18">
@@ -8452,68 +9817,8 @@
         </p:blipFill>
         <p:spPr>
           <a:xfrm>
-            <a:off x="1010669" y="1120015"/>
+            <a:off x="379462" y="5117406"/>
             <a:ext cx="1810669" cy="1085182"/>
-          </a:xfrm>
-          <a:prstGeom prst="rect">
-            <a:avLst/>
-          </a:prstGeom>
-        </p:spPr>
-      </p:pic>
-      <p:pic>
-        <p:nvPicPr>
-          <p:cNvPr id="20" name="Picture 19">
-            <a:extLst>
-              <a:ext uri="{FF2B5EF4-FFF2-40B4-BE49-F238E27FC236}">
-                <a16:creationId xmlns:a16="http://schemas.microsoft.com/office/drawing/2014/main" id="{6223D05A-6CC1-3BB0-56EC-E48ED1372BC1}"/>
-              </a:ext>
-            </a:extLst>
-          </p:cNvPr>
-          <p:cNvPicPr>
-            <a:picLocks noChangeAspect="1"/>
-          </p:cNvPicPr>
-          <p:nvPr/>
-        </p:nvPicPr>
-        <p:blipFill>
-          <a:blip r:embed="rId7"/>
-          <a:stretch>
-            <a:fillRect/>
-          </a:stretch>
-        </p:blipFill>
-        <p:spPr>
-          <a:xfrm rot="5400000">
-            <a:off x="1539802" y="2490841"/>
-            <a:ext cx="752404" cy="278702"/>
-          </a:xfrm>
-          <a:prstGeom prst="rect">
-            <a:avLst/>
-          </a:prstGeom>
-        </p:spPr>
-      </p:pic>
-      <p:pic>
-        <p:nvPicPr>
-          <p:cNvPr id="21" name="Picture 20">
-            <a:extLst>
-              <a:ext uri="{FF2B5EF4-FFF2-40B4-BE49-F238E27FC236}">
-                <a16:creationId xmlns:a16="http://schemas.microsoft.com/office/drawing/2014/main" id="{6223D05A-6CC1-3BB0-56EC-E48ED1372BC1}"/>
-              </a:ext>
-            </a:extLst>
-          </p:cNvPr>
-          <p:cNvPicPr>
-            <a:picLocks noChangeAspect="1"/>
-          </p:cNvPicPr>
-          <p:nvPr/>
-        </p:nvPicPr>
-        <p:blipFill>
-          <a:blip r:embed="rId7"/>
-          <a:stretch>
-            <a:fillRect/>
-          </a:stretch>
-        </p:blipFill>
-        <p:spPr>
-          <a:xfrm rot="1656693">
-            <a:off x="3202116" y="4658913"/>
-            <a:ext cx="1584729" cy="428898"/>
           </a:xfrm>
           <a:prstGeom prst="rect">
             <a:avLst/>
@@ -8528,7 +9833,7 @@
         </p:nvGrpSpPr>
         <p:grpSpPr>
           <a:xfrm>
-            <a:off x="4936870" y="4516335"/>
+            <a:off x="3474248" y="4591746"/>
             <a:ext cx="1785431" cy="2128878"/>
             <a:chOff x="5808303" y="4460011"/>
             <a:chExt cx="1785431" cy="2128878"/>
@@ -8616,9 +9921,9 @@
           <p:nvPr/>
         </p:nvGrpSpPr>
         <p:grpSpPr>
-          <a:xfrm rot="9176301">
-            <a:off x="6802492" y="4473152"/>
-            <a:ext cx="1575686" cy="800421"/>
+          <a:xfrm rot="5400000">
+            <a:off x="7291031" y="3750901"/>
+            <a:ext cx="1356940" cy="689302"/>
             <a:chOff x="2071940" y="4941171"/>
             <a:chExt cx="1486171" cy="885465"/>
           </a:xfrm>
@@ -8706,8 +10011,8 @@
         </p:blipFill>
         <p:spPr>
           <a:xfrm>
-            <a:off x="6743121" y="5680529"/>
-            <a:ext cx="1584729" cy="428898"/>
+            <a:off x="8433978" y="5501982"/>
+            <a:ext cx="1349095" cy="365125"/>
           </a:xfrm>
           <a:prstGeom prst="rect">
             <a:avLst/>
@@ -8742,7 +10047,7 @@
         </p:blipFill>
         <p:spPr>
           <a:xfrm>
-            <a:off x="8620147" y="5247676"/>
+            <a:off x="9802664" y="5301575"/>
             <a:ext cx="2206943" cy="865707"/>
           </a:xfrm>
           <a:prstGeom prst="rect">
@@ -8779,6 +10084,66 @@
           </a:p>
         </p:txBody>
       </p:sp>
+      <p:pic>
+        <p:nvPicPr>
+          <p:cNvPr id="32" name="Picture 31">
+            <a:extLst>
+              <a:ext uri="{FF2B5EF4-FFF2-40B4-BE49-F238E27FC236}">
+                <a16:creationId xmlns:a16="http://schemas.microsoft.com/office/drawing/2014/main" id="{B38C4DA5-75FC-DBDC-3386-3EACA6DA3E75}"/>
+              </a:ext>
+            </a:extLst>
+          </p:cNvPr>
+          <p:cNvPicPr>
+            <a:picLocks noChangeAspect="1"/>
+          </p:cNvPicPr>
+          <p:nvPr/>
+        </p:nvPicPr>
+        <p:blipFill>
+          <a:blip r:embed="rId7"/>
+          <a:stretch>
+            <a:fillRect/>
+          </a:stretch>
+        </p:blipFill>
+        <p:spPr>
+          <a:xfrm>
+            <a:off x="4922793" y="5474334"/>
+            <a:ext cx="1349095" cy="365125"/>
+          </a:xfrm>
+          <a:prstGeom prst="rect">
+            <a:avLst/>
+          </a:prstGeom>
+        </p:spPr>
+      </p:pic>
+      <p:pic>
+        <p:nvPicPr>
+          <p:cNvPr id="33" name="Picture 32">
+            <a:extLst>
+              <a:ext uri="{FF2B5EF4-FFF2-40B4-BE49-F238E27FC236}">
+                <a16:creationId xmlns:a16="http://schemas.microsoft.com/office/drawing/2014/main" id="{10DA6D19-172E-1097-C344-DE57B6C64D8B}"/>
+              </a:ext>
+            </a:extLst>
+          </p:cNvPr>
+          <p:cNvPicPr>
+            <a:picLocks noChangeAspect="1"/>
+          </p:cNvPicPr>
+          <p:nvPr/>
+        </p:nvPicPr>
+        <p:blipFill>
+          <a:blip r:embed="rId7"/>
+          <a:stretch>
+            <a:fillRect/>
+          </a:stretch>
+        </p:blipFill>
+        <p:spPr>
+          <a:xfrm>
+            <a:off x="2391319" y="5474333"/>
+            <a:ext cx="1349095" cy="365125"/>
+          </a:xfrm>
+          <a:prstGeom prst="rect">
+            <a:avLst/>
+          </a:prstGeom>
+        </p:spPr>
+      </p:pic>
     </p:spTree>
     <p:extLst>
       <p:ext uri="{BB962C8B-B14F-4D97-AF65-F5344CB8AC3E}">
@@ -10187,7 +11552,7 @@
         </p:blipFill>
         <p:spPr>
           <a:xfrm rot="14011547" flipH="1">
-            <a:off x="6559358" y="2918305"/>
+            <a:off x="6559358" y="2928938"/>
             <a:ext cx="714428" cy="207710"/>
           </a:xfrm>
           <a:prstGeom prst="rect">
@@ -10217,7 +11582,7 @@
         </p:blipFill>
         <p:spPr>
           <a:xfrm rot="16200000" flipH="1">
-            <a:off x="7728324" y="2888147"/>
+            <a:off x="7728324" y="2909413"/>
             <a:ext cx="562526" cy="192756"/>
           </a:xfrm>
           <a:prstGeom prst="rect">
@@ -10247,7 +11612,7 @@
         </p:blipFill>
         <p:spPr>
           <a:xfrm rot="8026173">
-            <a:off x="8835047" y="2921463"/>
+            <a:off x="8835047" y="2932096"/>
             <a:ext cx="714428" cy="207710"/>
           </a:xfrm>
           <a:prstGeom prst="rect">
@@ -12902,6 +14267,58 @@
           <a:chExt cx="0" cy="0"/>
         </a:xfrm>
       </p:grpSpPr>
+      <p:sp>
+        <p:nvSpPr>
+          <p:cNvPr id="52" name="Rectangle 51">
+            <a:extLst>
+              <a:ext uri="{FF2B5EF4-FFF2-40B4-BE49-F238E27FC236}">
+                <a16:creationId xmlns:a16="http://schemas.microsoft.com/office/drawing/2014/main" id="{529C2627-CD5F-A902-B215-21B7C19F6F64}"/>
+              </a:ext>
+            </a:extLst>
+          </p:cNvPr>
+          <p:cNvSpPr/>
+          <p:nvPr/>
+        </p:nvSpPr>
+        <p:spPr>
+          <a:xfrm>
+            <a:off x="1362777" y="3156756"/>
+            <a:ext cx="3794593" cy="1926720"/>
+          </a:xfrm>
+          <a:prstGeom prst="rect">
+            <a:avLst/>
+          </a:prstGeom>
+          <a:noFill/>
+          <a:ln w="76200">
+            <a:solidFill>
+              <a:schemeClr val="accent1">
+                <a:lumMod val="50000"/>
+              </a:schemeClr>
+            </a:solidFill>
+          </a:ln>
+        </p:spPr>
+        <p:style>
+          <a:lnRef idx="2">
+            <a:schemeClr val="accent6"/>
+          </a:lnRef>
+          <a:fillRef idx="1">
+            <a:schemeClr val="lt1"/>
+          </a:fillRef>
+          <a:effectRef idx="0">
+            <a:schemeClr val="accent6"/>
+          </a:effectRef>
+          <a:fontRef idx="minor">
+            <a:schemeClr val="dk1"/>
+          </a:fontRef>
+        </p:style>
+        <p:txBody>
+          <a:bodyPr rtlCol="0" anchor="ctr"/>
+          <a:lstStyle/>
+          <a:p>
+            <a:pPr algn="ctr"/>
+            <a:endParaRPr lang="en-US"/>
+          </a:p>
+        </p:txBody>
+      </p:sp>
       <p:pic>
         <p:nvPicPr>
           <p:cNvPr id="2" name="Picture 2" descr="C:\Users\Андрей\Desktop\1\Безымянный-1.png"/>
@@ -12990,8 +14407,8 @@
         </p:nvSpPr>
         <p:spPr>
           <a:xfrm>
-            <a:off x="1355767" y="168153"/>
-            <a:ext cx="9480480" cy="646331"/>
+            <a:off x="1874341" y="168153"/>
+            <a:ext cx="8443337" cy="646331"/>
           </a:xfrm>
           <a:prstGeom prst="rect">
             <a:avLst/>
@@ -13021,7 +14438,7 @@
                 </a:effectLst>
                 <a:latin typeface="Century Gothic" panose="020B0502020202020204" pitchFamily="34" charset="0"/>
               </a:rPr>
-              <a:t>Схема взаимодействия с эмбоссером</a:t>
+              <a:t>Схема взаимодействия с модулем</a:t>
             </a:r>
           </a:p>
         </p:txBody>
@@ -13090,7 +14507,7 @@
         </p:blipFill>
         <p:spPr>
           <a:xfrm>
-            <a:off x="1045986" y="2125557"/>
+            <a:off x="655182" y="1150792"/>
             <a:ext cx="1496533" cy="1562459"/>
           </a:xfrm>
           <a:prstGeom prst="rect">
@@ -13106,7 +14523,7 @@
         </p:nvSpPr>
         <p:spPr>
           <a:xfrm>
-            <a:off x="399164" y="3719491"/>
+            <a:off x="52893" y="2711148"/>
             <a:ext cx="2806089" cy="369332"/>
           </a:xfrm>
           <a:prstGeom prst="rect">
@@ -13144,112 +14561,6 @@
           </a:p>
         </p:txBody>
       </p:sp>
-      <p:pic>
-        <p:nvPicPr>
-          <p:cNvPr id="12" name="Picture 11">
-            <a:extLst>
-              <a:ext uri="{FF2B5EF4-FFF2-40B4-BE49-F238E27FC236}">
-                <a16:creationId xmlns:a16="http://schemas.microsoft.com/office/drawing/2014/main" id="{496E22DE-4516-4074-B8C8-B7A50F6B2AED}"/>
-              </a:ext>
-            </a:extLst>
-          </p:cNvPr>
-          <p:cNvPicPr>
-            <a:picLocks noChangeAspect="1"/>
-          </p:cNvPicPr>
-          <p:nvPr/>
-        </p:nvPicPr>
-        <p:blipFill>
-          <a:blip r:embed="rId5">
-            <a:extLst>
-              <a:ext uri="{28A0092B-C50C-407E-A947-70E740481C1C}">
-                <a14:useLocalDpi xmlns:a14="http://schemas.microsoft.com/office/drawing/2010/main" val="0"/>
-              </a:ext>
-            </a:extLst>
-          </a:blip>
-          <a:stretch>
-            <a:fillRect/>
-          </a:stretch>
-        </p:blipFill>
-        <p:spPr>
-          <a:xfrm>
-            <a:off x="3867099" y="1480065"/>
-            <a:ext cx="1276369" cy="979283"/>
-          </a:xfrm>
-          <a:prstGeom prst="rect">
-            <a:avLst/>
-          </a:prstGeom>
-        </p:spPr>
-      </p:pic>
-      <p:sp>
-        <p:nvSpPr>
-          <p:cNvPr id="3" name="TextBox 2">
-            <a:extLst>
-              <a:ext uri="{FF2B5EF4-FFF2-40B4-BE49-F238E27FC236}">
-                <a16:creationId xmlns:a16="http://schemas.microsoft.com/office/drawing/2014/main" id="{5B6B90C0-A00A-63D2-36CB-536B62992C28}"/>
-              </a:ext>
-            </a:extLst>
-          </p:cNvPr>
-          <p:cNvSpPr txBox="1"/>
-          <p:nvPr/>
-        </p:nvSpPr>
-        <p:spPr>
-          <a:xfrm>
-            <a:off x="2697714" y="1058916"/>
-            <a:ext cx="3615138" cy="369332"/>
-          </a:xfrm>
-          <a:prstGeom prst="rect">
-            <a:avLst/>
-          </a:prstGeom>
-          <a:noFill/>
-        </p:spPr>
-        <p:txBody>
-          <a:bodyPr wrap="square" rtlCol="0">
-            <a:spAutoFit/>
-          </a:bodyPr>
-          <a:lstStyle/>
-          <a:p>
-            <a:r>
-              <a:rPr lang="ru-RU" dirty="0">
-                <a:latin typeface="Century Gothic" panose="020B0502020202020204" pitchFamily="34" charset="0"/>
-              </a:rPr>
-              <a:t>База с таблицей данных карт</a:t>
-            </a:r>
-            <a:endParaRPr lang="en-US" dirty="0">
-              <a:latin typeface="Century Gothic" panose="020B0502020202020204" pitchFamily="34" charset="0"/>
-            </a:endParaRPr>
-          </a:p>
-        </p:txBody>
-      </p:sp>
-      <p:pic>
-        <p:nvPicPr>
-          <p:cNvPr id="4" name="Picture 3">
-            <a:extLst>
-              <a:ext uri="{FF2B5EF4-FFF2-40B4-BE49-F238E27FC236}">
-                <a16:creationId xmlns:a16="http://schemas.microsoft.com/office/drawing/2014/main" id="{0D601E62-BCE4-D040-93B7-241008D654F1}"/>
-              </a:ext>
-            </a:extLst>
-          </p:cNvPr>
-          <p:cNvPicPr>
-            <a:picLocks noChangeAspect="1"/>
-          </p:cNvPicPr>
-          <p:nvPr/>
-        </p:nvPicPr>
-        <p:blipFill>
-          <a:blip r:embed="rId6"/>
-          <a:stretch>
-            <a:fillRect/>
-          </a:stretch>
-        </p:blipFill>
-        <p:spPr>
-          <a:xfrm rot="20256606">
-            <a:off x="2500483" y="2334834"/>
-            <a:ext cx="1390684" cy="376396"/>
-          </a:xfrm>
-          <a:prstGeom prst="rect">
-            <a:avLst/>
-          </a:prstGeom>
-        </p:spPr>
-      </p:pic>
       <p:grpSp>
         <p:nvGrpSpPr>
           <p:cNvPr id="10" name="Group 9"/>
@@ -13258,7 +14569,7 @@
         </p:nvGrpSpPr>
         <p:grpSpPr>
           <a:xfrm>
-            <a:off x="9317614" y="1201715"/>
+            <a:off x="9370779" y="1201715"/>
             <a:ext cx="2144831" cy="1931791"/>
             <a:chOff x="9355402" y="2946927"/>
             <a:chExt cx="2144831" cy="1931791"/>
@@ -13279,7 +14590,7 @@
             <p:nvPr/>
           </p:nvPicPr>
           <p:blipFill>
-            <a:blip r:embed="rId7">
+            <a:blip r:embed="rId5">
               <a:extLst>
                 <a:ext uri="{28A0092B-C50C-407E-A947-70E740481C1C}">
                   <a14:useLocalDpi xmlns:a14="http://schemas.microsoft.com/office/drawing/2010/main" val="0"/>
@@ -13346,298 +14657,13 @@
       </p:grpSp>
       <p:grpSp>
         <p:nvGrpSpPr>
-          <p:cNvPr id="49" name="Group 48"/>
-          <p:cNvGrpSpPr/>
-          <p:nvPr/>
-        </p:nvGrpSpPr>
-        <p:grpSpPr>
-          <a:xfrm>
-            <a:off x="7224239" y="2535943"/>
-            <a:ext cx="1164942" cy="1562459"/>
-            <a:chOff x="7253890" y="2967187"/>
-            <a:chExt cx="1164942" cy="1562459"/>
-          </a:xfrm>
-        </p:grpSpPr>
-        <p:pic>
-          <p:nvPicPr>
-            <p:cNvPr id="20" name="Picture 19">
-              <a:extLst>
-                <a:ext uri="{FF2B5EF4-FFF2-40B4-BE49-F238E27FC236}">
-                  <a16:creationId xmlns:a16="http://schemas.microsoft.com/office/drawing/2014/main" id="{E3491331-5420-4D91-B017-712E5A6C1573}"/>
-                </a:ext>
-              </a:extLst>
-            </p:cNvPr>
-            <p:cNvPicPr>
-              <a:picLocks noChangeAspect="1"/>
-            </p:cNvPicPr>
-            <p:nvPr/>
-          </p:nvPicPr>
-          <p:blipFill>
-            <a:blip r:embed="rId8">
-              <a:extLst>
-                <a:ext uri="{28A0092B-C50C-407E-A947-70E740481C1C}">
-                  <a14:useLocalDpi xmlns:a14="http://schemas.microsoft.com/office/drawing/2010/main" val="0"/>
-                </a:ext>
-              </a:extLst>
-            </a:blip>
-            <a:stretch>
-              <a:fillRect/>
-            </a:stretch>
-          </p:blipFill>
-          <p:spPr>
-            <a:xfrm>
-              <a:off x="7253890" y="2967187"/>
-              <a:ext cx="1164942" cy="1562459"/>
-            </a:xfrm>
-            <a:prstGeom prst="rect">
-              <a:avLst/>
-            </a:prstGeom>
-          </p:spPr>
-        </p:pic>
-        <p:pic>
-          <p:nvPicPr>
-            <p:cNvPr id="22" name="Picture 21">
-              <a:extLst>
-                <a:ext uri="{FF2B5EF4-FFF2-40B4-BE49-F238E27FC236}">
-                  <a16:creationId xmlns:a16="http://schemas.microsoft.com/office/drawing/2014/main" id="{0E20CE0C-66E3-073B-E6D6-DD7E83255D76}"/>
-                </a:ext>
-              </a:extLst>
-            </p:cNvPr>
-            <p:cNvPicPr>
-              <a:picLocks noChangeAspect="1"/>
-            </p:cNvPicPr>
-            <p:nvPr/>
-          </p:nvPicPr>
-          <p:blipFill>
-            <a:blip r:embed="rId7" cstate="print">
-              <a:extLst>
-                <a:ext uri="{28A0092B-C50C-407E-A947-70E740481C1C}">
-                  <a14:useLocalDpi xmlns:a14="http://schemas.microsoft.com/office/drawing/2010/main" val="0"/>
-                </a:ext>
-              </a:extLst>
-            </a:blip>
-            <a:stretch>
-              <a:fillRect/>
-            </a:stretch>
-          </p:blipFill>
-          <p:spPr>
-            <a:xfrm>
-              <a:off x="7410581" y="3266531"/>
-              <a:ext cx="851560" cy="620342"/>
-            </a:xfrm>
-            <a:prstGeom prst="rect">
-              <a:avLst/>
-            </a:prstGeom>
-          </p:spPr>
-        </p:pic>
-        <p:sp>
-          <p:nvSpPr>
-            <p:cNvPr id="23" name="TextBox 22">
-              <a:extLst>
-                <a:ext uri="{FF2B5EF4-FFF2-40B4-BE49-F238E27FC236}">
-                  <a16:creationId xmlns:a16="http://schemas.microsoft.com/office/drawing/2014/main" id="{6C0A6251-3A3B-06AD-FFB2-18AD25A5A38C}"/>
-                </a:ext>
-              </a:extLst>
-            </p:cNvPr>
-            <p:cNvSpPr txBox="1"/>
-            <p:nvPr/>
-          </p:nvSpPr>
-          <p:spPr>
-            <a:xfrm>
-              <a:off x="7551892" y="3923527"/>
-              <a:ext cx="568938" cy="369332"/>
-            </a:xfrm>
-            <a:prstGeom prst="rect">
-              <a:avLst/>
-            </a:prstGeom>
-            <a:noFill/>
-          </p:spPr>
-          <p:txBody>
-            <a:bodyPr wrap="square" rtlCol="0">
-              <a:spAutoFit/>
-            </a:bodyPr>
-            <a:lstStyle/>
-            <a:p>
-              <a:r>
-                <a:rPr lang="en-US" dirty="0">
-                  <a:latin typeface="Century Gothic" panose="020B0502020202020204" pitchFamily="34" charset="0"/>
-                </a:rPr>
-                <a:t>DLL</a:t>
-              </a:r>
-            </a:p>
-          </p:txBody>
-        </p:sp>
-      </p:grpSp>
-      <p:grpSp>
-        <p:nvGrpSpPr>
-          <p:cNvPr id="14" name="Group 13"/>
-          <p:cNvGrpSpPr/>
-          <p:nvPr/>
-        </p:nvGrpSpPr>
-        <p:grpSpPr>
-          <a:xfrm>
-            <a:off x="4603613" y="2555354"/>
-            <a:ext cx="1098482" cy="1473321"/>
-            <a:chOff x="4831571" y="2946928"/>
-            <a:chExt cx="1164942" cy="1562459"/>
-          </a:xfrm>
-        </p:grpSpPr>
-        <p:pic>
-          <p:nvPicPr>
-            <p:cNvPr id="17" name="Picture 16">
-              <a:extLst>
-                <a:ext uri="{FF2B5EF4-FFF2-40B4-BE49-F238E27FC236}">
-                  <a16:creationId xmlns:a16="http://schemas.microsoft.com/office/drawing/2014/main" id="{E0F9B1DF-C0D3-5F68-7E9B-BF5685B16513}"/>
-                </a:ext>
-              </a:extLst>
-            </p:cNvPr>
-            <p:cNvPicPr>
-              <a:picLocks noChangeAspect="1"/>
-            </p:cNvPicPr>
-            <p:nvPr/>
-          </p:nvPicPr>
-          <p:blipFill>
-            <a:blip r:embed="rId8">
-              <a:extLst>
-                <a:ext uri="{28A0092B-C50C-407E-A947-70E740481C1C}">
-                  <a14:useLocalDpi xmlns:a14="http://schemas.microsoft.com/office/drawing/2010/main" val="0"/>
-                </a:ext>
-              </a:extLst>
-            </a:blip>
-            <a:stretch>
-              <a:fillRect/>
-            </a:stretch>
-          </p:blipFill>
-          <p:spPr>
-            <a:xfrm>
-              <a:off x="4831571" y="2946928"/>
-              <a:ext cx="1164942" cy="1562459"/>
-            </a:xfrm>
-            <a:prstGeom prst="rect">
-              <a:avLst/>
-            </a:prstGeom>
-          </p:spPr>
-        </p:pic>
-        <p:sp>
-          <p:nvSpPr>
-            <p:cNvPr id="24" name="TextBox 23">
-              <a:extLst>
-                <a:ext uri="{FF2B5EF4-FFF2-40B4-BE49-F238E27FC236}">
-                  <a16:creationId xmlns:a16="http://schemas.microsoft.com/office/drawing/2014/main" id="{2A7903FB-3E51-F02C-AC3F-FCD788A4A299}"/>
-                </a:ext>
-              </a:extLst>
-            </p:cNvPr>
-            <p:cNvSpPr txBox="1"/>
-            <p:nvPr/>
-          </p:nvSpPr>
-          <p:spPr>
-            <a:xfrm>
-              <a:off x="4939898" y="3435565"/>
-              <a:ext cx="948287" cy="685435"/>
-            </a:xfrm>
-            <a:prstGeom prst="rect">
-              <a:avLst/>
-            </a:prstGeom>
-            <a:noFill/>
-          </p:spPr>
-          <p:txBody>
-            <a:bodyPr wrap="square" rtlCol="0">
-              <a:spAutoFit/>
-            </a:bodyPr>
-            <a:lstStyle/>
-            <a:p>
-              <a:pPr algn="ctr"/>
-              <a:r>
-                <a:rPr lang="en-US" dirty="0">
-                  <a:latin typeface="Century Gothic" panose="020B0502020202020204" pitchFamily="34" charset="0"/>
-                </a:rPr>
-                <a:t>XML</a:t>
-              </a:r>
-            </a:p>
-            <a:p>
-              <a:pPr algn="ctr"/>
-              <a:r>
-                <a:rPr lang="ru-RU" dirty="0">
-                  <a:latin typeface="Century Gothic" panose="020B0502020202020204" pitchFamily="34" charset="0"/>
-                </a:rPr>
-                <a:t>файл</a:t>
-              </a:r>
-              <a:endParaRPr lang="en-US" dirty="0">
-                <a:latin typeface="Century Gothic" panose="020B0502020202020204" pitchFamily="34" charset="0"/>
-              </a:endParaRPr>
-            </a:p>
-          </p:txBody>
-        </p:sp>
-      </p:grpSp>
-      <p:pic>
-        <p:nvPicPr>
-          <p:cNvPr id="27" name="Picture 26">
-            <a:extLst>
-              <a:ext uri="{FF2B5EF4-FFF2-40B4-BE49-F238E27FC236}">
-                <a16:creationId xmlns:a16="http://schemas.microsoft.com/office/drawing/2014/main" id="{6223D05A-6CC1-3BB0-56EC-E48ED1372BC1}"/>
-              </a:ext>
-            </a:extLst>
-          </p:cNvPr>
-          <p:cNvPicPr>
-            <a:picLocks noChangeAspect="1"/>
-          </p:cNvPicPr>
-          <p:nvPr/>
-        </p:nvPicPr>
-        <p:blipFill>
-          <a:blip r:embed="rId6"/>
-          <a:stretch>
-            <a:fillRect/>
-          </a:stretch>
-        </p:blipFill>
-        <p:spPr>
-          <a:xfrm rot="10800000">
-            <a:off x="3228240" y="2919802"/>
-            <a:ext cx="1146960" cy="342224"/>
-          </a:xfrm>
-          <a:prstGeom prst="rect">
-            <a:avLst/>
-          </a:prstGeom>
-        </p:spPr>
-      </p:pic>
-      <p:pic>
-        <p:nvPicPr>
-          <p:cNvPr id="28" name="Picture 27">
-            <a:extLst>
-              <a:ext uri="{FF2B5EF4-FFF2-40B4-BE49-F238E27FC236}">
-                <a16:creationId xmlns:a16="http://schemas.microsoft.com/office/drawing/2014/main" id="{23FE7613-C3BD-ED6E-0B2C-B1B4C6E9DCA4}"/>
-              </a:ext>
-            </a:extLst>
-          </p:cNvPr>
-          <p:cNvPicPr>
-            <a:picLocks noChangeAspect="1"/>
-          </p:cNvPicPr>
-          <p:nvPr/>
-        </p:nvPicPr>
-        <p:blipFill>
-          <a:blip r:embed="rId6"/>
-          <a:stretch>
-            <a:fillRect/>
-          </a:stretch>
-        </p:blipFill>
-        <p:spPr>
-          <a:xfrm rot="10800000" flipH="1">
-            <a:off x="3239114" y="3365077"/>
-            <a:ext cx="1146962" cy="342224"/>
-          </a:xfrm>
-          <a:prstGeom prst="rect">
-            <a:avLst/>
-          </a:prstGeom>
-        </p:spPr>
-      </p:pic>
-      <p:grpSp>
-        <p:nvGrpSpPr>
           <p:cNvPr id="53" name="Group 52"/>
           <p:cNvGrpSpPr/>
           <p:nvPr/>
         </p:nvGrpSpPr>
         <p:grpSpPr>
           <a:xfrm>
-            <a:off x="5650433" y="4809780"/>
+            <a:off x="3788548" y="3360900"/>
             <a:ext cx="1321445" cy="1562459"/>
             <a:chOff x="4459057" y="4591624"/>
             <a:chExt cx="1321445" cy="1562459"/>
@@ -13658,7 +14684,7 @@
             <p:nvPr/>
           </p:nvPicPr>
           <p:blipFill>
-            <a:blip r:embed="rId8">
+            <a:blip r:embed="rId6">
               <a:extLst>
                 <a:ext uri="{28A0092B-C50C-407E-A947-70E740481C1C}">
                   <a14:useLocalDpi xmlns:a14="http://schemas.microsoft.com/office/drawing/2010/main" val="0"/>
@@ -13694,7 +14720,7 @@
             <p:nvPr/>
           </p:nvPicPr>
           <p:blipFill>
-            <a:blip r:embed="rId7" cstate="print">
+            <a:blip r:embed="rId5" cstate="print">
               <a:extLst>
                 <a:ext uri="{28A0092B-C50C-407E-A947-70E740481C1C}">
                   <a14:useLocalDpi xmlns:a14="http://schemas.microsoft.com/office/drawing/2010/main" val="0"/>
@@ -13766,81 +14792,6 @@
       </p:grpSp>
       <p:grpSp>
         <p:nvGrpSpPr>
-          <p:cNvPr id="48" name="Group 47"/>
-          <p:cNvGrpSpPr/>
-          <p:nvPr/>
-        </p:nvGrpSpPr>
-        <p:grpSpPr>
-          <a:xfrm rot="19634447">
-            <a:off x="8525887" y="2406087"/>
-            <a:ext cx="907316" cy="730791"/>
-            <a:chOff x="8433459" y="3513385"/>
-            <a:chExt cx="907316" cy="730791"/>
-          </a:xfrm>
-        </p:grpSpPr>
-        <p:pic>
-          <p:nvPicPr>
-            <p:cNvPr id="19" name="Picture 18">
-              <a:extLst>
-                <a:ext uri="{FF2B5EF4-FFF2-40B4-BE49-F238E27FC236}">
-                  <a16:creationId xmlns:a16="http://schemas.microsoft.com/office/drawing/2014/main" id="{F613C2B3-EFE0-C4C0-711F-B2EE0EB25390}"/>
-                </a:ext>
-              </a:extLst>
-            </p:cNvPr>
-            <p:cNvPicPr>
-              <a:picLocks noChangeAspect="1"/>
-            </p:cNvPicPr>
-            <p:nvPr/>
-          </p:nvPicPr>
-          <p:blipFill>
-            <a:blip r:embed="rId6"/>
-            <a:stretch>
-              <a:fillRect/>
-            </a:stretch>
-          </p:blipFill>
-          <p:spPr>
-            <a:xfrm rot="10800000">
-              <a:off x="8433459" y="3513385"/>
-              <a:ext cx="907316" cy="342842"/>
-            </a:xfrm>
-            <a:prstGeom prst="rect">
-              <a:avLst/>
-            </a:prstGeom>
-          </p:spPr>
-        </p:pic>
-        <p:pic>
-          <p:nvPicPr>
-            <p:cNvPr id="40" name="Picture 39">
-              <a:extLst>
-                <a:ext uri="{FF2B5EF4-FFF2-40B4-BE49-F238E27FC236}">
-                  <a16:creationId xmlns:a16="http://schemas.microsoft.com/office/drawing/2014/main" id="{C4DD3128-F762-F64F-974F-AF6ADA3E0438}"/>
-                </a:ext>
-              </a:extLst>
-            </p:cNvPr>
-            <p:cNvPicPr>
-              <a:picLocks noChangeAspect="1"/>
-            </p:cNvPicPr>
-            <p:nvPr/>
-          </p:nvPicPr>
-          <p:blipFill>
-            <a:blip r:embed="rId6"/>
-            <a:stretch>
-              <a:fillRect/>
-            </a:stretch>
-          </p:blipFill>
-          <p:spPr>
-            <a:xfrm rot="10800000" flipH="1">
-              <a:off x="8433459" y="3901334"/>
-              <a:ext cx="907316" cy="342842"/>
-            </a:xfrm>
-            <a:prstGeom prst="rect">
-              <a:avLst/>
-            </a:prstGeom>
-          </p:spPr>
-        </p:pic>
-      </p:grpSp>
-      <p:grpSp>
-        <p:nvGrpSpPr>
           <p:cNvPr id="33" name="Group 32">
             <a:extLst>
               <a:ext uri="{FF2B5EF4-FFF2-40B4-BE49-F238E27FC236}">
@@ -13853,10 +14804,10 @@
         </p:nvGrpSpPr>
         <p:grpSpPr>
           <a:xfrm>
-            <a:off x="7837562" y="4757389"/>
-            <a:ext cx="1719789" cy="1689407"/>
+            <a:off x="6626205" y="3321701"/>
+            <a:ext cx="1719789" cy="1721306"/>
             <a:chOff x="6979279" y="4486085"/>
-            <a:chExt cx="2000266" cy="1964929"/>
+            <a:chExt cx="2000266" cy="2002030"/>
           </a:xfrm>
         </p:grpSpPr>
         <p:pic>
@@ -13874,7 +14825,7 @@
             <p:nvPr/>
           </p:nvPicPr>
           <p:blipFill>
-            <a:blip r:embed="rId9">
+            <a:blip r:embed="rId7">
               <a:extLst>
                 <a:ext uri="{28A0092B-C50C-407E-A947-70E740481C1C}">
                   <a14:useLocalDpi xmlns:a14="http://schemas.microsoft.com/office/drawing/2010/main" val="0"/>
@@ -13910,7 +14861,7 @@
             <p:nvPr/>
           </p:nvPicPr>
           <p:blipFill>
-            <a:blip r:embed="rId10" cstate="print">
+            <a:blip r:embed="rId8" cstate="print">
               <a:extLst>
                 <a:ext uri="{28A0092B-C50C-407E-A947-70E740481C1C}">
                   <a14:useLocalDpi xmlns:a14="http://schemas.microsoft.com/office/drawing/2010/main" val="0"/>
@@ -13923,7 +14874,7 @@
           </p:blipFill>
           <p:spPr>
             <a:xfrm>
-              <a:off x="7689698" y="5174468"/>
+              <a:off x="7689698" y="5211569"/>
               <a:ext cx="641650" cy="1276546"/>
             </a:xfrm>
             <a:prstGeom prst="rect">
@@ -13940,7 +14891,7 @@
         </p:nvGrpSpPr>
         <p:grpSpPr>
           <a:xfrm>
-            <a:off x="3520426" y="4824567"/>
+            <a:off x="3788548" y="5222797"/>
             <a:ext cx="1307252" cy="1562459"/>
             <a:chOff x="2008240" y="4591624"/>
             <a:chExt cx="1307252" cy="1562459"/>
@@ -13961,7 +14912,7 @@
             <p:nvPr/>
           </p:nvPicPr>
           <p:blipFill>
-            <a:blip r:embed="rId8">
+            <a:blip r:embed="rId6">
               <a:extLst>
                 <a:ext uri="{28A0092B-C50C-407E-A947-70E740481C1C}">
                   <a14:useLocalDpi xmlns:a14="http://schemas.microsoft.com/office/drawing/2010/main" val="0"/>
@@ -14037,7 +14988,7 @@
             <p:nvPr/>
           </p:nvPicPr>
           <p:blipFill>
-            <a:blip r:embed="rId11" cstate="print">
+            <a:blip r:embed="rId9" cstate="print">
               <a:extLst>
                 <a:ext uri="{28A0092B-C50C-407E-A947-70E740481C1C}">
                   <a14:useLocalDpi xmlns:a14="http://schemas.microsoft.com/office/drawing/2010/main" val="0"/>
@@ -14063,15 +15014,15 @@
         <p:nvCxnSpPr>
           <p:cNvPr id="29" name="Straight Arrow Connector 28"/>
           <p:cNvCxnSpPr>
-            <a:stCxn id="12" idx="3"/>
+            <a:cxnSpLocks/>
             <a:endCxn id="13" idx="1"/>
           </p:cNvCxnSpPr>
           <p:nvPr/>
         </p:nvCxnSpPr>
         <p:spPr>
           <a:xfrm>
-            <a:off x="5143468" y="1969707"/>
-            <a:ext cx="4174146" cy="13238"/>
+            <a:off x="2172055" y="1982945"/>
+            <a:ext cx="7198724" cy="0"/>
           </a:xfrm>
           <a:prstGeom prst="straightConnector1">
             <a:avLst/>
@@ -14100,118 +15051,6 @@
       </p:cxnSp>
       <p:pic>
         <p:nvPicPr>
-          <p:cNvPr id="50" name="Picture 49">
-            <a:extLst>
-              <a:ext uri="{FF2B5EF4-FFF2-40B4-BE49-F238E27FC236}">
-                <a16:creationId xmlns:a16="http://schemas.microsoft.com/office/drawing/2014/main" id="{6223D05A-6CC1-3BB0-56EC-E48ED1372BC1}"/>
-              </a:ext>
-            </a:extLst>
-          </p:cNvPr>
-          <p:cNvPicPr>
-            <a:picLocks noChangeAspect="1"/>
-          </p:cNvPicPr>
-          <p:nvPr/>
-        </p:nvPicPr>
-        <p:blipFill>
-          <a:blip r:embed="rId6"/>
-          <a:stretch>
-            <a:fillRect/>
-          </a:stretch>
-        </p:blipFill>
-        <p:spPr>
-          <a:xfrm rot="10800000">
-            <a:off x="5832319" y="2919802"/>
-            <a:ext cx="1146960" cy="342224"/>
-          </a:xfrm>
-          <a:prstGeom prst="rect">
-            <a:avLst/>
-          </a:prstGeom>
-        </p:spPr>
-      </p:pic>
-      <p:pic>
-        <p:nvPicPr>
-          <p:cNvPr id="51" name="Picture 50">
-            <a:extLst>
-              <a:ext uri="{FF2B5EF4-FFF2-40B4-BE49-F238E27FC236}">
-                <a16:creationId xmlns:a16="http://schemas.microsoft.com/office/drawing/2014/main" id="{23FE7613-C3BD-ED6E-0B2C-B1B4C6E9DCA4}"/>
-              </a:ext>
-            </a:extLst>
-          </p:cNvPr>
-          <p:cNvPicPr>
-            <a:picLocks noChangeAspect="1"/>
-          </p:cNvPicPr>
-          <p:nvPr/>
-        </p:nvPicPr>
-        <p:blipFill>
-          <a:blip r:embed="rId6"/>
-          <a:stretch>
-            <a:fillRect/>
-          </a:stretch>
-        </p:blipFill>
-        <p:spPr>
-          <a:xfrm rot="10800000" flipH="1">
-            <a:off x="5843193" y="3365077"/>
-            <a:ext cx="1146962" cy="342224"/>
-          </a:xfrm>
-          <a:prstGeom prst="rect">
-            <a:avLst/>
-          </a:prstGeom>
-        </p:spPr>
-      </p:pic>
-      <p:sp>
-        <p:nvSpPr>
-          <p:cNvPr id="52" name="Rectangle 51">
-            <a:extLst>
-              <a:ext uri="{FF2B5EF4-FFF2-40B4-BE49-F238E27FC236}">
-                <a16:creationId xmlns:a16="http://schemas.microsoft.com/office/drawing/2014/main" id="{529C2627-CD5F-A902-B215-21B7C19F6F64}"/>
-              </a:ext>
-            </a:extLst>
-          </p:cNvPr>
-          <p:cNvSpPr/>
-          <p:nvPr/>
-        </p:nvSpPr>
-        <p:spPr>
-          <a:xfrm>
-            <a:off x="1045986" y="4613032"/>
-            <a:ext cx="10814041" cy="1934054"/>
-          </a:xfrm>
-          <a:prstGeom prst="rect">
-            <a:avLst/>
-          </a:prstGeom>
-          <a:noFill/>
-          <a:ln w="76200">
-            <a:solidFill>
-              <a:schemeClr val="accent1">
-                <a:lumMod val="50000"/>
-              </a:schemeClr>
-            </a:solidFill>
-          </a:ln>
-        </p:spPr>
-        <p:style>
-          <a:lnRef idx="2">
-            <a:schemeClr val="accent6"/>
-          </a:lnRef>
-          <a:fillRef idx="1">
-            <a:schemeClr val="lt1"/>
-          </a:fillRef>
-          <a:effectRef idx="0">
-            <a:schemeClr val="accent6"/>
-          </a:effectRef>
-          <a:fontRef idx="minor">
-            <a:schemeClr val="dk1"/>
-          </a:fontRef>
-        </p:style>
-        <p:txBody>
-          <a:bodyPr rtlCol="0" anchor="ctr"/>
-          <a:lstStyle/>
-          <a:p>
-            <a:pPr algn="ctr"/>
-            <a:endParaRPr lang="en-US"/>
-          </a:p>
-        </p:txBody>
-      </p:sp>
-      <p:pic>
-        <p:nvPicPr>
           <p:cNvPr id="6" name="Picture 5">
             <a:extLst>
               <a:ext uri="{FF2B5EF4-FFF2-40B4-BE49-F238E27FC236}">
@@ -14225,7 +15064,7 @@
           <p:nvPr/>
         </p:nvPicPr>
         <p:blipFill>
-          <a:blip r:embed="rId11" cstate="print">
+          <a:blip r:embed="rId9" cstate="print">
             <a:extLst>
               <a:ext uri="{28A0092B-C50C-407E-A947-70E740481C1C}">
                 <a14:useLocalDpi xmlns:a14="http://schemas.microsoft.com/office/drawing/2010/main" val="0"/>
@@ -14238,7 +15077,7 @@
         </p:blipFill>
         <p:spPr>
           <a:xfrm>
-            <a:off x="10498360" y="5209797"/>
+            <a:off x="9768366" y="3724495"/>
             <a:ext cx="1272141" cy="762426"/>
           </a:xfrm>
           <a:prstGeom prst="rect">
@@ -14260,7 +15099,7 @@
         </p:nvGrpSpPr>
         <p:grpSpPr>
           <a:xfrm>
-            <a:off x="6908555" y="5342834"/>
+            <a:off x="5457862" y="3790714"/>
             <a:ext cx="859777" cy="584775"/>
             <a:chOff x="5722721" y="5018774"/>
             <a:chExt cx="1157836" cy="787499"/>
@@ -14281,7 +15120,7 @@
             <p:nvPr/>
           </p:nvPicPr>
           <p:blipFill>
-            <a:blip r:embed="rId6"/>
+            <a:blip r:embed="rId10"/>
             <a:stretch>
               <a:fillRect/>
             </a:stretch>
@@ -14311,7 +15150,7 @@
             <p:nvPr/>
           </p:nvPicPr>
           <p:blipFill>
-            <a:blip r:embed="rId6"/>
+            <a:blip r:embed="rId10"/>
             <a:stretch>
               <a:fillRect/>
             </a:stretch>
@@ -14319,87 +15158,6 @@
           <p:spPr>
             <a:xfrm rot="10800000" flipH="1">
               <a:off x="5733595" y="5464049"/>
-              <a:ext cx="1146962" cy="342224"/>
-            </a:xfrm>
-            <a:prstGeom prst="rect">
-              <a:avLst/>
-            </a:prstGeom>
-          </p:spPr>
-        </p:pic>
-      </p:grpSp>
-      <p:grpSp>
-        <p:nvGrpSpPr>
-          <p:cNvPr id="30" name="Group 29">
-            <a:extLst>
-              <a:ext uri="{FF2B5EF4-FFF2-40B4-BE49-F238E27FC236}">
-                <a16:creationId xmlns:a16="http://schemas.microsoft.com/office/drawing/2014/main" id="{6D8572C8-F88A-BD91-A979-960C60990E11}"/>
-              </a:ext>
-            </a:extLst>
-          </p:cNvPr>
-          <p:cNvGrpSpPr/>
-          <p:nvPr/>
-        </p:nvGrpSpPr>
-        <p:grpSpPr>
-          <a:xfrm>
-            <a:off x="4729274" y="5320477"/>
-            <a:ext cx="894618" cy="608472"/>
-            <a:chOff x="3243250" y="5007056"/>
-            <a:chExt cx="1157836" cy="787499"/>
-          </a:xfrm>
-        </p:grpSpPr>
-        <p:pic>
-          <p:nvPicPr>
-            <p:cNvPr id="21" name="Picture 20">
-              <a:extLst>
-                <a:ext uri="{FF2B5EF4-FFF2-40B4-BE49-F238E27FC236}">
-                  <a16:creationId xmlns:a16="http://schemas.microsoft.com/office/drawing/2014/main" id="{46673D39-38B0-2E2F-8A17-75DD311248B5}"/>
-                </a:ext>
-              </a:extLst>
-            </p:cNvPr>
-            <p:cNvPicPr>
-              <a:picLocks noChangeAspect="1"/>
-            </p:cNvPicPr>
-            <p:nvPr/>
-          </p:nvPicPr>
-          <p:blipFill>
-            <a:blip r:embed="rId6"/>
-            <a:stretch>
-              <a:fillRect/>
-            </a:stretch>
-          </p:blipFill>
-          <p:spPr>
-            <a:xfrm rot="10800000">
-              <a:off x="3243250" y="5007056"/>
-              <a:ext cx="1146960" cy="342224"/>
-            </a:xfrm>
-            <a:prstGeom prst="rect">
-              <a:avLst/>
-            </a:prstGeom>
-          </p:spPr>
-        </p:pic>
-        <p:pic>
-          <p:nvPicPr>
-            <p:cNvPr id="25" name="Picture 24">
-              <a:extLst>
-                <a:ext uri="{FF2B5EF4-FFF2-40B4-BE49-F238E27FC236}">
-                  <a16:creationId xmlns:a16="http://schemas.microsoft.com/office/drawing/2014/main" id="{DF88766D-1513-B9DF-5308-B9E4B3A67B4F}"/>
-                </a:ext>
-              </a:extLst>
-            </p:cNvPr>
-            <p:cNvPicPr>
-              <a:picLocks noChangeAspect="1"/>
-            </p:cNvPicPr>
-            <p:nvPr/>
-          </p:nvPicPr>
-          <p:blipFill>
-            <a:blip r:embed="rId6"/>
-            <a:stretch>
-              <a:fillRect/>
-            </a:stretch>
-          </p:blipFill>
-          <p:spPr>
-            <a:xfrm rot="10800000" flipH="1">
-              <a:off x="3254124" y="5452331"/>
               <a:ext cx="1146962" cy="342224"/>
             </a:xfrm>
             <a:prstGeom prst="rect">
@@ -14422,7 +15180,7 @@
         </p:nvGrpSpPr>
         <p:grpSpPr>
           <a:xfrm>
-            <a:off x="9571163" y="5342834"/>
+            <a:off x="8662636" y="3752453"/>
             <a:ext cx="859777" cy="584775"/>
             <a:chOff x="5722721" y="5018774"/>
             <a:chExt cx="1157836" cy="787499"/>
@@ -14443,7 +15201,7 @@
             <p:nvPr/>
           </p:nvPicPr>
           <p:blipFill>
-            <a:blip r:embed="rId6"/>
+            <a:blip r:embed="rId10"/>
             <a:stretch>
               <a:fillRect/>
             </a:stretch>
@@ -14473,7 +15231,7 @@
             <p:nvPr/>
           </p:nvPicPr>
           <p:blipFill>
-            <a:blip r:embed="rId6"/>
+            <a:blip r:embed="rId10"/>
             <a:stretch>
               <a:fillRect/>
             </a:stretch>
@@ -14503,7 +15261,7 @@
         </p:nvGrpSpPr>
         <p:grpSpPr>
           <a:xfrm>
-            <a:off x="1261827" y="4832243"/>
+            <a:off x="1541128" y="3354968"/>
             <a:ext cx="1265206" cy="1562459"/>
             <a:chOff x="6698461" y="1494327"/>
             <a:chExt cx="1265206" cy="1562459"/>
@@ -14524,7 +15282,7 @@
             <p:nvPr/>
           </p:nvPicPr>
           <p:blipFill>
-            <a:blip r:embed="rId8">
+            <a:blip r:embed="rId6">
               <a:extLst>
                 <a:ext uri="{28A0092B-C50C-407E-A947-70E740481C1C}">
                   <a14:useLocalDpi xmlns:a14="http://schemas.microsoft.com/office/drawing/2010/main" val="0"/>
@@ -14560,7 +15318,7 @@
             <p:nvPr/>
           </p:nvPicPr>
           <p:blipFill>
-            <a:blip r:embed="rId7" cstate="print">
+            <a:blip r:embed="rId5" cstate="print">
               <a:extLst>
                 <a:ext uri="{28A0092B-C50C-407E-A947-70E740481C1C}">
                   <a14:useLocalDpi xmlns:a14="http://schemas.microsoft.com/office/drawing/2010/main" val="0"/>
@@ -14653,45 +15411,15 @@
           <p:nvPr/>
         </p:nvPicPr>
         <p:blipFill>
-          <a:blip r:embed="rId6"/>
+          <a:blip r:embed="rId10"/>
           <a:stretch>
             <a:fillRect/>
           </a:stretch>
         </p:blipFill>
         <p:spPr>
           <a:xfrm rot="10800000" flipH="1">
-            <a:off x="2565206" y="5481260"/>
+            <a:off x="2832962" y="4003986"/>
             <a:ext cx="886216" cy="264424"/>
-          </a:xfrm>
-          <a:prstGeom prst="rect">
-            <a:avLst/>
-          </a:prstGeom>
-        </p:spPr>
-      </p:pic>
-      <p:pic>
-        <p:nvPicPr>
-          <p:cNvPr id="62" name="Picture 61">
-            <a:extLst>
-              <a:ext uri="{FF2B5EF4-FFF2-40B4-BE49-F238E27FC236}">
-                <a16:creationId xmlns:a16="http://schemas.microsoft.com/office/drawing/2014/main" id="{A9B52C45-A0B3-59E4-2B9C-FEF6C17708C6}"/>
-              </a:ext>
-            </a:extLst>
-          </p:cNvPr>
-          <p:cNvPicPr>
-            <a:picLocks noChangeAspect="1"/>
-          </p:cNvPicPr>
-          <p:nvPr/>
-        </p:nvPicPr>
-        <p:blipFill>
-          <a:blip r:embed="rId6"/>
-          <a:stretch>
-            <a:fillRect/>
-          </a:stretch>
-        </p:blipFill>
-        <p:spPr>
-          <a:xfrm rot="13040518" flipH="1">
-            <a:off x="1536455" y="4239120"/>
-            <a:ext cx="715950" cy="213621"/>
           </a:xfrm>
           <a:prstGeom prst="rect">
             <a:avLst/>
@@ -14732,6 +15460,212 @@
           </a:p>
         </p:txBody>
       </p:sp>
+      <p:cxnSp>
+        <p:nvCxnSpPr>
+          <p:cNvPr id="38" name="Straight Arrow Connector 37">
+            <a:extLst>
+              <a:ext uri="{FF2B5EF4-FFF2-40B4-BE49-F238E27FC236}">
+                <a16:creationId xmlns:a16="http://schemas.microsoft.com/office/drawing/2014/main" id="{6596FDAE-0869-AD91-AC57-FE72C146D4AE}"/>
+              </a:ext>
+            </a:extLst>
+          </p:cNvPr>
+          <p:cNvCxnSpPr>
+            <a:cxnSpLocks/>
+          </p:cNvCxnSpPr>
+          <p:nvPr/>
+        </p:nvCxnSpPr>
+        <p:spPr>
+          <a:xfrm flipH="1" flipV="1">
+            <a:off x="2172055" y="2533809"/>
+            <a:ext cx="7198724" cy="23999"/>
+          </a:xfrm>
+          <a:prstGeom prst="straightConnector1">
+            <a:avLst/>
+          </a:prstGeom>
+          <a:ln w="57150">
+            <a:solidFill>
+              <a:srgbClr val="4D4D4E"/>
+            </a:solidFill>
+            <a:tailEnd type="triangle"/>
+          </a:ln>
+        </p:spPr>
+        <p:style>
+          <a:lnRef idx="1">
+            <a:schemeClr val="accent1"/>
+          </a:lnRef>
+          <a:fillRef idx="0">
+            <a:schemeClr val="accent1"/>
+          </a:fillRef>
+          <a:effectRef idx="0">
+            <a:schemeClr val="accent1"/>
+          </a:effectRef>
+          <a:fontRef idx="minor">
+            <a:schemeClr val="tx1"/>
+          </a:fontRef>
+        </p:style>
+      </p:cxnSp>
+      <p:cxnSp>
+        <p:nvCxnSpPr>
+          <p:cNvPr id="64" name="Straight Arrow Connector 63">
+            <a:extLst>
+              <a:ext uri="{FF2B5EF4-FFF2-40B4-BE49-F238E27FC236}">
+                <a16:creationId xmlns:a16="http://schemas.microsoft.com/office/drawing/2014/main" id="{E1721875-13FE-66BF-4A7E-40203F0A5786}"/>
+              </a:ext>
+            </a:extLst>
+          </p:cNvPr>
+          <p:cNvCxnSpPr>
+            <a:cxnSpLocks/>
+          </p:cNvCxnSpPr>
+          <p:nvPr/>
+        </p:nvCxnSpPr>
+        <p:spPr>
+          <a:xfrm>
+            <a:off x="4048318" y="4878994"/>
+            <a:ext cx="0" cy="330803"/>
+          </a:xfrm>
+          <a:prstGeom prst="straightConnector1">
+            <a:avLst/>
+          </a:prstGeom>
+          <a:ln w="57150">
+            <a:solidFill>
+              <a:srgbClr val="4D4D4E"/>
+            </a:solidFill>
+            <a:tailEnd type="triangle"/>
+          </a:ln>
+        </p:spPr>
+        <p:style>
+          <a:lnRef idx="1">
+            <a:schemeClr val="accent1"/>
+          </a:lnRef>
+          <a:fillRef idx="0">
+            <a:schemeClr val="accent1"/>
+          </a:fillRef>
+          <a:effectRef idx="0">
+            <a:schemeClr val="accent1"/>
+          </a:effectRef>
+          <a:fontRef idx="minor">
+            <a:schemeClr val="tx1"/>
+          </a:fontRef>
+        </p:style>
+      </p:cxnSp>
+      <p:cxnSp>
+        <p:nvCxnSpPr>
+          <p:cNvPr id="68" name="Straight Arrow Connector 67">
+            <a:extLst>
+              <a:ext uri="{FF2B5EF4-FFF2-40B4-BE49-F238E27FC236}">
+                <a16:creationId xmlns:a16="http://schemas.microsoft.com/office/drawing/2014/main" id="{5C669222-507E-4E17-CA01-91029B54BF4A}"/>
+              </a:ext>
+            </a:extLst>
+          </p:cNvPr>
+          <p:cNvCxnSpPr>
+            <a:cxnSpLocks/>
+          </p:cNvCxnSpPr>
+          <p:nvPr/>
+        </p:nvCxnSpPr>
+        <p:spPr>
+          <a:xfrm flipV="1">
+            <a:off x="4611382" y="4894731"/>
+            <a:ext cx="0" cy="359965"/>
+          </a:xfrm>
+          <a:prstGeom prst="straightConnector1">
+            <a:avLst/>
+          </a:prstGeom>
+          <a:ln w="57150">
+            <a:solidFill>
+              <a:srgbClr val="4D4D4E"/>
+            </a:solidFill>
+            <a:tailEnd type="triangle"/>
+          </a:ln>
+        </p:spPr>
+        <p:style>
+          <a:lnRef idx="1">
+            <a:schemeClr val="accent1"/>
+          </a:lnRef>
+          <a:fillRef idx="0">
+            <a:schemeClr val="accent1"/>
+          </a:fillRef>
+          <a:effectRef idx="0">
+            <a:schemeClr val="accent1"/>
+          </a:effectRef>
+          <a:fontRef idx="minor">
+            <a:schemeClr val="tx1"/>
+          </a:fontRef>
+        </p:style>
+      </p:cxnSp>
+      <p:cxnSp>
+        <p:nvCxnSpPr>
+          <p:cNvPr id="71" name="Straight Arrow Connector 70">
+            <a:extLst>
+              <a:ext uri="{FF2B5EF4-FFF2-40B4-BE49-F238E27FC236}">
+                <a16:creationId xmlns:a16="http://schemas.microsoft.com/office/drawing/2014/main" id="{5156E54C-61DF-CCD3-D68C-223357D82704}"/>
+              </a:ext>
+            </a:extLst>
+          </p:cNvPr>
+          <p:cNvCxnSpPr>
+            <a:cxnSpLocks/>
+          </p:cNvCxnSpPr>
+          <p:nvPr/>
+        </p:nvCxnSpPr>
+        <p:spPr>
+          <a:xfrm>
+            <a:off x="1383036" y="3024165"/>
+            <a:ext cx="491305" cy="330803"/>
+          </a:xfrm>
+          <a:prstGeom prst="straightConnector1">
+            <a:avLst/>
+          </a:prstGeom>
+          <a:ln w="57150">
+            <a:solidFill>
+              <a:srgbClr val="4D4D4E"/>
+            </a:solidFill>
+            <a:tailEnd type="triangle"/>
+          </a:ln>
+        </p:spPr>
+        <p:style>
+          <a:lnRef idx="1">
+            <a:schemeClr val="accent1"/>
+          </a:lnRef>
+          <a:fillRef idx="0">
+            <a:schemeClr val="accent1"/>
+          </a:fillRef>
+          <a:effectRef idx="0">
+            <a:schemeClr val="accent1"/>
+          </a:effectRef>
+          <a:fontRef idx="minor">
+            <a:schemeClr val="tx1"/>
+          </a:fontRef>
+        </p:style>
+      </p:cxnSp>
+      <p:pic>
+        <p:nvPicPr>
+          <p:cNvPr id="31" name="Picture 30">
+            <a:extLst>
+              <a:ext uri="{FF2B5EF4-FFF2-40B4-BE49-F238E27FC236}">
+                <a16:creationId xmlns:a16="http://schemas.microsoft.com/office/drawing/2014/main" id="{741D210E-BC0D-1B12-B66D-7FBE430C7A2B}"/>
+              </a:ext>
+            </a:extLst>
+          </p:cNvPr>
+          <p:cNvPicPr>
+            <a:picLocks noChangeAspect="1"/>
+          </p:cNvPicPr>
+          <p:nvPr/>
+        </p:nvPicPr>
+        <p:blipFill>
+          <a:blip r:embed="rId10"/>
+          <a:stretch>
+            <a:fillRect/>
+          </a:stretch>
+        </p:blipFill>
+        <p:spPr>
+          <a:xfrm rot="12680291" flipH="1">
+            <a:off x="2817148" y="5020156"/>
+            <a:ext cx="886216" cy="264424"/>
+          </a:xfrm>
+          <a:prstGeom prst="rect">
+            <a:avLst/>
+          </a:prstGeom>
+        </p:spPr>
+      </p:pic>
     </p:spTree>
     <p:extLst>
       <p:ext uri="{BB962C8B-B14F-4D97-AF65-F5344CB8AC3E}">

</xml_diff>

<commit_message>
Refactored bibliographical links to meet standarts. Minor refactoring in presentation.
</commit_message>
<xml_diff>
--- a/Presentation/NMSTU_Presentation.pptx
+++ b/Presentation/NMSTU_Presentation.pptx
@@ -227,7 +227,7 @@
           <a:p>
             <a:fld id="{1E26F5DA-879A-4326-91CA-0B965521B3A2}" type="datetimeFigureOut">
               <a:rPr lang="ru-RU" smtClean="0"/>
-              <a:t>14.06.2025</a:t>
+              <a:t>17.06.2025</a:t>
             </a:fld>
             <a:endParaRPr lang="ru-RU"/>
           </a:p>
@@ -404,7 +404,7 @@
           <a:p>
             <a:fld id="{536AE87B-970E-4FB6-80B1-2A90D9E8F8EA}" type="datetimeFigureOut">
               <a:rPr lang="en-US" smtClean="0"/>
-              <a:t>6/14/2025</a:t>
+              <a:t>6/17/2025</a:t>
             </a:fld>
             <a:endParaRPr lang="en-US"/>
           </a:p>
@@ -2673,7 +2673,7 @@
           <a:p>
             <a:fld id="{2BA16B55-A083-400A-A53D-83CD673D7AB5}" type="datetime1">
               <a:rPr lang="ru-RU" smtClean="0"/>
-              <a:t>14.06.2025</a:t>
+              <a:t>17.06.2025</a:t>
             </a:fld>
             <a:endParaRPr lang="ru-RU"/>
           </a:p>
@@ -2846,7 +2846,7 @@
           <a:p>
             <a:fld id="{E2DC6F81-D76A-46BC-82B2-E452FF2CA9C5}" type="datetime1">
               <a:rPr lang="ru-RU" smtClean="0"/>
-              <a:t>14.06.2025</a:t>
+              <a:t>17.06.2025</a:t>
             </a:fld>
             <a:endParaRPr lang="ru-RU"/>
           </a:p>
@@ -3024,7 +3024,7 @@
           <a:p>
             <a:fld id="{48484A5D-C6EA-476C-B204-F5D11ADE9E0C}" type="datetime1">
               <a:rPr lang="ru-RU" smtClean="0"/>
-              <a:t>14.06.2025</a:t>
+              <a:t>17.06.2025</a:t>
             </a:fld>
             <a:endParaRPr lang="ru-RU"/>
           </a:p>
@@ -3192,7 +3192,7 @@
           <a:p>
             <a:fld id="{EB2C1C20-8488-406D-BEC1-3EBBFF7F0C88}" type="datetime1">
               <a:rPr lang="ru-RU" smtClean="0"/>
-              <a:t>14.06.2025</a:t>
+              <a:t>17.06.2025</a:t>
             </a:fld>
             <a:endParaRPr lang="ru-RU"/>
           </a:p>
@@ -3442,7 +3442,7 @@
           <a:p>
             <a:fld id="{B64FA3E3-1B09-48E4-B3AA-C803D5E16A77}" type="datetime1">
               <a:rPr lang="ru-RU" smtClean="0"/>
-              <a:t>14.06.2025</a:t>
+              <a:t>17.06.2025</a:t>
             </a:fld>
             <a:endParaRPr lang="ru-RU"/>
           </a:p>
@@ -3671,7 +3671,7 @@
           <a:p>
             <a:fld id="{62A63F76-3CA2-4748-A29D-2AB22D0BEB5B}" type="datetime1">
               <a:rPr lang="ru-RU" smtClean="0"/>
-              <a:t>14.06.2025</a:t>
+              <a:t>17.06.2025</a:t>
             </a:fld>
             <a:endParaRPr lang="ru-RU"/>
           </a:p>
@@ -4035,7 +4035,7 @@
           <a:p>
             <a:fld id="{A544ED6F-8BE4-4669-B0A3-175B5B131B11}" type="datetime1">
               <a:rPr lang="ru-RU" smtClean="0"/>
-              <a:t>14.06.2025</a:t>
+              <a:t>17.06.2025</a:t>
             </a:fld>
             <a:endParaRPr lang="ru-RU"/>
           </a:p>
@@ -4157,7 +4157,7 @@
           <a:p>
             <a:fld id="{4737DC02-F460-4FDC-95DB-DC6352A1EE94}" type="datetime1">
               <a:rPr lang="ru-RU" smtClean="0"/>
-              <a:t>14.06.2025</a:t>
+              <a:t>17.06.2025</a:t>
             </a:fld>
             <a:endParaRPr lang="ru-RU"/>
           </a:p>
@@ -4257,7 +4257,7 @@
           <a:p>
             <a:fld id="{6EB7CF50-D4ED-4F06-9251-EFB3C02E6C46}" type="datetime1">
               <a:rPr lang="ru-RU" smtClean="0"/>
-              <a:t>14.06.2025</a:t>
+              <a:t>17.06.2025</a:t>
             </a:fld>
             <a:endParaRPr lang="ru-RU"/>
           </a:p>
@@ -4537,7 +4537,7 @@
           <a:p>
             <a:fld id="{FA48FBA7-1AD2-4D2B-BCA1-27950A33E466}" type="datetime1">
               <a:rPr lang="ru-RU" smtClean="0"/>
-              <a:t>14.06.2025</a:t>
+              <a:t>17.06.2025</a:t>
             </a:fld>
             <a:endParaRPr lang="ru-RU"/>
           </a:p>
@@ -4789,7 +4789,7 @@
           <a:p>
             <a:fld id="{E233C2C1-A2CA-49E6-9101-CA7FFB180E53}" type="datetime1">
               <a:rPr lang="ru-RU" smtClean="0"/>
-              <a:t>14.06.2025</a:t>
+              <a:t>17.06.2025</a:t>
             </a:fld>
             <a:endParaRPr lang="ru-RU"/>
           </a:p>
@@ -5000,7 +5000,7 @@
           <a:p>
             <a:fld id="{642239AA-F603-409E-949B-21A349D872FF}" type="datetime1">
               <a:rPr lang="ru-RU" smtClean="0"/>
-              <a:t>14.06.2025</a:t>
+              <a:t>17.06.2025</a:t>
             </a:fld>
             <a:endParaRPr lang="ru-RU"/>
           </a:p>
@@ -5663,7 +5663,7 @@
                 </a:solidFill>
                 <a:latin typeface="Century Gothic" panose="020B0502020202020204" pitchFamily="34" charset="0"/>
               </a:rPr>
-              <a:t>Министерство образования и науки Российской Федерации</a:t>
+              <a:t>Министерство науки и высшего образования Российской Федерации</a:t>
             </a:r>
           </a:p>
           <a:p>
@@ -7716,87 +7716,6 @@
           </p:spPr>
         </p:pic>
       </p:grpSp>
-      <p:grpSp>
-        <p:nvGrpSpPr>
-          <p:cNvPr id="32" name="Group 31">
-            <a:extLst>
-              <a:ext uri="{FF2B5EF4-FFF2-40B4-BE49-F238E27FC236}">
-                <a16:creationId xmlns:a16="http://schemas.microsoft.com/office/drawing/2014/main" id="{4B469F37-80B1-DB06-5F60-D1F07695E31F}"/>
-              </a:ext>
-            </a:extLst>
-          </p:cNvPr>
-          <p:cNvGrpSpPr/>
-          <p:nvPr/>
-        </p:nvGrpSpPr>
-        <p:grpSpPr>
-          <a:xfrm rot="18994099">
-            <a:off x="6937248" y="3677414"/>
-            <a:ext cx="1860339" cy="993213"/>
-            <a:chOff x="6743121" y="2762420"/>
-            <a:chExt cx="1486171" cy="885465"/>
-          </a:xfrm>
-        </p:grpSpPr>
-        <p:pic>
-          <p:nvPicPr>
-            <p:cNvPr id="17" name="Picture 16">
-              <a:extLst>
-                <a:ext uri="{FF2B5EF4-FFF2-40B4-BE49-F238E27FC236}">
-                  <a16:creationId xmlns:a16="http://schemas.microsoft.com/office/drawing/2014/main" id="{6A685DFE-FB4D-4EE7-4A84-911F703F1318}"/>
-                </a:ext>
-              </a:extLst>
-            </p:cNvPr>
-            <p:cNvPicPr>
-              <a:picLocks noChangeAspect="1"/>
-            </p:cNvPicPr>
-            <p:nvPr/>
-          </p:nvPicPr>
-          <p:blipFill>
-            <a:blip r:embed="rId7"/>
-            <a:stretch>
-              <a:fillRect/>
-            </a:stretch>
-          </p:blipFill>
-          <p:spPr>
-            <a:xfrm rot="10800000">
-              <a:off x="6743121" y="2762420"/>
-              <a:ext cx="1475297" cy="440190"/>
-            </a:xfrm>
-            <a:prstGeom prst="rect">
-              <a:avLst/>
-            </a:prstGeom>
-          </p:spPr>
-        </p:pic>
-        <p:pic>
-          <p:nvPicPr>
-            <p:cNvPr id="18" name="Picture 17">
-              <a:extLst>
-                <a:ext uri="{FF2B5EF4-FFF2-40B4-BE49-F238E27FC236}">
-                  <a16:creationId xmlns:a16="http://schemas.microsoft.com/office/drawing/2014/main" id="{55E88F04-3D18-0261-429A-930D0E17F431}"/>
-                </a:ext>
-              </a:extLst>
-            </p:cNvPr>
-            <p:cNvPicPr>
-              <a:picLocks noChangeAspect="1"/>
-            </p:cNvPicPr>
-            <p:nvPr/>
-          </p:nvPicPr>
-          <p:blipFill>
-            <a:blip r:embed="rId7"/>
-            <a:stretch>
-              <a:fillRect/>
-            </a:stretch>
-          </p:blipFill>
-          <p:spPr>
-            <a:xfrm rot="10800000" flipH="1">
-              <a:off x="6753995" y="3207695"/>
-              <a:ext cx="1475297" cy="440190"/>
-            </a:xfrm>
-            <a:prstGeom prst="rect">
-              <a:avLst/>
-            </a:prstGeom>
-          </p:spPr>
-        </p:pic>
-      </p:grpSp>
       <p:pic>
         <p:nvPicPr>
           <p:cNvPr id="19" name="Picture 18">
@@ -7833,87 +7752,6 @@
           </a:prstGeom>
         </p:spPr>
       </p:pic>
-      <p:grpSp>
-        <p:nvGrpSpPr>
-          <p:cNvPr id="27" name="Group 26">
-            <a:extLst>
-              <a:ext uri="{FF2B5EF4-FFF2-40B4-BE49-F238E27FC236}">
-                <a16:creationId xmlns:a16="http://schemas.microsoft.com/office/drawing/2014/main" id="{3D6BF4B3-441C-FF17-2555-CD6E50C18946}"/>
-              </a:ext>
-            </a:extLst>
-          </p:cNvPr>
-          <p:cNvGrpSpPr/>
-          <p:nvPr/>
-        </p:nvGrpSpPr>
-        <p:grpSpPr>
-          <a:xfrm rot="10800000">
-            <a:off x="4937098" y="1688513"/>
-            <a:ext cx="1959959" cy="800421"/>
-            <a:chOff x="2071940" y="4941171"/>
-            <a:chExt cx="1486171" cy="885465"/>
-          </a:xfrm>
-        </p:grpSpPr>
-        <p:pic>
-          <p:nvPicPr>
-            <p:cNvPr id="25" name="Picture 24">
-              <a:extLst>
-                <a:ext uri="{FF2B5EF4-FFF2-40B4-BE49-F238E27FC236}">
-                  <a16:creationId xmlns:a16="http://schemas.microsoft.com/office/drawing/2014/main" id="{ADC03664-4CC0-C642-F3DA-25A8281D12AA}"/>
-                </a:ext>
-              </a:extLst>
-            </p:cNvPr>
-            <p:cNvPicPr>
-              <a:picLocks noChangeAspect="1"/>
-            </p:cNvPicPr>
-            <p:nvPr/>
-          </p:nvPicPr>
-          <p:blipFill>
-            <a:blip r:embed="rId7"/>
-            <a:stretch>
-              <a:fillRect/>
-            </a:stretch>
-          </p:blipFill>
-          <p:spPr>
-            <a:xfrm rot="10800000">
-              <a:off x="2071940" y="4941171"/>
-              <a:ext cx="1475297" cy="440190"/>
-            </a:xfrm>
-            <a:prstGeom prst="rect">
-              <a:avLst/>
-            </a:prstGeom>
-          </p:spPr>
-        </p:pic>
-        <p:pic>
-          <p:nvPicPr>
-            <p:cNvPr id="26" name="Picture 25">
-              <a:extLst>
-                <a:ext uri="{FF2B5EF4-FFF2-40B4-BE49-F238E27FC236}">
-                  <a16:creationId xmlns:a16="http://schemas.microsoft.com/office/drawing/2014/main" id="{CDCFED0A-0F27-87E2-FAC1-FBBAFB14AC6D}"/>
-                </a:ext>
-              </a:extLst>
-            </p:cNvPr>
-            <p:cNvPicPr>
-              <a:picLocks noChangeAspect="1"/>
-            </p:cNvPicPr>
-            <p:nvPr/>
-          </p:nvPicPr>
-          <p:blipFill>
-            <a:blip r:embed="rId7"/>
-            <a:stretch>
-              <a:fillRect/>
-            </a:stretch>
-          </p:blipFill>
-          <p:spPr>
-            <a:xfrm rot="10800000" flipH="1">
-              <a:off x="2082814" y="5386446"/>
-              <a:ext cx="1475297" cy="440190"/>
-            </a:xfrm>
-            <a:prstGeom prst="rect">
-              <a:avLst/>
-            </a:prstGeom>
-          </p:spPr>
-        </p:pic>
-      </p:grpSp>
       <p:pic>
         <p:nvPicPr>
           <p:cNvPr id="28" name="Picture 27">
@@ -8261,6 +8099,271 @@
           </p:spPr>
         </p:pic>
       </p:grpSp>
+      <p:sp>
+        <p:nvSpPr>
+          <p:cNvPr id="20" name="Arrow: Right 19">
+            <a:extLst>
+              <a:ext uri="{FF2B5EF4-FFF2-40B4-BE49-F238E27FC236}">
+                <a16:creationId xmlns:a16="http://schemas.microsoft.com/office/drawing/2014/main" id="{19317591-C0BE-C8C4-B732-F6EB5765880F}"/>
+              </a:ext>
+            </a:extLst>
+          </p:cNvPr>
+          <p:cNvSpPr/>
+          <p:nvPr/>
+        </p:nvSpPr>
+        <p:spPr>
+          <a:xfrm>
+            <a:off x="4154385" y="1600843"/>
+            <a:ext cx="3538502" cy="484632"/>
+          </a:xfrm>
+          <a:prstGeom prst="rightArrow">
+            <a:avLst/>
+          </a:prstGeom>
+          <a:noFill/>
+          <a:ln w="28575">
+            <a:solidFill>
+              <a:schemeClr val="tx1">
+                <a:lumMod val="65000"/>
+                <a:lumOff val="35000"/>
+              </a:schemeClr>
+            </a:solidFill>
+          </a:ln>
+        </p:spPr>
+        <p:style>
+          <a:lnRef idx="2">
+            <a:schemeClr val="accent1">
+              <a:shade val="15000"/>
+            </a:schemeClr>
+          </a:lnRef>
+          <a:fillRef idx="1">
+            <a:schemeClr val="accent1"/>
+          </a:fillRef>
+          <a:effectRef idx="0">
+            <a:schemeClr val="accent1"/>
+          </a:effectRef>
+          <a:fontRef idx="minor">
+            <a:schemeClr val="lt1"/>
+          </a:fontRef>
+        </p:style>
+        <p:txBody>
+          <a:bodyPr rtlCol="0" anchor="ctr"/>
+          <a:lstStyle/>
+          <a:p>
+            <a:pPr algn="ctr"/>
+            <a:endParaRPr lang="ru-RU">
+              <a:ln w="57150">
+                <a:solidFill>
+                  <a:schemeClr val="tx1"/>
+                </a:solidFill>
+              </a:ln>
+            </a:endParaRPr>
+          </a:p>
+        </p:txBody>
+      </p:sp>
+      <p:sp>
+        <p:nvSpPr>
+          <p:cNvPr id="21" name="Arrow: Right 20">
+            <a:extLst>
+              <a:ext uri="{FF2B5EF4-FFF2-40B4-BE49-F238E27FC236}">
+                <a16:creationId xmlns:a16="http://schemas.microsoft.com/office/drawing/2014/main" id="{54CD1BC5-655A-647E-A20E-77ED616B1451}"/>
+              </a:ext>
+            </a:extLst>
+          </p:cNvPr>
+          <p:cNvSpPr/>
+          <p:nvPr/>
+        </p:nvSpPr>
+        <p:spPr>
+          <a:xfrm rot="10800000">
+            <a:off x="4134505" y="2092199"/>
+            <a:ext cx="3538502" cy="484632"/>
+          </a:xfrm>
+          <a:prstGeom prst="rightArrow">
+            <a:avLst/>
+          </a:prstGeom>
+          <a:noFill/>
+          <a:ln w="28575">
+            <a:solidFill>
+              <a:schemeClr val="tx1">
+                <a:lumMod val="65000"/>
+                <a:lumOff val="35000"/>
+              </a:schemeClr>
+            </a:solidFill>
+          </a:ln>
+        </p:spPr>
+        <p:style>
+          <a:lnRef idx="2">
+            <a:schemeClr val="accent1">
+              <a:shade val="15000"/>
+            </a:schemeClr>
+          </a:lnRef>
+          <a:fillRef idx="1">
+            <a:schemeClr val="accent1"/>
+          </a:fillRef>
+          <a:effectRef idx="0">
+            <a:schemeClr val="accent1"/>
+          </a:effectRef>
+          <a:fontRef idx="minor">
+            <a:schemeClr val="lt1"/>
+          </a:fontRef>
+        </p:style>
+        <p:txBody>
+          <a:bodyPr rtlCol="0" anchor="ctr"/>
+          <a:lstStyle/>
+          <a:p>
+            <a:pPr algn="ctr"/>
+            <a:endParaRPr lang="ru-RU">
+              <a:ln w="57150">
+                <a:solidFill>
+                  <a:schemeClr val="tx1"/>
+                </a:solidFill>
+              </a:ln>
+            </a:endParaRPr>
+          </a:p>
+        </p:txBody>
+      </p:sp>
+      <p:grpSp>
+        <p:nvGrpSpPr>
+          <p:cNvPr id="24" name="Group 23">
+            <a:extLst>
+              <a:ext uri="{FF2B5EF4-FFF2-40B4-BE49-F238E27FC236}">
+                <a16:creationId xmlns:a16="http://schemas.microsoft.com/office/drawing/2014/main" id="{CD760113-C4D4-23B8-5AD9-5EC7DAFB75DA}"/>
+              </a:ext>
+            </a:extLst>
+          </p:cNvPr>
+          <p:cNvGrpSpPr/>
+          <p:nvPr/>
+        </p:nvGrpSpPr>
+        <p:grpSpPr>
+          <a:xfrm rot="18737432">
+            <a:off x="6973287" y="3756803"/>
+            <a:ext cx="1939558" cy="764973"/>
+            <a:chOff x="7497459" y="3494533"/>
+            <a:chExt cx="3558382" cy="975988"/>
+          </a:xfrm>
+        </p:grpSpPr>
+        <p:sp>
+          <p:nvSpPr>
+            <p:cNvPr id="22" name="Arrow: Right 21">
+              <a:extLst>
+                <a:ext uri="{FF2B5EF4-FFF2-40B4-BE49-F238E27FC236}">
+                  <a16:creationId xmlns:a16="http://schemas.microsoft.com/office/drawing/2014/main" id="{41F3CD33-7DDD-229F-6EA1-CA70F01DB346}"/>
+                </a:ext>
+              </a:extLst>
+            </p:cNvPr>
+            <p:cNvSpPr/>
+            <p:nvPr/>
+          </p:nvSpPr>
+          <p:spPr>
+            <a:xfrm>
+              <a:off x="7517339" y="3494533"/>
+              <a:ext cx="3538502" cy="484632"/>
+            </a:xfrm>
+            <a:prstGeom prst="rightArrow">
+              <a:avLst/>
+            </a:prstGeom>
+            <a:noFill/>
+            <a:ln w="28575">
+              <a:solidFill>
+                <a:schemeClr val="tx1">
+                  <a:lumMod val="65000"/>
+                  <a:lumOff val="35000"/>
+                </a:schemeClr>
+              </a:solidFill>
+            </a:ln>
+          </p:spPr>
+          <p:style>
+            <a:lnRef idx="2">
+              <a:schemeClr val="accent1">
+                <a:shade val="15000"/>
+              </a:schemeClr>
+            </a:lnRef>
+            <a:fillRef idx="1">
+              <a:schemeClr val="accent1"/>
+            </a:fillRef>
+            <a:effectRef idx="0">
+              <a:schemeClr val="accent1"/>
+            </a:effectRef>
+            <a:fontRef idx="minor">
+              <a:schemeClr val="lt1"/>
+            </a:fontRef>
+          </p:style>
+          <p:txBody>
+            <a:bodyPr rtlCol="0" anchor="ctr"/>
+            <a:lstStyle/>
+            <a:p>
+              <a:pPr algn="ctr"/>
+              <a:endParaRPr lang="ru-RU">
+                <a:ln w="57150">
+                  <a:solidFill>
+                    <a:schemeClr val="tx1"/>
+                  </a:solidFill>
+                </a:ln>
+              </a:endParaRPr>
+            </a:p>
+          </p:txBody>
+        </p:sp>
+        <p:sp>
+          <p:nvSpPr>
+            <p:cNvPr id="23" name="Arrow: Right 22">
+              <a:extLst>
+                <a:ext uri="{FF2B5EF4-FFF2-40B4-BE49-F238E27FC236}">
+                  <a16:creationId xmlns:a16="http://schemas.microsoft.com/office/drawing/2014/main" id="{31C42D58-2968-FA74-D035-DEEA2AF327B1}"/>
+                </a:ext>
+              </a:extLst>
+            </p:cNvPr>
+            <p:cNvSpPr/>
+            <p:nvPr/>
+          </p:nvSpPr>
+          <p:spPr>
+            <a:xfrm rot="10800000">
+              <a:off x="7497459" y="3985889"/>
+              <a:ext cx="3538502" cy="484632"/>
+            </a:xfrm>
+            <a:prstGeom prst="rightArrow">
+              <a:avLst/>
+            </a:prstGeom>
+            <a:noFill/>
+            <a:ln w="28575">
+              <a:solidFill>
+                <a:schemeClr val="tx1">
+                  <a:lumMod val="65000"/>
+                  <a:lumOff val="35000"/>
+                </a:schemeClr>
+              </a:solidFill>
+            </a:ln>
+          </p:spPr>
+          <p:style>
+            <a:lnRef idx="2">
+              <a:schemeClr val="accent1">
+                <a:shade val="15000"/>
+              </a:schemeClr>
+            </a:lnRef>
+            <a:fillRef idx="1">
+              <a:schemeClr val="accent1"/>
+            </a:fillRef>
+            <a:effectRef idx="0">
+              <a:schemeClr val="accent1"/>
+            </a:effectRef>
+            <a:fontRef idx="minor">
+              <a:schemeClr val="lt1"/>
+            </a:fontRef>
+          </p:style>
+          <p:txBody>
+            <a:bodyPr rtlCol="0" anchor="ctr"/>
+            <a:lstStyle/>
+            <a:p>
+              <a:pPr algn="ctr"/>
+              <a:endParaRPr lang="ru-RU">
+                <a:ln w="57150">
+                  <a:solidFill>
+                    <a:schemeClr val="tx1"/>
+                  </a:solidFill>
+                </a:ln>
+              </a:endParaRPr>
+            </a:p>
+          </p:txBody>
+        </p:sp>
+      </p:grpSp>
     </p:spTree>
     <p:extLst>
       <p:ext uri="{BB962C8B-B14F-4D97-AF65-F5344CB8AC3E}">
@@ -8573,23 +8676,7 @@
                 <a:ea typeface="Calibri" panose="020F0502020204030204" pitchFamily="34" charset="0"/>
                 <a:cs typeface="Times New Roman" panose="02020603050405020304" pitchFamily="18" charset="0"/>
               </a:rPr>
-              <a:t>даст компании ООО «</a:t>
-            </a:r>
-            <a:r>
-              <a:rPr lang="en-US" altLang="ru-RU" sz="2000" dirty="0">
-                <a:latin typeface="Century Gothic" panose="020B0502020202020204" pitchFamily="34" charset="0"/>
-                <a:ea typeface="Calibri" panose="020F0502020204030204" pitchFamily="34" charset="0"/>
-                <a:cs typeface="Times New Roman" panose="02020603050405020304" pitchFamily="18" charset="0"/>
-              </a:rPr>
-              <a:t>Compass Plus</a:t>
-            </a:r>
-            <a:r>
-              <a:rPr lang="ru-RU" altLang="ru-RU" sz="2000" dirty="0">
-                <a:latin typeface="Century Gothic" panose="020B0502020202020204" pitchFamily="34" charset="0"/>
-                <a:ea typeface="Calibri" panose="020F0502020204030204" pitchFamily="34" charset="0"/>
-                <a:cs typeface="Times New Roman" panose="02020603050405020304" pitchFamily="18" charset="0"/>
-              </a:rPr>
-              <a:t>» и ее клиентам такие преимущества как: </a:t>
+              <a:t>даст компании ООО «Компас плюс» и ее клиентам такие преимущества как: </a:t>
             </a:r>
           </a:p>
           <a:p>
@@ -8689,8 +8776,21 @@
                 <a:ea typeface="Calibri" panose="020F0502020204030204" pitchFamily="34" charset="0"/>
                 <a:cs typeface="Times New Roman" panose="02020603050405020304" pitchFamily="18" charset="0"/>
               </a:rPr>
-              <a:t>Возможность изменения настроек кардридерного модуля внутри собственного продукта;</a:t>
-            </a:r>
+              <a:t>Возможность изменения настроек кардридерного модуля внутри собственного продукта</a:t>
+            </a:r>
+            <a:r>
+              <a:rPr lang="en-US" altLang="ru-RU" sz="2000" dirty="0">
+                <a:latin typeface="Century Gothic" panose="020B0502020202020204" pitchFamily="34" charset="0"/>
+                <a:ea typeface="Calibri" panose="020F0502020204030204" pitchFamily="34" charset="0"/>
+                <a:cs typeface="Times New Roman" panose="02020603050405020304" pitchFamily="18" charset="0"/>
+              </a:rPr>
+              <a:t>.</a:t>
+            </a:r>
+            <a:endParaRPr lang="ru-RU" altLang="ru-RU" sz="2000" dirty="0">
+              <a:latin typeface="Century Gothic" panose="020B0502020202020204" pitchFamily="34" charset="0"/>
+              <a:ea typeface="Calibri" panose="020F0502020204030204" pitchFamily="34" charset="0"/>
+              <a:cs typeface="Times New Roman" panose="02020603050405020304" pitchFamily="18" charset="0"/>
+            </a:endParaRPr>
           </a:p>
         </p:txBody>
       </p:sp>
@@ -10634,7 +10734,7 @@
         </p:nvSpPr>
         <p:spPr>
           <a:xfrm>
-            <a:off x="181689" y="860650"/>
+            <a:off x="201567" y="1377485"/>
             <a:ext cx="11808823" cy="4947636"/>
           </a:xfrm>
           <a:prstGeom prst="rect">
@@ -10760,13 +10860,25 @@
               <a:rPr lang="ru-RU" sz="2100" dirty="0">
                 <a:latin typeface="Century Gothic" panose="020B0502020202020204" pitchFamily="34" charset="0"/>
               </a:rPr>
-              <a:t>Описать проектное решение для управления кардридерным модулем эмбоссера </a:t>
+              <a:t>Описать проектные решения для управления кардридерным модулем эмбоссера </a:t>
             </a:r>
             <a:r>
               <a:rPr lang="en-US" sz="2100" dirty="0">
                 <a:latin typeface="Century Gothic" panose="020B0502020202020204" pitchFamily="34" charset="0"/>
               </a:rPr>
-              <a:t>MATICA;</a:t>
+              <a:t>MATICA</a:t>
+            </a:r>
+            <a:r>
+              <a:rPr lang="ru-RU" sz="2100" dirty="0">
+                <a:latin typeface="Century Gothic" panose="020B0502020202020204" pitchFamily="34" charset="0"/>
+              </a:rPr>
+              <a:t> и выполнить программную реализацию библиотеки</a:t>
+            </a:r>
+            <a:r>
+              <a:rPr lang="en-US" sz="2100" dirty="0">
+                <a:latin typeface="Century Gothic" panose="020B0502020202020204" pitchFamily="34" charset="0"/>
+              </a:rPr>
+              <a:t>;</a:t>
             </a:r>
           </a:p>
           <a:p>
@@ -10781,7 +10893,25 @@
               <a:rPr lang="ru-RU" sz="2100" dirty="0">
                 <a:latin typeface="Century Gothic" panose="020B0502020202020204" pitchFamily="34" charset="0"/>
               </a:rPr>
-              <a:t>Получить результаты опытной эксплуатации разработанной программной библиотеки. </a:t>
+              <a:t>Внедрить разработанное программное решение в продукт </a:t>
+            </a:r>
+            <a:r>
+              <a:rPr lang="en-US" sz="2100" dirty="0" err="1">
+                <a:latin typeface="Century Gothic" panose="020B0502020202020204" pitchFamily="34" charset="0"/>
+              </a:rPr>
+              <a:t>CardFactory</a:t>
+            </a:r>
+            <a:r>
+              <a:rPr lang="en-US" sz="2100" dirty="0">
+                <a:latin typeface="Century Gothic" panose="020B0502020202020204" pitchFamily="34" charset="0"/>
+              </a:rPr>
+              <a:t> </a:t>
+            </a:r>
+            <a:r>
+              <a:rPr lang="ru-RU" sz="2100" dirty="0">
+                <a:latin typeface="Century Gothic" panose="020B0502020202020204" pitchFamily="34" charset="0"/>
+              </a:rPr>
+              <a:t>и получить результаты опытной эксплуатации разработанной библиотеки. </a:t>
             </a:r>
           </a:p>
         </p:txBody>
@@ -11523,96 +11653,6 @@
         <p:spPr>
           <a:xfrm rot="8680572" flipH="1">
             <a:off x="5415075" y="2795872"/>
-            <a:ext cx="714428" cy="207710"/>
-          </a:xfrm>
-          <a:prstGeom prst="rect">
-            <a:avLst/>
-          </a:prstGeom>
-        </p:spPr>
-      </p:pic>
-      <p:pic>
-        <p:nvPicPr>
-          <p:cNvPr id="39" name="Picture 38">
-            <a:extLst>
-              <a:ext uri="{FF2B5EF4-FFF2-40B4-BE49-F238E27FC236}">
-                <a16:creationId xmlns:a16="http://schemas.microsoft.com/office/drawing/2014/main" id="{F4C83E37-90D7-C377-6624-E555648A8E0C}"/>
-              </a:ext>
-            </a:extLst>
-          </p:cNvPr>
-          <p:cNvPicPr>
-            <a:picLocks noChangeAspect="1"/>
-          </p:cNvPicPr>
-          <p:nvPr/>
-        </p:nvPicPr>
-        <p:blipFill>
-          <a:blip r:embed="rId6"/>
-          <a:stretch>
-            <a:fillRect/>
-          </a:stretch>
-        </p:blipFill>
-        <p:spPr>
-          <a:xfrm rot="14011547" flipH="1">
-            <a:off x="6559358" y="2928938"/>
-            <a:ext cx="714428" cy="207710"/>
-          </a:xfrm>
-          <a:prstGeom prst="rect">
-            <a:avLst/>
-          </a:prstGeom>
-        </p:spPr>
-      </p:pic>
-      <p:pic>
-        <p:nvPicPr>
-          <p:cNvPr id="40" name="Picture 39">
-            <a:extLst>
-              <a:ext uri="{FF2B5EF4-FFF2-40B4-BE49-F238E27FC236}">
-                <a16:creationId xmlns:a16="http://schemas.microsoft.com/office/drawing/2014/main" id="{F4C83E37-90D7-C377-6624-E555648A8E0C}"/>
-              </a:ext>
-            </a:extLst>
-          </p:cNvPr>
-          <p:cNvPicPr>
-            <a:picLocks noChangeAspect="1"/>
-          </p:cNvPicPr>
-          <p:nvPr/>
-        </p:nvPicPr>
-        <p:blipFill>
-          <a:blip r:embed="rId6"/>
-          <a:stretch>
-            <a:fillRect/>
-          </a:stretch>
-        </p:blipFill>
-        <p:spPr>
-          <a:xfrm rot="16200000" flipH="1">
-            <a:off x="7728324" y="2909413"/>
-            <a:ext cx="562526" cy="192756"/>
-          </a:xfrm>
-          <a:prstGeom prst="rect">
-            <a:avLst/>
-          </a:prstGeom>
-        </p:spPr>
-      </p:pic>
-      <p:pic>
-        <p:nvPicPr>
-          <p:cNvPr id="42" name="Picture 41">
-            <a:extLst>
-              <a:ext uri="{FF2B5EF4-FFF2-40B4-BE49-F238E27FC236}">
-                <a16:creationId xmlns:a16="http://schemas.microsoft.com/office/drawing/2014/main" id="{F4C83E37-90D7-C377-6624-E555648A8E0C}"/>
-              </a:ext>
-            </a:extLst>
-          </p:cNvPr>
-          <p:cNvPicPr>
-            <a:picLocks noChangeAspect="1"/>
-          </p:cNvPicPr>
-          <p:nvPr/>
-        </p:nvPicPr>
-        <p:blipFill>
-          <a:blip r:embed="rId6"/>
-          <a:stretch>
-            <a:fillRect/>
-          </a:stretch>
-        </p:blipFill>
-        <p:spPr>
-          <a:xfrm rot="8026173">
-            <a:off x="8835047" y="2932096"/>
             <a:ext cx="714428" cy="207710"/>
           </a:xfrm>
           <a:prstGeom prst="rect">
@@ -13009,6 +13049,186 @@
           </a:p>
         </p:txBody>
       </p:sp>
+      <p:cxnSp>
+        <p:nvCxnSpPr>
+          <p:cNvPr id="12" name="Connector: Elbow 11">
+            <a:extLst>
+              <a:ext uri="{FF2B5EF4-FFF2-40B4-BE49-F238E27FC236}">
+                <a16:creationId xmlns:a16="http://schemas.microsoft.com/office/drawing/2014/main" id="{04A00D43-72D1-9436-D065-4106D5DB9753}"/>
+              </a:ext>
+            </a:extLst>
+          </p:cNvPr>
+          <p:cNvCxnSpPr>
+            <a:stCxn id="15" idx="2"/>
+            <a:endCxn id="43" idx="0"/>
+          </p:cNvCxnSpPr>
+          <p:nvPr/>
+        </p:nvCxnSpPr>
+        <p:spPr>
+          <a:xfrm rot="16200000" flipH="1">
+            <a:off x="7021881" y="2405191"/>
+            <a:ext cx="697374" cy="1278038"/>
+          </a:xfrm>
+          <a:prstGeom prst="bentConnector3">
+            <a:avLst/>
+          </a:prstGeom>
+          <a:ln w="57150">
+            <a:solidFill>
+              <a:schemeClr val="accent1">
+                <a:lumMod val="50000"/>
+              </a:schemeClr>
+            </a:solidFill>
+          </a:ln>
+        </p:spPr>
+        <p:style>
+          <a:lnRef idx="1">
+            <a:schemeClr val="accent1"/>
+          </a:lnRef>
+          <a:fillRef idx="0">
+            <a:schemeClr val="accent1"/>
+          </a:fillRef>
+          <a:effectRef idx="0">
+            <a:schemeClr val="accent1"/>
+          </a:effectRef>
+          <a:fontRef idx="minor">
+            <a:schemeClr val="tx1"/>
+          </a:fontRef>
+        </p:style>
+      </p:cxnSp>
+      <p:cxnSp>
+        <p:nvCxnSpPr>
+          <p:cNvPr id="16" name="Connector: Elbow 15">
+            <a:extLst>
+              <a:ext uri="{FF2B5EF4-FFF2-40B4-BE49-F238E27FC236}">
+                <a16:creationId xmlns:a16="http://schemas.microsoft.com/office/drawing/2014/main" id="{20E26390-BD57-D275-0CE3-097FD0CC1167}"/>
+              </a:ext>
+            </a:extLst>
+          </p:cNvPr>
+          <p:cNvCxnSpPr>
+            <a:stCxn id="28" idx="2"/>
+            <a:endCxn id="43" idx="0"/>
+          </p:cNvCxnSpPr>
+          <p:nvPr/>
+        </p:nvCxnSpPr>
+        <p:spPr>
+          <a:xfrm rot="5400000">
+            <a:off x="7663368" y="3041741"/>
+            <a:ext cx="697375" cy="4936"/>
+          </a:xfrm>
+          <a:prstGeom prst="bentConnector3">
+            <a:avLst/>
+          </a:prstGeom>
+          <a:ln w="57150">
+            <a:solidFill>
+              <a:schemeClr val="accent1">
+                <a:lumMod val="50000"/>
+              </a:schemeClr>
+            </a:solidFill>
+          </a:ln>
+        </p:spPr>
+        <p:style>
+          <a:lnRef idx="1">
+            <a:schemeClr val="accent1"/>
+          </a:lnRef>
+          <a:fillRef idx="0">
+            <a:schemeClr val="accent1"/>
+          </a:fillRef>
+          <a:effectRef idx="0">
+            <a:schemeClr val="accent1"/>
+          </a:effectRef>
+          <a:fontRef idx="minor">
+            <a:schemeClr val="tx1"/>
+          </a:fontRef>
+        </p:style>
+      </p:cxnSp>
+      <p:cxnSp>
+        <p:nvCxnSpPr>
+          <p:cNvPr id="19" name="Connector: Elbow 18">
+            <a:extLst>
+              <a:ext uri="{FF2B5EF4-FFF2-40B4-BE49-F238E27FC236}">
+                <a16:creationId xmlns:a16="http://schemas.microsoft.com/office/drawing/2014/main" id="{99744BAC-EF43-EFB3-7BEB-079C5C3B5800}"/>
+              </a:ext>
+            </a:extLst>
+          </p:cNvPr>
+          <p:cNvCxnSpPr>
+            <a:stCxn id="32" idx="2"/>
+            <a:endCxn id="43" idx="0"/>
+          </p:cNvCxnSpPr>
+          <p:nvPr/>
+        </p:nvCxnSpPr>
+        <p:spPr>
+          <a:xfrm rot="5400000">
+            <a:off x="8673394" y="2035873"/>
+            <a:ext cx="693217" cy="2020830"/>
+          </a:xfrm>
+          <a:prstGeom prst="bentConnector3">
+            <a:avLst>
+              <a:gd name="adj1" fmla="val 24192"/>
+            </a:avLst>
+          </a:prstGeom>
+          <a:ln w="57150">
+            <a:solidFill>
+              <a:schemeClr val="accent1">
+                <a:lumMod val="50000"/>
+              </a:schemeClr>
+            </a:solidFill>
+          </a:ln>
+        </p:spPr>
+        <p:style>
+          <a:lnRef idx="1">
+            <a:schemeClr val="accent1"/>
+          </a:lnRef>
+          <a:fillRef idx="0">
+            <a:schemeClr val="accent1"/>
+          </a:fillRef>
+          <a:effectRef idx="0">
+            <a:schemeClr val="accent1"/>
+          </a:effectRef>
+          <a:fontRef idx="minor">
+            <a:schemeClr val="tx1"/>
+          </a:fontRef>
+        </p:style>
+      </p:cxnSp>
+      <p:sp>
+        <p:nvSpPr>
+          <p:cNvPr id="24" name="TextBox 23">
+            <a:extLst>
+              <a:ext uri="{FF2B5EF4-FFF2-40B4-BE49-F238E27FC236}">
+                <a16:creationId xmlns:a16="http://schemas.microsoft.com/office/drawing/2014/main" id="{B595390B-60FD-DE33-2770-A5BA83E85515}"/>
+              </a:ext>
+            </a:extLst>
+          </p:cNvPr>
+          <p:cNvSpPr txBox="1"/>
+          <p:nvPr/>
+        </p:nvSpPr>
+        <p:spPr>
+          <a:xfrm>
+            <a:off x="7106477" y="3770091"/>
+            <a:ext cx="564578" cy="461665"/>
+          </a:xfrm>
+          <a:prstGeom prst="rect">
+            <a:avLst/>
+          </a:prstGeom>
+          <a:noFill/>
+        </p:spPr>
+        <p:txBody>
+          <a:bodyPr wrap="none" rtlCol="0">
+            <a:spAutoFit/>
+          </a:bodyPr>
+          <a:lstStyle/>
+          <a:p>
+            <a:r>
+              <a:rPr lang="en-US" sz="2400" dirty="0"/>
+              <a:t>.</a:t>
+            </a:r>
+            <a:r>
+              <a:rPr lang="en-US" sz="2400" dirty="0" err="1"/>
+              <a:t>ini</a:t>
+            </a:r>
+            <a:endParaRPr lang="ru-RU" sz="2400" dirty="0"/>
+          </a:p>
+        </p:txBody>
+      </p:sp>
     </p:spTree>
     <p:extLst>
       <p:ext uri="{BB962C8B-B14F-4D97-AF65-F5344CB8AC3E}">
@@ -13179,7 +13399,13 @@
           <a:solidFill>
             <a:schemeClr val="bg1"/>
           </a:solidFill>
-          <a:ln w="19050"/>
+          <a:ln w="57150">
+            <a:solidFill>
+              <a:schemeClr val="accent1">
+                <a:lumMod val="50000"/>
+              </a:schemeClr>
+            </a:solidFill>
+          </a:ln>
         </p:spPr>
         <p:style>
           <a:lnRef idx="2">
@@ -13281,10 +13507,10 @@
           <a:prstGeom prst="line">
             <a:avLst/>
           </a:prstGeom>
-          <a:ln w="19050">
+          <a:ln w="57150">
             <a:solidFill>
               <a:schemeClr val="accent1">
-                <a:lumMod val="75000"/>
+                <a:lumMod val="50000"/>
               </a:schemeClr>
             </a:solidFill>
           </a:ln>
@@ -13379,22 +13605,24 @@
         <p:nvCxnSpPr>
           <p:cNvPr id="16" name="Straight Connector 15"/>
           <p:cNvCxnSpPr>
+            <a:cxnSpLocks/>
+            <a:stCxn id="15" idx="0"/>
             <a:endCxn id="3" idx="1"/>
           </p:cNvCxnSpPr>
           <p:nvPr/>
         </p:nvCxnSpPr>
         <p:spPr>
           <a:xfrm flipV="1">
-            <a:off x="2861701" y="4983132"/>
-            <a:ext cx="0" cy="419932"/>
+            <a:off x="2861699" y="4983132"/>
+            <a:ext cx="2" cy="420100"/>
           </a:xfrm>
           <a:prstGeom prst="line">
             <a:avLst/>
           </a:prstGeom>
-          <a:ln w="19050">
+          <a:ln w="57150">
             <a:solidFill>
               <a:schemeClr val="accent1">
-                <a:lumMod val="75000"/>
+                <a:lumMod val="50000"/>
               </a:schemeClr>
             </a:solidFill>
           </a:ln>
@@ -13477,22 +13705,23 @@
         <p:nvCxnSpPr>
           <p:cNvPr id="20" name="Straight Connector 19"/>
           <p:cNvCxnSpPr>
-            <a:endCxn id="19" idx="2"/>
+            <a:cxnSpLocks/>
+            <a:stCxn id="21" idx="0"/>
           </p:cNvCxnSpPr>
           <p:nvPr/>
         </p:nvCxnSpPr>
         <p:spPr>
-          <a:xfrm flipH="1" flipV="1">
-            <a:off x="6084087" y="3610959"/>
-            <a:ext cx="2" cy="540221"/>
+          <a:xfrm flipV="1">
+            <a:off x="6084087" y="3577959"/>
+            <a:ext cx="11911" cy="570307"/>
           </a:xfrm>
           <a:prstGeom prst="line">
             <a:avLst/>
           </a:prstGeom>
-          <a:ln w="19050">
+          <a:ln w="57150">
             <a:solidFill>
               <a:schemeClr val="accent1">
-                <a:lumMod val="75000"/>
+                <a:lumMod val="50000"/>
               </a:schemeClr>
             </a:solidFill>
           </a:ln>
@@ -13668,10 +13897,10 @@
           <a:prstGeom prst="line">
             <a:avLst/>
           </a:prstGeom>
-          <a:ln w="19050">
+          <a:ln w="57150">
             <a:solidFill>
               <a:schemeClr val="accent1">
-                <a:lumMod val="75000"/>
+                <a:lumMod val="50000"/>
               </a:schemeClr>
             </a:solidFill>
           </a:ln>
@@ -13707,10 +13936,10 @@
           <a:prstGeom prst="line">
             <a:avLst/>
           </a:prstGeom>
-          <a:ln w="19050">
+          <a:ln w="57150">
             <a:solidFill>
               <a:schemeClr val="accent1">
-                <a:lumMod val="75000"/>
+                <a:lumMod val="50000"/>
               </a:schemeClr>
             </a:solidFill>
           </a:ln>
@@ -13744,10 +13973,10 @@
           <a:prstGeom prst="line">
             <a:avLst/>
           </a:prstGeom>
-          <a:ln w="19050">
+          <a:ln w="57150">
             <a:solidFill>
               <a:schemeClr val="accent1">
-                <a:lumMod val="75000"/>
+                <a:lumMod val="50000"/>
               </a:schemeClr>
             </a:solidFill>
           </a:ln>
@@ -13783,10 +14012,10 @@
           <a:prstGeom prst="line">
             <a:avLst/>
           </a:prstGeom>
-          <a:ln w="19050">
+          <a:ln w="57150">
             <a:solidFill>
               <a:schemeClr val="accent1">
-                <a:lumMod val="75000"/>
+                <a:lumMod val="50000"/>
               </a:schemeClr>
             </a:solidFill>
           </a:ln>
@@ -13931,6 +14160,13 @@
           <a:solidFill>
             <a:schemeClr val="bg1"/>
           </a:solidFill>
+          <a:ln w="57150">
+            <a:solidFill>
+              <a:schemeClr val="accent1">
+                <a:lumMod val="50000"/>
+              </a:schemeClr>
+            </a:solidFill>
+          </a:ln>
         </p:spPr>
         <p:style>
           <a:lnRef idx="2">
@@ -15010,45 +15246,6 @@
           </p:spPr>
         </p:pic>
       </p:grpSp>
-      <p:cxnSp>
-        <p:nvCxnSpPr>
-          <p:cNvPr id="29" name="Straight Arrow Connector 28"/>
-          <p:cNvCxnSpPr>
-            <a:cxnSpLocks/>
-            <a:endCxn id="13" idx="1"/>
-          </p:cNvCxnSpPr>
-          <p:nvPr/>
-        </p:nvCxnSpPr>
-        <p:spPr>
-          <a:xfrm>
-            <a:off x="2172055" y="1982945"/>
-            <a:ext cx="7198724" cy="0"/>
-          </a:xfrm>
-          <a:prstGeom prst="straightConnector1">
-            <a:avLst/>
-          </a:prstGeom>
-          <a:ln w="57150">
-            <a:solidFill>
-              <a:srgbClr val="4D4D4E"/>
-            </a:solidFill>
-            <a:tailEnd type="triangle"/>
-          </a:ln>
-        </p:spPr>
-        <p:style>
-          <a:lnRef idx="1">
-            <a:schemeClr val="accent1"/>
-          </a:lnRef>
-          <a:fillRef idx="0">
-            <a:schemeClr val="accent1"/>
-          </a:fillRef>
-          <a:effectRef idx="0">
-            <a:schemeClr val="accent1"/>
-          </a:effectRef>
-          <a:fontRef idx="minor">
-            <a:schemeClr val="tx1"/>
-          </a:fontRef>
-        </p:style>
-      </p:cxnSp>
       <p:pic>
         <p:nvPicPr>
           <p:cNvPr id="6" name="Picture 5">
@@ -15462,50 +15659,6 @@
       </p:sp>
       <p:cxnSp>
         <p:nvCxnSpPr>
-          <p:cNvPr id="38" name="Straight Arrow Connector 37">
-            <a:extLst>
-              <a:ext uri="{FF2B5EF4-FFF2-40B4-BE49-F238E27FC236}">
-                <a16:creationId xmlns:a16="http://schemas.microsoft.com/office/drawing/2014/main" id="{6596FDAE-0869-AD91-AC57-FE72C146D4AE}"/>
-              </a:ext>
-            </a:extLst>
-          </p:cNvPr>
-          <p:cNvCxnSpPr>
-            <a:cxnSpLocks/>
-          </p:cNvCxnSpPr>
-          <p:nvPr/>
-        </p:nvCxnSpPr>
-        <p:spPr>
-          <a:xfrm flipH="1" flipV="1">
-            <a:off x="2172055" y="2533809"/>
-            <a:ext cx="7198724" cy="23999"/>
-          </a:xfrm>
-          <a:prstGeom prst="straightConnector1">
-            <a:avLst/>
-          </a:prstGeom>
-          <a:ln w="57150">
-            <a:solidFill>
-              <a:srgbClr val="4D4D4E"/>
-            </a:solidFill>
-            <a:tailEnd type="triangle"/>
-          </a:ln>
-        </p:spPr>
-        <p:style>
-          <a:lnRef idx="1">
-            <a:schemeClr val="accent1"/>
-          </a:lnRef>
-          <a:fillRef idx="0">
-            <a:schemeClr val="accent1"/>
-          </a:fillRef>
-          <a:effectRef idx="0">
-            <a:schemeClr val="accent1"/>
-          </a:effectRef>
-          <a:fontRef idx="minor">
-            <a:schemeClr val="tx1"/>
-          </a:fontRef>
-        </p:style>
-      </p:cxnSp>
-      <p:cxnSp>
-        <p:nvCxnSpPr>
           <p:cNvPr id="64" name="Straight Arrow Connector 63">
             <a:extLst>
               <a:ext uri="{FF2B5EF4-FFF2-40B4-BE49-F238E27FC236}">
@@ -15566,50 +15719,6 @@
           <a:xfrm flipV="1">
             <a:off x="4611382" y="4894731"/>
             <a:ext cx="0" cy="359965"/>
-          </a:xfrm>
-          <a:prstGeom prst="straightConnector1">
-            <a:avLst/>
-          </a:prstGeom>
-          <a:ln w="57150">
-            <a:solidFill>
-              <a:srgbClr val="4D4D4E"/>
-            </a:solidFill>
-            <a:tailEnd type="triangle"/>
-          </a:ln>
-        </p:spPr>
-        <p:style>
-          <a:lnRef idx="1">
-            <a:schemeClr val="accent1"/>
-          </a:lnRef>
-          <a:fillRef idx="0">
-            <a:schemeClr val="accent1"/>
-          </a:fillRef>
-          <a:effectRef idx="0">
-            <a:schemeClr val="accent1"/>
-          </a:effectRef>
-          <a:fontRef idx="minor">
-            <a:schemeClr val="tx1"/>
-          </a:fontRef>
-        </p:style>
-      </p:cxnSp>
-      <p:cxnSp>
-        <p:nvCxnSpPr>
-          <p:cNvPr id="71" name="Straight Arrow Connector 70">
-            <a:extLst>
-              <a:ext uri="{FF2B5EF4-FFF2-40B4-BE49-F238E27FC236}">
-                <a16:creationId xmlns:a16="http://schemas.microsoft.com/office/drawing/2014/main" id="{5156E54C-61DF-CCD3-D68C-223357D82704}"/>
-              </a:ext>
-            </a:extLst>
-          </p:cNvPr>
-          <p:cNvCxnSpPr>
-            <a:cxnSpLocks/>
-          </p:cNvCxnSpPr>
-          <p:nvPr/>
-        </p:nvCxnSpPr>
-        <p:spPr>
-          <a:xfrm>
-            <a:off x="1383036" y="3024165"/>
-            <a:ext cx="491305" cy="330803"/>
           </a:xfrm>
           <a:prstGeom prst="straightConnector1">
             <a:avLst/>
@@ -15666,6 +15775,189 @@
           </a:prstGeom>
         </p:spPr>
       </p:pic>
+      <p:sp>
+        <p:nvSpPr>
+          <p:cNvPr id="3" name="Arrow: Right 2">
+            <a:extLst>
+              <a:ext uri="{FF2B5EF4-FFF2-40B4-BE49-F238E27FC236}">
+                <a16:creationId xmlns:a16="http://schemas.microsoft.com/office/drawing/2014/main" id="{BE15AC37-9892-2EC3-291B-085BF0E4F107}"/>
+              </a:ext>
+            </a:extLst>
+          </p:cNvPr>
+          <p:cNvSpPr/>
+          <p:nvPr/>
+        </p:nvSpPr>
+        <p:spPr>
+          <a:xfrm>
+            <a:off x="2470305" y="1520689"/>
+            <a:ext cx="6652162" cy="484632"/>
+          </a:xfrm>
+          <a:prstGeom prst="rightArrow">
+            <a:avLst/>
+          </a:prstGeom>
+          <a:noFill/>
+          <a:ln w="28575">
+            <a:solidFill>
+              <a:schemeClr val="tx1">
+                <a:lumMod val="65000"/>
+                <a:lumOff val="35000"/>
+              </a:schemeClr>
+            </a:solidFill>
+          </a:ln>
+        </p:spPr>
+        <p:style>
+          <a:lnRef idx="2">
+            <a:schemeClr val="accent1">
+              <a:shade val="15000"/>
+            </a:schemeClr>
+          </a:lnRef>
+          <a:fillRef idx="1">
+            <a:schemeClr val="accent1"/>
+          </a:fillRef>
+          <a:effectRef idx="0">
+            <a:schemeClr val="accent1"/>
+          </a:effectRef>
+          <a:fontRef idx="minor">
+            <a:schemeClr val="lt1"/>
+          </a:fontRef>
+        </p:style>
+        <p:txBody>
+          <a:bodyPr rtlCol="0" anchor="ctr"/>
+          <a:lstStyle/>
+          <a:p>
+            <a:pPr algn="ctr"/>
+            <a:endParaRPr lang="ru-RU">
+              <a:ln w="57150">
+                <a:solidFill>
+                  <a:schemeClr val="tx1"/>
+                </a:solidFill>
+              </a:ln>
+            </a:endParaRPr>
+          </a:p>
+        </p:txBody>
+      </p:sp>
+      <p:sp>
+        <p:nvSpPr>
+          <p:cNvPr id="4" name="Arrow: Right 3">
+            <a:extLst>
+              <a:ext uri="{FF2B5EF4-FFF2-40B4-BE49-F238E27FC236}">
+                <a16:creationId xmlns:a16="http://schemas.microsoft.com/office/drawing/2014/main" id="{94C92A2D-D328-D7CB-1029-4AD0C19F55AE}"/>
+              </a:ext>
+            </a:extLst>
+          </p:cNvPr>
+          <p:cNvSpPr/>
+          <p:nvPr/>
+        </p:nvSpPr>
+        <p:spPr>
+          <a:xfrm rot="10800000">
+            <a:off x="2450427" y="2171069"/>
+            <a:ext cx="6652162" cy="484632"/>
+          </a:xfrm>
+          <a:prstGeom prst="rightArrow">
+            <a:avLst/>
+          </a:prstGeom>
+          <a:noFill/>
+          <a:ln w="28575">
+            <a:solidFill>
+              <a:schemeClr val="tx1">
+                <a:lumMod val="65000"/>
+                <a:lumOff val="35000"/>
+              </a:schemeClr>
+            </a:solidFill>
+          </a:ln>
+        </p:spPr>
+        <p:style>
+          <a:lnRef idx="2">
+            <a:schemeClr val="accent1">
+              <a:shade val="15000"/>
+            </a:schemeClr>
+          </a:lnRef>
+          <a:fillRef idx="1">
+            <a:schemeClr val="accent1"/>
+          </a:fillRef>
+          <a:effectRef idx="0">
+            <a:schemeClr val="accent1"/>
+          </a:effectRef>
+          <a:fontRef idx="minor">
+            <a:schemeClr val="lt1"/>
+          </a:fontRef>
+        </p:style>
+        <p:txBody>
+          <a:bodyPr rtlCol="0" anchor="ctr"/>
+          <a:lstStyle/>
+          <a:p>
+            <a:pPr algn="ctr"/>
+            <a:endParaRPr lang="ru-RU">
+              <a:ln w="57150">
+                <a:solidFill>
+                  <a:schemeClr val="tx1"/>
+                </a:solidFill>
+              </a:ln>
+            </a:endParaRPr>
+          </a:p>
+        </p:txBody>
+      </p:sp>
+      <p:sp>
+        <p:nvSpPr>
+          <p:cNvPr id="12" name="Arrow: Right 11">
+            <a:extLst>
+              <a:ext uri="{FF2B5EF4-FFF2-40B4-BE49-F238E27FC236}">
+                <a16:creationId xmlns:a16="http://schemas.microsoft.com/office/drawing/2014/main" id="{1244E59A-381A-CE4A-AC2A-205D68AC2214}"/>
+              </a:ext>
+            </a:extLst>
+          </p:cNvPr>
+          <p:cNvSpPr/>
+          <p:nvPr/>
+        </p:nvSpPr>
+        <p:spPr>
+          <a:xfrm rot="2291880">
+            <a:off x="862633" y="3259787"/>
+            <a:ext cx="702666" cy="236178"/>
+          </a:xfrm>
+          <a:prstGeom prst="rightArrow">
+            <a:avLst/>
+          </a:prstGeom>
+          <a:noFill/>
+          <a:ln w="19050">
+            <a:solidFill>
+              <a:schemeClr val="tx1">
+                <a:lumMod val="65000"/>
+                <a:lumOff val="35000"/>
+              </a:schemeClr>
+            </a:solidFill>
+          </a:ln>
+        </p:spPr>
+        <p:style>
+          <a:lnRef idx="2">
+            <a:schemeClr val="accent1">
+              <a:shade val="15000"/>
+            </a:schemeClr>
+          </a:lnRef>
+          <a:fillRef idx="1">
+            <a:schemeClr val="accent1"/>
+          </a:fillRef>
+          <a:effectRef idx="0">
+            <a:schemeClr val="accent1"/>
+          </a:effectRef>
+          <a:fontRef idx="minor">
+            <a:schemeClr val="lt1"/>
+          </a:fontRef>
+        </p:style>
+        <p:txBody>
+          <a:bodyPr rtlCol="0" anchor="ctr"/>
+          <a:lstStyle/>
+          <a:p>
+            <a:pPr algn="ctr"/>
+            <a:endParaRPr lang="ru-RU">
+              <a:ln w="57150">
+                <a:solidFill>
+                  <a:schemeClr val="tx1"/>
+                </a:solidFill>
+              </a:ln>
+            </a:endParaRPr>
+          </a:p>
+        </p:txBody>
+      </p:sp>
     </p:spTree>
     <p:extLst>
       <p:ext uri="{BB962C8B-B14F-4D97-AF65-F5344CB8AC3E}">

</xml_diff>

<commit_message>
Refactored presentation started working on script
</commit_message>
<xml_diff>
--- a/Presentation/NMSTU_Presentation.pptx
+++ b/Presentation/NMSTU_Presentation.pptx
@@ -6670,7 +6670,7 @@
         </p:nvGrpSpPr>
         <p:grpSpPr>
           <a:xfrm>
-            <a:off x="293228" y="3033217"/>
+            <a:off x="210102" y="2940848"/>
             <a:ext cx="1765292" cy="2367668"/>
             <a:chOff x="2008240" y="4591624"/>
             <a:chExt cx="1164942" cy="1562459"/>
@@ -6954,7 +6954,7 @@
         </p:nvGrpSpPr>
         <p:grpSpPr>
           <a:xfrm>
-            <a:off x="2095790" y="3719710"/>
+            <a:off x="2079792" y="3429000"/>
             <a:ext cx="1294475" cy="880434"/>
             <a:chOff x="9590966" y="4185349"/>
             <a:chExt cx="1157836" cy="787499"/>
@@ -7116,7 +7116,7 @@
         </p:nvSpPr>
         <p:spPr>
           <a:xfrm>
-            <a:off x="2220170" y="4715355"/>
+            <a:off x="2164079" y="4444042"/>
             <a:ext cx="1041915" cy="646331"/>
           </a:xfrm>
           <a:prstGeom prst="rect">
@@ -7649,7 +7649,7 @@
         </p:nvGrpSpPr>
         <p:grpSpPr>
           <a:xfrm>
-            <a:off x="4134526" y="3159894"/>
+            <a:off x="4134526" y="2873570"/>
             <a:ext cx="1250190" cy="744867"/>
             <a:chOff x="3051580" y="2997200"/>
             <a:chExt cx="1486171" cy="885465"/>
@@ -7746,36 +7746,6 @@
           <a:xfrm>
             <a:off x="1215226" y="5080571"/>
             <a:ext cx="1810669" cy="1085182"/>
-          </a:xfrm>
-          <a:prstGeom prst="rect">
-            <a:avLst/>
-          </a:prstGeom>
-        </p:spPr>
-      </p:pic>
-      <p:pic>
-        <p:nvPicPr>
-          <p:cNvPr id="28" name="Picture 27">
-            <a:extLst>
-              <a:ext uri="{FF2B5EF4-FFF2-40B4-BE49-F238E27FC236}">
-                <a16:creationId xmlns:a16="http://schemas.microsoft.com/office/drawing/2014/main" id="{AF3A5F0D-C1A3-E312-A2DE-B38061EEBCA2}"/>
-              </a:ext>
-            </a:extLst>
-          </p:cNvPr>
-          <p:cNvPicPr>
-            <a:picLocks noChangeAspect="1"/>
-          </p:cNvPicPr>
-          <p:nvPr/>
-        </p:nvPicPr>
-        <p:blipFill>
-          <a:blip r:embed="rId7"/>
-          <a:stretch>
-            <a:fillRect/>
-          </a:stretch>
-        </p:blipFill>
-        <p:spPr>
-          <a:xfrm>
-            <a:off x="7378980" y="5448970"/>
-            <a:ext cx="1584729" cy="428898"/>
           </a:xfrm>
           <a:prstGeom prst="rect">
             <a:avLst/>
@@ -8017,87 +7987,6 @@
             </a:p>
           </p:txBody>
         </p:sp>
-      </p:grpSp>
-      <p:grpSp>
-        <p:nvGrpSpPr>
-          <p:cNvPr id="37" name="Group 36">
-            <a:extLst>
-              <a:ext uri="{FF2B5EF4-FFF2-40B4-BE49-F238E27FC236}">
-                <a16:creationId xmlns:a16="http://schemas.microsoft.com/office/drawing/2014/main" id="{FBC0659D-63F2-2C70-04DC-C69AC93B3E0C}"/>
-              </a:ext>
-            </a:extLst>
-          </p:cNvPr>
-          <p:cNvGrpSpPr/>
-          <p:nvPr/>
-        </p:nvGrpSpPr>
-        <p:grpSpPr>
-          <a:xfrm rot="5400000">
-            <a:off x="5953048" y="4389403"/>
-            <a:ext cx="478518" cy="333690"/>
-            <a:chOff x="3051580" y="2997200"/>
-            <a:chExt cx="1486171" cy="885465"/>
-          </a:xfrm>
-        </p:grpSpPr>
-        <p:pic>
-          <p:nvPicPr>
-            <p:cNvPr id="38" name="Picture 37">
-              <a:extLst>
-                <a:ext uri="{FF2B5EF4-FFF2-40B4-BE49-F238E27FC236}">
-                  <a16:creationId xmlns:a16="http://schemas.microsoft.com/office/drawing/2014/main" id="{CF4DD96F-D166-215C-71F3-BD4E16574C1D}"/>
-                </a:ext>
-              </a:extLst>
-            </p:cNvPr>
-            <p:cNvPicPr>
-              <a:picLocks noChangeAspect="1"/>
-            </p:cNvPicPr>
-            <p:nvPr/>
-          </p:nvPicPr>
-          <p:blipFill>
-            <a:blip r:embed="rId7"/>
-            <a:stretch>
-              <a:fillRect/>
-            </a:stretch>
-          </p:blipFill>
-          <p:spPr>
-            <a:xfrm rot="10800000">
-              <a:off x="3051580" y="2997200"/>
-              <a:ext cx="1475297" cy="440190"/>
-            </a:xfrm>
-            <a:prstGeom prst="rect">
-              <a:avLst/>
-            </a:prstGeom>
-          </p:spPr>
-        </p:pic>
-        <p:pic>
-          <p:nvPicPr>
-            <p:cNvPr id="39" name="Picture 38">
-              <a:extLst>
-                <a:ext uri="{FF2B5EF4-FFF2-40B4-BE49-F238E27FC236}">
-                  <a16:creationId xmlns:a16="http://schemas.microsoft.com/office/drawing/2014/main" id="{12B37ACB-3A02-A7A8-832A-CBFC2B9F2616}"/>
-                </a:ext>
-              </a:extLst>
-            </p:cNvPr>
-            <p:cNvPicPr>
-              <a:picLocks noChangeAspect="1"/>
-            </p:cNvPicPr>
-            <p:nvPr/>
-          </p:nvPicPr>
-          <p:blipFill>
-            <a:blip r:embed="rId7"/>
-            <a:stretch>
-              <a:fillRect/>
-            </a:stretch>
-          </p:blipFill>
-          <p:spPr>
-            <a:xfrm rot="10800000" flipH="1">
-              <a:off x="3062454" y="3442475"/>
-              <a:ext cx="1475297" cy="440190"/>
-            </a:xfrm>
-            <a:prstGeom prst="rect">
-              <a:avLst/>
-            </a:prstGeom>
-          </p:spPr>
-        </p:pic>
       </p:grpSp>
       <p:sp>
         <p:nvSpPr>
@@ -8364,6 +8253,179 @@
           </p:txBody>
         </p:sp>
       </p:grpSp>
+      <p:grpSp>
+        <p:nvGrpSpPr>
+          <p:cNvPr id="17" name="Group 16">
+            <a:extLst>
+              <a:ext uri="{FF2B5EF4-FFF2-40B4-BE49-F238E27FC236}">
+                <a16:creationId xmlns:a16="http://schemas.microsoft.com/office/drawing/2014/main" id="{20126E9F-0B96-C82A-167E-A7D4F20365D6}"/>
+              </a:ext>
+            </a:extLst>
+          </p:cNvPr>
+          <p:cNvGrpSpPr/>
+          <p:nvPr/>
+        </p:nvGrpSpPr>
+        <p:grpSpPr>
+          <a:xfrm rot="16200000">
+            <a:off x="5957291" y="4133828"/>
+            <a:ext cx="451525" cy="912748"/>
+            <a:chOff x="7180363" y="3494533"/>
+            <a:chExt cx="3875478" cy="1164531"/>
+          </a:xfrm>
+        </p:grpSpPr>
+        <p:sp>
+          <p:nvSpPr>
+            <p:cNvPr id="18" name="Arrow: Right 17">
+              <a:extLst>
+                <a:ext uri="{FF2B5EF4-FFF2-40B4-BE49-F238E27FC236}">
+                  <a16:creationId xmlns:a16="http://schemas.microsoft.com/office/drawing/2014/main" id="{78FFFB51-77A7-3A82-32D0-6FF7740AFC5C}"/>
+                </a:ext>
+              </a:extLst>
+            </p:cNvPr>
+            <p:cNvSpPr/>
+            <p:nvPr/>
+          </p:nvSpPr>
+          <p:spPr>
+            <a:xfrm>
+              <a:off x="7517339" y="3494533"/>
+              <a:ext cx="3538502" cy="484632"/>
+            </a:xfrm>
+            <a:prstGeom prst="rightArrow">
+              <a:avLst/>
+            </a:prstGeom>
+            <a:noFill/>
+            <a:ln w="28575">
+              <a:solidFill>
+                <a:schemeClr val="tx1">
+                  <a:lumMod val="65000"/>
+                  <a:lumOff val="35000"/>
+                </a:schemeClr>
+              </a:solidFill>
+            </a:ln>
+          </p:spPr>
+          <p:style>
+            <a:lnRef idx="2">
+              <a:schemeClr val="accent1">
+                <a:shade val="15000"/>
+              </a:schemeClr>
+            </a:lnRef>
+            <a:fillRef idx="1">
+              <a:schemeClr val="accent1"/>
+            </a:fillRef>
+            <a:effectRef idx="0">
+              <a:schemeClr val="accent1"/>
+            </a:effectRef>
+            <a:fontRef idx="minor">
+              <a:schemeClr val="lt1"/>
+            </a:fontRef>
+          </p:style>
+          <p:txBody>
+            <a:bodyPr rtlCol="0" anchor="ctr"/>
+            <a:lstStyle/>
+            <a:p>
+              <a:pPr algn="ctr"/>
+              <a:endParaRPr lang="ru-RU">
+                <a:ln w="57150">
+                  <a:solidFill>
+                    <a:schemeClr val="tx1"/>
+                  </a:solidFill>
+                </a:ln>
+              </a:endParaRPr>
+            </a:p>
+          </p:txBody>
+        </p:sp>
+        <p:sp>
+          <p:nvSpPr>
+            <p:cNvPr id="25" name="Arrow: Right 24">
+              <a:extLst>
+                <a:ext uri="{FF2B5EF4-FFF2-40B4-BE49-F238E27FC236}">
+                  <a16:creationId xmlns:a16="http://schemas.microsoft.com/office/drawing/2014/main" id="{30415E33-5B30-B160-ED7E-0B245F98B66B}"/>
+                </a:ext>
+              </a:extLst>
+            </p:cNvPr>
+            <p:cNvSpPr/>
+            <p:nvPr/>
+          </p:nvSpPr>
+          <p:spPr>
+            <a:xfrm rot="10800000">
+              <a:off x="7180363" y="4174431"/>
+              <a:ext cx="3538506" cy="484633"/>
+            </a:xfrm>
+            <a:prstGeom prst="rightArrow">
+              <a:avLst/>
+            </a:prstGeom>
+            <a:noFill/>
+            <a:ln w="28575">
+              <a:solidFill>
+                <a:schemeClr val="tx1">
+                  <a:lumMod val="65000"/>
+                  <a:lumOff val="35000"/>
+                </a:schemeClr>
+              </a:solidFill>
+            </a:ln>
+          </p:spPr>
+          <p:style>
+            <a:lnRef idx="2">
+              <a:schemeClr val="accent1">
+                <a:shade val="15000"/>
+              </a:schemeClr>
+            </a:lnRef>
+            <a:fillRef idx="1">
+              <a:schemeClr val="accent1"/>
+            </a:fillRef>
+            <a:effectRef idx="0">
+              <a:schemeClr val="accent1"/>
+            </a:effectRef>
+            <a:fontRef idx="minor">
+              <a:schemeClr val="lt1"/>
+            </a:fontRef>
+          </p:style>
+          <p:txBody>
+            <a:bodyPr rtlCol="0" anchor="ctr"/>
+            <a:lstStyle/>
+            <a:p>
+              <a:pPr algn="ctr"/>
+              <a:endParaRPr lang="ru-RU">
+                <a:ln w="57150">
+                  <a:solidFill>
+                    <a:schemeClr val="tx1"/>
+                  </a:solidFill>
+                </a:ln>
+              </a:endParaRPr>
+            </a:p>
+          </p:txBody>
+        </p:sp>
+      </p:grpSp>
+      <p:pic>
+        <p:nvPicPr>
+          <p:cNvPr id="26" name="Picture 25">
+            <a:extLst>
+              <a:ext uri="{FF2B5EF4-FFF2-40B4-BE49-F238E27FC236}">
+                <a16:creationId xmlns:a16="http://schemas.microsoft.com/office/drawing/2014/main" id="{2DF4CCBC-1517-C17C-258C-6E3EDB21B65A}"/>
+              </a:ext>
+            </a:extLst>
+          </p:cNvPr>
+          <p:cNvPicPr>
+            <a:picLocks noChangeAspect="1"/>
+          </p:cNvPicPr>
+          <p:nvPr/>
+        </p:nvPicPr>
+        <p:blipFill>
+          <a:blip r:embed="rId7"/>
+          <a:stretch>
+            <a:fillRect/>
+          </a:stretch>
+        </p:blipFill>
+        <p:spPr>
+          <a:xfrm>
+            <a:off x="7442522" y="5408713"/>
+            <a:ext cx="1584729" cy="428898"/>
+          </a:xfrm>
+          <a:prstGeom prst="rect">
+            <a:avLst/>
+          </a:prstGeom>
+        </p:spPr>
+      </p:pic>
     </p:spTree>
     <p:extLst>
       <p:ext uri="{BB962C8B-B14F-4D97-AF65-F5344CB8AC3E}">
@@ -9808,87 +9870,36 @@
           </p:spPr>
         </p:pic>
       </p:grpSp>
-      <p:grpSp>
-        <p:nvGrpSpPr>
-          <p:cNvPr id="31" name="Group 30">
+      <p:pic>
+        <p:nvPicPr>
+          <p:cNvPr id="18" name="Picture 17">
             <a:extLst>
               <a:ext uri="{FF2B5EF4-FFF2-40B4-BE49-F238E27FC236}">
-                <a16:creationId xmlns:a16="http://schemas.microsoft.com/office/drawing/2014/main" id="{1BCDE1F2-4856-DB46-81B0-9741872E5801}"/>
+                <a16:creationId xmlns:a16="http://schemas.microsoft.com/office/drawing/2014/main" id="{23FE7613-C3BD-ED6E-0B2C-B1B4C6E9DCA4}"/>
               </a:ext>
             </a:extLst>
           </p:cNvPr>
-          <p:cNvGrpSpPr/>
+          <p:cNvPicPr>
+            <a:picLocks noChangeAspect="1"/>
+          </p:cNvPicPr>
           <p:nvPr/>
-        </p:nvGrpSpPr>
-        <p:grpSpPr>
-          <a:xfrm>
-            <a:off x="5411530" y="1895788"/>
-            <a:ext cx="1368940" cy="815619"/>
-            <a:chOff x="6871862" y="1433188"/>
-            <a:chExt cx="1486171" cy="885465"/>
-          </a:xfrm>
-        </p:grpSpPr>
-        <p:pic>
-          <p:nvPicPr>
-            <p:cNvPr id="17" name="Picture 16">
-              <a:extLst>
-                <a:ext uri="{FF2B5EF4-FFF2-40B4-BE49-F238E27FC236}">
-                  <a16:creationId xmlns:a16="http://schemas.microsoft.com/office/drawing/2014/main" id="{6223D05A-6CC1-3BB0-56EC-E48ED1372BC1}"/>
-                </a:ext>
-              </a:extLst>
-            </p:cNvPr>
-            <p:cNvPicPr>
-              <a:picLocks noChangeAspect="1"/>
-            </p:cNvPicPr>
-            <p:nvPr/>
-          </p:nvPicPr>
-          <p:blipFill>
-            <a:blip r:embed="rId7"/>
-            <a:stretch>
-              <a:fillRect/>
-            </a:stretch>
-          </p:blipFill>
-          <p:spPr>
-            <a:xfrm rot="10800000">
-              <a:off x="6871862" y="1433188"/>
-              <a:ext cx="1475297" cy="440190"/>
-            </a:xfrm>
-            <a:prstGeom prst="rect">
-              <a:avLst/>
-            </a:prstGeom>
-          </p:spPr>
-        </p:pic>
-        <p:pic>
-          <p:nvPicPr>
-            <p:cNvPr id="18" name="Picture 17">
-              <a:extLst>
-                <a:ext uri="{FF2B5EF4-FFF2-40B4-BE49-F238E27FC236}">
-                  <a16:creationId xmlns:a16="http://schemas.microsoft.com/office/drawing/2014/main" id="{23FE7613-C3BD-ED6E-0B2C-B1B4C6E9DCA4}"/>
-                </a:ext>
-              </a:extLst>
-            </p:cNvPr>
-            <p:cNvPicPr>
-              <a:picLocks noChangeAspect="1"/>
-            </p:cNvPicPr>
-            <p:nvPr/>
-          </p:nvPicPr>
-          <p:blipFill>
-            <a:blip r:embed="rId7"/>
-            <a:stretch>
-              <a:fillRect/>
-            </a:stretch>
-          </p:blipFill>
-          <p:spPr>
-            <a:xfrm rot="10800000" flipH="1">
-              <a:off x="6882736" y="1878463"/>
-              <a:ext cx="1475297" cy="440190"/>
-            </a:xfrm>
-            <a:prstGeom prst="rect">
-              <a:avLst/>
-            </a:prstGeom>
-          </p:spPr>
-        </p:pic>
-      </p:grpSp>
+        </p:nvPicPr>
+        <p:blipFill>
+          <a:blip r:embed="rId7"/>
+          <a:stretch>
+            <a:fillRect/>
+          </a:stretch>
+        </p:blipFill>
+        <p:spPr>
+          <a:xfrm rot="10800000" flipH="1">
+            <a:off x="5373420" y="2049267"/>
+            <a:ext cx="1358924" cy="405468"/>
+          </a:xfrm>
+          <a:prstGeom prst="rect">
+            <a:avLst/>
+          </a:prstGeom>
+        </p:spPr>
+      </p:pic>
       <p:pic>
         <p:nvPicPr>
           <p:cNvPr id="19" name="Picture 18">
@@ -10022,8 +10033,8 @@
         </p:nvGrpSpPr>
         <p:grpSpPr>
           <a:xfrm rot="5400000">
-            <a:off x="7291031" y="3750901"/>
-            <a:ext cx="1356940" cy="689302"/>
+            <a:off x="7375178" y="3739798"/>
+            <a:ext cx="1188645" cy="689302"/>
             <a:chOff x="2071940" y="4941171"/>
             <a:chExt cx="1486171" cy="885465"/>
           </a:xfrm>
@@ -14517,8 +14528,8 @@
         </p:nvSpPr>
         <p:spPr>
           <a:xfrm>
-            <a:off x="1362777" y="3156756"/>
-            <a:ext cx="3794593" cy="1926720"/>
+            <a:off x="3384340" y="1229897"/>
+            <a:ext cx="1583431" cy="4708051"/>
           </a:xfrm>
           <a:prstGeom prst="rect">
             <a:avLst/>
@@ -14899,7 +14910,7 @@
         </p:nvGrpSpPr>
         <p:grpSpPr>
           <a:xfrm>
-            <a:off x="3788548" y="3360900"/>
+            <a:off x="3587184" y="4003986"/>
             <a:ext cx="1321445" cy="1562459"/>
             <a:chOff x="4459057" y="4591624"/>
             <a:chExt cx="1321445" cy="1562459"/>
@@ -15040,8 +15051,8 @@
         </p:nvGrpSpPr>
         <p:grpSpPr>
           <a:xfrm>
-            <a:off x="6626205" y="3321701"/>
-            <a:ext cx="1719789" cy="1721306"/>
+            <a:off x="6433398" y="3697448"/>
+            <a:ext cx="2318274" cy="2220462"/>
             <a:chOff x="6979279" y="4486085"/>
             <a:chExt cx="2000266" cy="2002030"/>
           </a:xfrm>
@@ -15127,7 +15138,7 @@
         </p:nvGrpSpPr>
         <p:grpSpPr>
           <a:xfrm>
-            <a:off x="3788548" y="5222797"/>
+            <a:off x="749822" y="3938125"/>
             <a:ext cx="1307252" cy="1562459"/>
             <a:chOff x="2008240" y="4591624"/>
             <a:chExt cx="1307252" cy="1562459"/>
@@ -15274,176 +15285,14 @@
         </p:blipFill>
         <p:spPr>
           <a:xfrm>
-            <a:off x="9768366" y="3724495"/>
-            <a:ext cx="1272141" cy="762426"/>
+            <a:off x="10370703" y="4197030"/>
+            <a:ext cx="1594785" cy="955795"/>
           </a:xfrm>
           <a:prstGeom prst="rect">
             <a:avLst/>
           </a:prstGeom>
         </p:spPr>
       </p:pic>
-      <p:grpSp>
-        <p:nvGrpSpPr>
-          <p:cNvPr id="26" name="Group 25">
-            <a:extLst>
-              <a:ext uri="{FF2B5EF4-FFF2-40B4-BE49-F238E27FC236}">
-                <a16:creationId xmlns:a16="http://schemas.microsoft.com/office/drawing/2014/main" id="{81CE34D0-EE19-43A1-0A54-50FDC3E138F2}"/>
-              </a:ext>
-            </a:extLst>
-          </p:cNvPr>
-          <p:cNvGrpSpPr/>
-          <p:nvPr/>
-        </p:nvGrpSpPr>
-        <p:grpSpPr>
-          <a:xfrm>
-            <a:off x="5457862" y="3790714"/>
-            <a:ext cx="859777" cy="584775"/>
-            <a:chOff x="5722721" y="5018774"/>
-            <a:chExt cx="1157836" cy="787499"/>
-          </a:xfrm>
-        </p:grpSpPr>
-        <p:pic>
-          <p:nvPicPr>
-            <p:cNvPr id="16" name="Picture 15">
-              <a:extLst>
-                <a:ext uri="{FF2B5EF4-FFF2-40B4-BE49-F238E27FC236}">
-                  <a16:creationId xmlns:a16="http://schemas.microsoft.com/office/drawing/2014/main" id="{CEC84ECF-E301-9167-7DE1-79EDE2277973}"/>
-                </a:ext>
-              </a:extLst>
-            </p:cNvPr>
-            <p:cNvPicPr>
-              <a:picLocks noChangeAspect="1"/>
-            </p:cNvPicPr>
-            <p:nvPr/>
-          </p:nvPicPr>
-          <p:blipFill>
-            <a:blip r:embed="rId10"/>
-            <a:stretch>
-              <a:fillRect/>
-            </a:stretch>
-          </p:blipFill>
-          <p:spPr>
-            <a:xfrm rot="10800000">
-              <a:off x="5722721" y="5018774"/>
-              <a:ext cx="1146960" cy="342224"/>
-            </a:xfrm>
-            <a:prstGeom prst="rect">
-              <a:avLst/>
-            </a:prstGeom>
-          </p:spPr>
-        </p:pic>
-        <p:pic>
-          <p:nvPicPr>
-            <p:cNvPr id="18" name="Picture 17">
-              <a:extLst>
-                <a:ext uri="{FF2B5EF4-FFF2-40B4-BE49-F238E27FC236}">
-                  <a16:creationId xmlns:a16="http://schemas.microsoft.com/office/drawing/2014/main" id="{1D4A90F9-D5E2-0950-1E01-BB7CF9A1D4B6}"/>
-                </a:ext>
-              </a:extLst>
-            </p:cNvPr>
-            <p:cNvPicPr>
-              <a:picLocks noChangeAspect="1"/>
-            </p:cNvPicPr>
-            <p:nvPr/>
-          </p:nvPicPr>
-          <p:blipFill>
-            <a:blip r:embed="rId10"/>
-            <a:stretch>
-              <a:fillRect/>
-            </a:stretch>
-          </p:blipFill>
-          <p:spPr>
-            <a:xfrm rot="10800000" flipH="1">
-              <a:off x="5733595" y="5464049"/>
-              <a:ext cx="1146962" cy="342224"/>
-            </a:xfrm>
-            <a:prstGeom prst="rect">
-              <a:avLst/>
-            </a:prstGeom>
-          </p:spPr>
-        </p:pic>
-      </p:grpSp>
-      <p:grpSp>
-        <p:nvGrpSpPr>
-          <p:cNvPr id="39" name="Group 38">
-            <a:extLst>
-              <a:ext uri="{FF2B5EF4-FFF2-40B4-BE49-F238E27FC236}">
-                <a16:creationId xmlns:a16="http://schemas.microsoft.com/office/drawing/2014/main" id="{D46D93D2-77B9-F939-F91B-C906152E37EB}"/>
-              </a:ext>
-            </a:extLst>
-          </p:cNvPr>
-          <p:cNvGrpSpPr/>
-          <p:nvPr/>
-        </p:nvGrpSpPr>
-        <p:grpSpPr>
-          <a:xfrm>
-            <a:off x="8662636" y="3752453"/>
-            <a:ext cx="859777" cy="584775"/>
-            <a:chOff x="5722721" y="5018774"/>
-            <a:chExt cx="1157836" cy="787499"/>
-          </a:xfrm>
-        </p:grpSpPr>
-        <p:pic>
-          <p:nvPicPr>
-            <p:cNvPr id="41" name="Picture 40">
-              <a:extLst>
-                <a:ext uri="{FF2B5EF4-FFF2-40B4-BE49-F238E27FC236}">
-                  <a16:creationId xmlns:a16="http://schemas.microsoft.com/office/drawing/2014/main" id="{F5BF952A-586D-DF8D-4226-F2CCCEE5EA4F}"/>
-                </a:ext>
-              </a:extLst>
-            </p:cNvPr>
-            <p:cNvPicPr>
-              <a:picLocks noChangeAspect="1"/>
-            </p:cNvPicPr>
-            <p:nvPr/>
-          </p:nvPicPr>
-          <p:blipFill>
-            <a:blip r:embed="rId10"/>
-            <a:stretch>
-              <a:fillRect/>
-            </a:stretch>
-          </p:blipFill>
-          <p:spPr>
-            <a:xfrm rot="10800000">
-              <a:off x="5722721" y="5018774"/>
-              <a:ext cx="1146960" cy="342224"/>
-            </a:xfrm>
-            <a:prstGeom prst="rect">
-              <a:avLst/>
-            </a:prstGeom>
-          </p:spPr>
-        </p:pic>
-        <p:pic>
-          <p:nvPicPr>
-            <p:cNvPr id="42" name="Picture 41">
-              <a:extLst>
-                <a:ext uri="{FF2B5EF4-FFF2-40B4-BE49-F238E27FC236}">
-                  <a16:creationId xmlns:a16="http://schemas.microsoft.com/office/drawing/2014/main" id="{1594E80D-43BC-CDFB-F1DE-E9FBA2CDA946}"/>
-                </a:ext>
-              </a:extLst>
-            </p:cNvPr>
-            <p:cNvPicPr>
-              <a:picLocks noChangeAspect="1"/>
-            </p:cNvPicPr>
-            <p:nvPr/>
-          </p:nvPicPr>
-          <p:blipFill>
-            <a:blip r:embed="rId10"/>
-            <a:stretch>
-              <a:fillRect/>
-            </a:stretch>
-          </p:blipFill>
-          <p:spPr>
-            <a:xfrm rot="10800000" flipH="1">
-              <a:off x="5733595" y="5464049"/>
-              <a:ext cx="1146962" cy="342224"/>
-            </a:xfrm>
-            <a:prstGeom prst="rect">
-              <a:avLst/>
-            </a:prstGeom>
-          </p:spPr>
-        </p:pic>
-      </p:grpSp>
       <p:grpSp>
         <p:nvGrpSpPr>
           <p:cNvPr id="54" name="Group 53">
@@ -15458,7 +15307,7 @@
         </p:nvGrpSpPr>
         <p:grpSpPr>
           <a:xfrm>
-            <a:off x="1541128" y="3354968"/>
+            <a:off x="3543452" y="1407330"/>
             <a:ext cx="1265206" cy="1562459"/>
             <a:chOff x="6698461" y="1494327"/>
             <a:chExt cx="1265206" cy="1562459"/>
@@ -15593,36 +15442,6 @@
           </p:txBody>
         </p:sp>
       </p:grpSp>
-      <p:pic>
-        <p:nvPicPr>
-          <p:cNvPr id="61" name="Picture 60">
-            <a:extLst>
-              <a:ext uri="{FF2B5EF4-FFF2-40B4-BE49-F238E27FC236}">
-                <a16:creationId xmlns:a16="http://schemas.microsoft.com/office/drawing/2014/main" id="{AD5D77DF-8935-90A0-FB2F-0AE93475751D}"/>
-              </a:ext>
-            </a:extLst>
-          </p:cNvPr>
-          <p:cNvPicPr>
-            <a:picLocks noChangeAspect="1"/>
-          </p:cNvPicPr>
-          <p:nvPr/>
-        </p:nvPicPr>
-        <p:blipFill>
-          <a:blip r:embed="rId10"/>
-          <a:stretch>
-            <a:fillRect/>
-          </a:stretch>
-        </p:blipFill>
-        <p:spPr>
-          <a:xfrm rot="10800000" flipH="1">
-            <a:off x="2832962" y="4003986"/>
-            <a:ext cx="886216" cy="264424"/>
-          </a:xfrm>
-          <a:prstGeom prst="rect">
-            <a:avLst/>
-          </a:prstGeom>
-        </p:spPr>
-      </p:pic>
       <p:sp>
         <p:nvSpPr>
           <p:cNvPr id="63" name="Slide Number Placeholder 62">
@@ -15657,124 +15476,6 @@
           </a:p>
         </p:txBody>
       </p:sp>
-      <p:cxnSp>
-        <p:nvCxnSpPr>
-          <p:cNvPr id="64" name="Straight Arrow Connector 63">
-            <a:extLst>
-              <a:ext uri="{FF2B5EF4-FFF2-40B4-BE49-F238E27FC236}">
-                <a16:creationId xmlns:a16="http://schemas.microsoft.com/office/drawing/2014/main" id="{E1721875-13FE-66BF-4A7E-40203F0A5786}"/>
-              </a:ext>
-            </a:extLst>
-          </p:cNvPr>
-          <p:cNvCxnSpPr>
-            <a:cxnSpLocks/>
-          </p:cNvCxnSpPr>
-          <p:nvPr/>
-        </p:nvCxnSpPr>
-        <p:spPr>
-          <a:xfrm>
-            <a:off x="4048318" y="4878994"/>
-            <a:ext cx="0" cy="330803"/>
-          </a:xfrm>
-          <a:prstGeom prst="straightConnector1">
-            <a:avLst/>
-          </a:prstGeom>
-          <a:ln w="57150">
-            <a:solidFill>
-              <a:srgbClr val="4D4D4E"/>
-            </a:solidFill>
-            <a:tailEnd type="triangle"/>
-          </a:ln>
-        </p:spPr>
-        <p:style>
-          <a:lnRef idx="1">
-            <a:schemeClr val="accent1"/>
-          </a:lnRef>
-          <a:fillRef idx="0">
-            <a:schemeClr val="accent1"/>
-          </a:fillRef>
-          <a:effectRef idx="0">
-            <a:schemeClr val="accent1"/>
-          </a:effectRef>
-          <a:fontRef idx="minor">
-            <a:schemeClr val="tx1"/>
-          </a:fontRef>
-        </p:style>
-      </p:cxnSp>
-      <p:cxnSp>
-        <p:nvCxnSpPr>
-          <p:cNvPr id="68" name="Straight Arrow Connector 67">
-            <a:extLst>
-              <a:ext uri="{FF2B5EF4-FFF2-40B4-BE49-F238E27FC236}">
-                <a16:creationId xmlns:a16="http://schemas.microsoft.com/office/drawing/2014/main" id="{5C669222-507E-4E17-CA01-91029B54BF4A}"/>
-              </a:ext>
-            </a:extLst>
-          </p:cNvPr>
-          <p:cNvCxnSpPr>
-            <a:cxnSpLocks/>
-          </p:cNvCxnSpPr>
-          <p:nvPr/>
-        </p:nvCxnSpPr>
-        <p:spPr>
-          <a:xfrm flipV="1">
-            <a:off x="4611382" y="4894731"/>
-            <a:ext cx="0" cy="359965"/>
-          </a:xfrm>
-          <a:prstGeom prst="straightConnector1">
-            <a:avLst/>
-          </a:prstGeom>
-          <a:ln w="57150">
-            <a:solidFill>
-              <a:srgbClr val="4D4D4E"/>
-            </a:solidFill>
-            <a:tailEnd type="triangle"/>
-          </a:ln>
-        </p:spPr>
-        <p:style>
-          <a:lnRef idx="1">
-            <a:schemeClr val="accent1"/>
-          </a:lnRef>
-          <a:fillRef idx="0">
-            <a:schemeClr val="accent1"/>
-          </a:fillRef>
-          <a:effectRef idx="0">
-            <a:schemeClr val="accent1"/>
-          </a:effectRef>
-          <a:fontRef idx="minor">
-            <a:schemeClr val="tx1"/>
-          </a:fontRef>
-        </p:style>
-      </p:cxnSp>
-      <p:pic>
-        <p:nvPicPr>
-          <p:cNvPr id="31" name="Picture 30">
-            <a:extLst>
-              <a:ext uri="{FF2B5EF4-FFF2-40B4-BE49-F238E27FC236}">
-                <a16:creationId xmlns:a16="http://schemas.microsoft.com/office/drawing/2014/main" id="{741D210E-BC0D-1B12-B66D-7FBE430C7A2B}"/>
-              </a:ext>
-            </a:extLst>
-          </p:cNvPr>
-          <p:cNvPicPr>
-            <a:picLocks noChangeAspect="1"/>
-          </p:cNvPicPr>
-          <p:nvPr/>
-        </p:nvPicPr>
-        <p:blipFill>
-          <a:blip r:embed="rId10"/>
-          <a:stretch>
-            <a:fillRect/>
-          </a:stretch>
-        </p:blipFill>
-        <p:spPr>
-          <a:xfrm rot="12680291" flipH="1">
-            <a:off x="2817148" y="5020156"/>
-            <a:ext cx="886216" cy="264424"/>
-          </a:xfrm>
-          <a:prstGeom prst="rect">
-            <a:avLst/>
-          </a:prstGeom>
-        </p:spPr>
-      </p:pic>
       <p:sp>
         <p:nvSpPr>
           <p:cNvPr id="3" name="Arrow: Right 2">
@@ -15789,8 +15490,8 @@
         </p:nvSpPr>
         <p:spPr>
           <a:xfrm>
-            <a:off x="2470305" y="1520689"/>
-            <a:ext cx="6652162" cy="484632"/>
+            <a:off x="4822912" y="1542053"/>
+            <a:ext cx="4293931" cy="484632"/>
           </a:xfrm>
           <a:prstGeom prst="rightArrow">
             <a:avLst/>
@@ -15850,8 +15551,8 @@
         </p:nvSpPr>
         <p:spPr>
           <a:xfrm rot="10800000">
-            <a:off x="2450427" y="2171069"/>
-            <a:ext cx="6652162" cy="484632"/>
+            <a:off x="4808658" y="2171069"/>
+            <a:ext cx="4293931" cy="484632"/>
           </a:xfrm>
           <a:prstGeom prst="rightArrow">
             <a:avLst/>
@@ -15910,15 +15611,15 @@
           <p:nvPr/>
         </p:nvSpPr>
         <p:spPr>
-          <a:xfrm rot="2291880">
-            <a:off x="862633" y="3259787"/>
-            <a:ext cx="702666" cy="236178"/>
+          <a:xfrm>
+            <a:off x="2357112" y="1951200"/>
+            <a:ext cx="1136423" cy="369332"/>
           </a:xfrm>
           <a:prstGeom prst="rightArrow">
             <a:avLst/>
           </a:prstGeom>
           <a:noFill/>
-          <a:ln w="19050">
+          <a:ln w="28575">
             <a:solidFill>
               <a:schemeClr val="tx1">
                 <a:lumMod val="65000"/>
@@ -15958,6 +15659,371 @@
           </a:p>
         </p:txBody>
       </p:sp>
+      <p:grpSp>
+        <p:nvGrpSpPr>
+          <p:cNvPr id="19" name="Group 18">
+            <a:extLst>
+              <a:ext uri="{FF2B5EF4-FFF2-40B4-BE49-F238E27FC236}">
+                <a16:creationId xmlns:a16="http://schemas.microsoft.com/office/drawing/2014/main" id="{F1B39A18-70A9-03F6-E561-E7330C907482}"/>
+              </a:ext>
+            </a:extLst>
+          </p:cNvPr>
+          <p:cNvGrpSpPr/>
+          <p:nvPr/>
+        </p:nvGrpSpPr>
+        <p:grpSpPr>
+          <a:xfrm>
+            <a:off x="2097801" y="4242586"/>
+            <a:ext cx="1413783" cy="976739"/>
+            <a:chOff x="5722721" y="5018774"/>
+            <a:chExt cx="1157836" cy="787499"/>
+          </a:xfrm>
+        </p:grpSpPr>
+        <p:pic>
+          <p:nvPicPr>
+            <p:cNvPr id="20" name="Picture 19">
+              <a:extLst>
+                <a:ext uri="{FF2B5EF4-FFF2-40B4-BE49-F238E27FC236}">
+                  <a16:creationId xmlns:a16="http://schemas.microsoft.com/office/drawing/2014/main" id="{9F0EFA19-E671-2297-3A55-D427667B009E}"/>
+                </a:ext>
+              </a:extLst>
+            </p:cNvPr>
+            <p:cNvPicPr>
+              <a:picLocks noChangeAspect="1"/>
+            </p:cNvPicPr>
+            <p:nvPr/>
+          </p:nvPicPr>
+          <p:blipFill>
+            <a:blip r:embed="rId10"/>
+            <a:stretch>
+              <a:fillRect/>
+            </a:stretch>
+          </p:blipFill>
+          <p:spPr>
+            <a:xfrm rot="10800000">
+              <a:off x="5722721" y="5018774"/>
+              <a:ext cx="1146960" cy="342224"/>
+            </a:xfrm>
+            <a:prstGeom prst="rect">
+              <a:avLst/>
+            </a:prstGeom>
+          </p:spPr>
+        </p:pic>
+        <p:pic>
+          <p:nvPicPr>
+            <p:cNvPr id="21" name="Picture 20">
+              <a:extLst>
+                <a:ext uri="{FF2B5EF4-FFF2-40B4-BE49-F238E27FC236}">
+                  <a16:creationId xmlns:a16="http://schemas.microsoft.com/office/drawing/2014/main" id="{8D73D725-8513-FB78-41CC-6AB006A9D0C0}"/>
+                </a:ext>
+              </a:extLst>
+            </p:cNvPr>
+            <p:cNvPicPr>
+              <a:picLocks noChangeAspect="1"/>
+            </p:cNvPicPr>
+            <p:nvPr/>
+          </p:nvPicPr>
+          <p:blipFill>
+            <a:blip r:embed="rId10"/>
+            <a:stretch>
+              <a:fillRect/>
+            </a:stretch>
+          </p:blipFill>
+          <p:spPr>
+            <a:xfrm rot="10800000" flipH="1">
+              <a:off x="5733595" y="5464049"/>
+              <a:ext cx="1146962" cy="342224"/>
+            </a:xfrm>
+            <a:prstGeom prst="rect">
+              <a:avLst/>
+            </a:prstGeom>
+          </p:spPr>
+        </p:pic>
+      </p:grpSp>
+      <p:sp>
+        <p:nvSpPr>
+          <p:cNvPr id="22" name="Arrow: Right 21">
+            <a:extLst>
+              <a:ext uri="{FF2B5EF4-FFF2-40B4-BE49-F238E27FC236}">
+                <a16:creationId xmlns:a16="http://schemas.microsoft.com/office/drawing/2014/main" id="{11434227-1539-4E76-E115-9BCF75FFF332}"/>
+              </a:ext>
+            </a:extLst>
+          </p:cNvPr>
+          <p:cNvSpPr/>
+          <p:nvPr/>
+        </p:nvSpPr>
+        <p:spPr>
+          <a:xfrm rot="5400000">
+            <a:off x="3750373" y="3334736"/>
+            <a:ext cx="898269" cy="369332"/>
+          </a:xfrm>
+          <a:prstGeom prst="rightArrow">
+            <a:avLst/>
+          </a:prstGeom>
+          <a:noFill/>
+          <a:ln w="28575">
+            <a:solidFill>
+              <a:schemeClr val="tx1">
+                <a:lumMod val="65000"/>
+                <a:lumOff val="35000"/>
+              </a:schemeClr>
+            </a:solidFill>
+          </a:ln>
+        </p:spPr>
+        <p:style>
+          <a:lnRef idx="2">
+            <a:schemeClr val="accent1">
+              <a:shade val="15000"/>
+            </a:schemeClr>
+          </a:lnRef>
+          <a:fillRef idx="1">
+            <a:schemeClr val="accent1"/>
+          </a:fillRef>
+          <a:effectRef idx="0">
+            <a:schemeClr val="accent1"/>
+          </a:effectRef>
+          <a:fontRef idx="minor">
+            <a:schemeClr val="lt1"/>
+          </a:fontRef>
+        </p:style>
+        <p:txBody>
+          <a:bodyPr rtlCol="0" anchor="ctr"/>
+          <a:lstStyle/>
+          <a:p>
+            <a:pPr algn="ctr"/>
+            <a:endParaRPr lang="ru-RU">
+              <a:ln w="57150">
+                <a:solidFill>
+                  <a:schemeClr val="tx1"/>
+                </a:solidFill>
+              </a:ln>
+            </a:endParaRPr>
+          </a:p>
+        </p:txBody>
+      </p:sp>
+      <p:sp>
+        <p:nvSpPr>
+          <p:cNvPr id="23" name="Arrow: Right 22">
+            <a:extLst>
+              <a:ext uri="{FF2B5EF4-FFF2-40B4-BE49-F238E27FC236}">
+                <a16:creationId xmlns:a16="http://schemas.microsoft.com/office/drawing/2014/main" id="{8FC53B2C-B5A8-81B2-B5F9-DFE85786FC8F}"/>
+              </a:ext>
+            </a:extLst>
+          </p:cNvPr>
+          <p:cNvSpPr/>
+          <p:nvPr/>
+        </p:nvSpPr>
+        <p:spPr>
+          <a:xfrm rot="8980560">
+            <a:off x="1749754" y="3248099"/>
+            <a:ext cx="1900460" cy="389800"/>
+          </a:xfrm>
+          <a:prstGeom prst="rightArrow">
+            <a:avLst/>
+          </a:prstGeom>
+          <a:noFill/>
+          <a:ln w="28575">
+            <a:solidFill>
+              <a:schemeClr val="tx1">
+                <a:lumMod val="65000"/>
+                <a:lumOff val="35000"/>
+              </a:schemeClr>
+            </a:solidFill>
+          </a:ln>
+        </p:spPr>
+        <p:style>
+          <a:lnRef idx="2">
+            <a:schemeClr val="accent1">
+              <a:shade val="15000"/>
+            </a:schemeClr>
+          </a:lnRef>
+          <a:fillRef idx="1">
+            <a:schemeClr val="accent1"/>
+          </a:fillRef>
+          <a:effectRef idx="0">
+            <a:schemeClr val="accent1"/>
+          </a:effectRef>
+          <a:fontRef idx="minor">
+            <a:schemeClr val="lt1"/>
+          </a:fontRef>
+        </p:style>
+        <p:txBody>
+          <a:bodyPr rtlCol="0" anchor="ctr"/>
+          <a:lstStyle/>
+          <a:p>
+            <a:pPr algn="ctr"/>
+            <a:endParaRPr lang="ru-RU">
+              <a:ln w="57150">
+                <a:solidFill>
+                  <a:schemeClr val="tx1"/>
+                </a:solidFill>
+              </a:ln>
+            </a:endParaRPr>
+          </a:p>
+        </p:txBody>
+      </p:sp>
+      <p:grpSp>
+        <p:nvGrpSpPr>
+          <p:cNvPr id="28" name="Group 27">
+            <a:extLst>
+              <a:ext uri="{FF2B5EF4-FFF2-40B4-BE49-F238E27FC236}">
+                <a16:creationId xmlns:a16="http://schemas.microsoft.com/office/drawing/2014/main" id="{0BB628C2-0CC7-78B0-5273-7D2C00C3AF54}"/>
+              </a:ext>
+            </a:extLst>
+          </p:cNvPr>
+          <p:cNvGrpSpPr/>
+          <p:nvPr/>
+        </p:nvGrpSpPr>
+        <p:grpSpPr>
+          <a:xfrm>
+            <a:off x="4835207" y="4210008"/>
+            <a:ext cx="1413783" cy="976739"/>
+            <a:chOff x="5722721" y="5018774"/>
+            <a:chExt cx="1157836" cy="787499"/>
+          </a:xfrm>
+        </p:grpSpPr>
+        <p:pic>
+          <p:nvPicPr>
+            <p:cNvPr id="29" name="Picture 28">
+              <a:extLst>
+                <a:ext uri="{FF2B5EF4-FFF2-40B4-BE49-F238E27FC236}">
+                  <a16:creationId xmlns:a16="http://schemas.microsoft.com/office/drawing/2014/main" id="{16670E0F-88F1-CFCA-61C0-783A23D4043A}"/>
+                </a:ext>
+              </a:extLst>
+            </p:cNvPr>
+            <p:cNvPicPr>
+              <a:picLocks noChangeAspect="1"/>
+            </p:cNvPicPr>
+            <p:nvPr/>
+          </p:nvPicPr>
+          <p:blipFill>
+            <a:blip r:embed="rId10"/>
+            <a:stretch>
+              <a:fillRect/>
+            </a:stretch>
+          </p:blipFill>
+          <p:spPr>
+            <a:xfrm rot="10800000">
+              <a:off x="5722721" y="5018774"/>
+              <a:ext cx="1146960" cy="342224"/>
+            </a:xfrm>
+            <a:prstGeom prst="rect">
+              <a:avLst/>
+            </a:prstGeom>
+          </p:spPr>
+        </p:pic>
+        <p:pic>
+          <p:nvPicPr>
+            <p:cNvPr id="30" name="Picture 29">
+              <a:extLst>
+                <a:ext uri="{FF2B5EF4-FFF2-40B4-BE49-F238E27FC236}">
+                  <a16:creationId xmlns:a16="http://schemas.microsoft.com/office/drawing/2014/main" id="{0002B4AA-E488-EB16-5B4F-6C120E10DD69}"/>
+                </a:ext>
+              </a:extLst>
+            </p:cNvPr>
+            <p:cNvPicPr>
+              <a:picLocks noChangeAspect="1"/>
+            </p:cNvPicPr>
+            <p:nvPr/>
+          </p:nvPicPr>
+          <p:blipFill>
+            <a:blip r:embed="rId10"/>
+            <a:stretch>
+              <a:fillRect/>
+            </a:stretch>
+          </p:blipFill>
+          <p:spPr>
+            <a:xfrm rot="10800000" flipH="1">
+              <a:off x="5733595" y="5464049"/>
+              <a:ext cx="1146962" cy="342224"/>
+            </a:xfrm>
+            <a:prstGeom prst="rect">
+              <a:avLst/>
+            </a:prstGeom>
+          </p:spPr>
+        </p:pic>
+      </p:grpSp>
+      <p:grpSp>
+        <p:nvGrpSpPr>
+          <p:cNvPr id="38" name="Group 37">
+            <a:extLst>
+              <a:ext uri="{FF2B5EF4-FFF2-40B4-BE49-F238E27FC236}">
+                <a16:creationId xmlns:a16="http://schemas.microsoft.com/office/drawing/2014/main" id="{6A78D4E0-1CE7-61E5-0943-16AB1A97EDBA}"/>
+              </a:ext>
+            </a:extLst>
+          </p:cNvPr>
+          <p:cNvGrpSpPr/>
+          <p:nvPr/>
+        </p:nvGrpSpPr>
+        <p:grpSpPr>
+          <a:xfrm>
+            <a:off x="8875629" y="4180313"/>
+            <a:ext cx="1413783" cy="976739"/>
+            <a:chOff x="5722721" y="5018774"/>
+            <a:chExt cx="1157836" cy="787499"/>
+          </a:xfrm>
+        </p:grpSpPr>
+        <p:pic>
+          <p:nvPicPr>
+            <p:cNvPr id="40" name="Picture 39">
+              <a:extLst>
+                <a:ext uri="{FF2B5EF4-FFF2-40B4-BE49-F238E27FC236}">
+                  <a16:creationId xmlns:a16="http://schemas.microsoft.com/office/drawing/2014/main" id="{A88AC7AD-7EA6-C581-B9AD-1C8946836698}"/>
+                </a:ext>
+              </a:extLst>
+            </p:cNvPr>
+            <p:cNvPicPr>
+              <a:picLocks noChangeAspect="1"/>
+            </p:cNvPicPr>
+            <p:nvPr/>
+          </p:nvPicPr>
+          <p:blipFill>
+            <a:blip r:embed="rId10"/>
+            <a:stretch>
+              <a:fillRect/>
+            </a:stretch>
+          </p:blipFill>
+          <p:spPr>
+            <a:xfrm rot="10800000">
+              <a:off x="5722721" y="5018774"/>
+              <a:ext cx="1146960" cy="342224"/>
+            </a:xfrm>
+            <a:prstGeom prst="rect">
+              <a:avLst/>
+            </a:prstGeom>
+          </p:spPr>
+        </p:pic>
+        <p:pic>
+          <p:nvPicPr>
+            <p:cNvPr id="46" name="Picture 45">
+              <a:extLst>
+                <a:ext uri="{FF2B5EF4-FFF2-40B4-BE49-F238E27FC236}">
+                  <a16:creationId xmlns:a16="http://schemas.microsoft.com/office/drawing/2014/main" id="{C1665200-A64B-4249-C4B8-F19B866D334E}"/>
+                </a:ext>
+              </a:extLst>
+            </p:cNvPr>
+            <p:cNvPicPr>
+              <a:picLocks noChangeAspect="1"/>
+            </p:cNvPicPr>
+            <p:nvPr/>
+          </p:nvPicPr>
+          <p:blipFill>
+            <a:blip r:embed="rId10"/>
+            <a:stretch>
+              <a:fillRect/>
+            </a:stretch>
+          </p:blipFill>
+          <p:spPr>
+            <a:xfrm rot="10800000" flipH="1">
+              <a:off x="5733595" y="5464049"/>
+              <a:ext cx="1146962" cy="342224"/>
+            </a:xfrm>
+            <a:prstGeom prst="rect">
+              <a:avLst/>
+            </a:prstGeom>
+          </p:spPr>
+        </p:pic>
+      </p:grpSp>
     </p:spTree>
     <p:extLst>
       <p:ext uri="{BB962C8B-B14F-4D97-AF65-F5344CB8AC3E}">
@@ -16341,7 +16407,7 @@
         </p:nvSpPr>
         <p:spPr>
           <a:xfrm>
-            <a:off x="2879953" y="2377041"/>
+            <a:off x="2838094" y="1134745"/>
             <a:ext cx="2804845" cy="626607"/>
           </a:xfrm>
           <a:prstGeom prst="rect">
@@ -16402,8 +16468,8 @@
         </p:nvCxnSpPr>
         <p:spPr>
           <a:xfrm flipV="1">
-            <a:off x="2317077" y="2690345"/>
-            <a:ext cx="562876" cy="1034519"/>
+            <a:off x="2317077" y="1448049"/>
+            <a:ext cx="521017" cy="2276815"/>
           </a:xfrm>
           <a:prstGeom prst="bentConnector3">
             <a:avLst/>
@@ -16765,87 +16831,6 @@
       </p:sp>
       <p:grpSp>
         <p:nvGrpSpPr>
-          <p:cNvPr id="52" name="Group 51">
-            <a:extLst>
-              <a:ext uri="{FF2B5EF4-FFF2-40B4-BE49-F238E27FC236}">
-                <a16:creationId xmlns:a16="http://schemas.microsoft.com/office/drawing/2014/main" id="{0D19DEE1-3A2E-4D29-B086-87E9AF69FB70}"/>
-              </a:ext>
-            </a:extLst>
-          </p:cNvPr>
-          <p:cNvGrpSpPr/>
-          <p:nvPr/>
-        </p:nvGrpSpPr>
-        <p:grpSpPr>
-          <a:xfrm rot="16200000">
-            <a:off x="8506838" y="5107457"/>
-            <a:ext cx="490073" cy="333322"/>
-            <a:chOff x="9590966" y="4185349"/>
-            <a:chExt cx="1157836" cy="787499"/>
-          </a:xfrm>
-        </p:grpSpPr>
-        <p:pic>
-          <p:nvPicPr>
-            <p:cNvPr id="50" name="Picture 49">
-              <a:extLst>
-                <a:ext uri="{FF2B5EF4-FFF2-40B4-BE49-F238E27FC236}">
-                  <a16:creationId xmlns:a16="http://schemas.microsoft.com/office/drawing/2014/main" id="{18A56A1B-C84B-E09A-3B41-68361A5751BC}"/>
-                </a:ext>
-              </a:extLst>
-            </p:cNvPr>
-            <p:cNvPicPr>
-              <a:picLocks noChangeAspect="1"/>
-            </p:cNvPicPr>
-            <p:nvPr/>
-          </p:nvPicPr>
-          <p:blipFill>
-            <a:blip r:embed="rId7"/>
-            <a:stretch>
-              <a:fillRect/>
-            </a:stretch>
-          </p:blipFill>
-          <p:spPr>
-            <a:xfrm rot="10800000">
-              <a:off x="9590966" y="4185349"/>
-              <a:ext cx="1146960" cy="342224"/>
-            </a:xfrm>
-            <a:prstGeom prst="rect">
-              <a:avLst/>
-            </a:prstGeom>
-          </p:spPr>
-        </p:pic>
-        <p:pic>
-          <p:nvPicPr>
-            <p:cNvPr id="51" name="Picture 50">
-              <a:extLst>
-                <a:ext uri="{FF2B5EF4-FFF2-40B4-BE49-F238E27FC236}">
-                  <a16:creationId xmlns:a16="http://schemas.microsoft.com/office/drawing/2014/main" id="{53DE1425-4595-F69F-F29C-49278A1C0337}"/>
-                </a:ext>
-              </a:extLst>
-            </p:cNvPr>
-            <p:cNvPicPr>
-              <a:picLocks noChangeAspect="1"/>
-            </p:cNvPicPr>
-            <p:nvPr/>
-          </p:nvPicPr>
-          <p:blipFill>
-            <a:blip r:embed="rId7"/>
-            <a:stretch>
-              <a:fillRect/>
-            </a:stretch>
-          </p:blipFill>
-          <p:spPr>
-            <a:xfrm rot="10800000" flipH="1">
-              <a:off x="9601840" y="4630624"/>
-              <a:ext cx="1146962" cy="342224"/>
-            </a:xfrm>
-            <a:prstGeom prst="rect">
-              <a:avLst/>
-            </a:prstGeom>
-          </p:spPr>
-        </p:pic>
-      </p:grpSp>
-      <p:grpSp>
-        <p:nvGrpSpPr>
           <p:cNvPr id="97" name="Group 96">
             <a:extLst>
               <a:ext uri="{FF2B5EF4-FFF2-40B4-BE49-F238E27FC236}">
@@ -16858,10 +16843,10 @@
         </p:nvGrpSpPr>
         <p:grpSpPr>
           <a:xfrm>
-            <a:off x="7400260" y="5568268"/>
-            <a:ext cx="2703769" cy="1171441"/>
+            <a:off x="7400259" y="5568268"/>
+            <a:ext cx="2703232" cy="1171891"/>
             <a:chOff x="7861714" y="5230663"/>
-            <a:chExt cx="2020105" cy="1514605"/>
+            <a:chExt cx="2019704" cy="1515187"/>
           </a:xfrm>
         </p:grpSpPr>
         <p:sp>
@@ -16933,7 +16918,7 @@
           <p:spPr>
             <a:xfrm>
               <a:off x="7861714" y="5353070"/>
-              <a:ext cx="2020105" cy="1077218"/>
+              <a:ext cx="1509309" cy="1392780"/>
             </a:xfrm>
             <a:prstGeom prst="rect">
               <a:avLst/>
@@ -16954,7 +16939,7 @@
                 <a:rPr lang="en-US" sz="1600" dirty="0">
                   <a:latin typeface="Century Gothic" panose="020B0502020202020204" pitchFamily="34" charset="0"/>
                 </a:rPr>
-                <a:t>Send()</a:t>
+                <a:t>Open()</a:t>
               </a:r>
               <a:endParaRPr lang="ru-RU" sz="1600" dirty="0">
                 <a:latin typeface="Century Gothic" panose="020B0502020202020204" pitchFamily="34" charset="0"/>
@@ -17181,56 +17166,6 @@
           </a:fontRef>
         </p:style>
       </p:cxnSp>
-      <p:cxnSp>
-        <p:nvCxnSpPr>
-          <p:cNvPr id="83" name="Elbow Connector 82">
-            <a:extLst>
-              <a:ext uri="{FF2B5EF4-FFF2-40B4-BE49-F238E27FC236}">
-                <a16:creationId xmlns:a16="http://schemas.microsoft.com/office/drawing/2014/main" id="{297ED4CB-1C93-DDA3-6A3C-52E5A572C13F}"/>
-              </a:ext>
-            </a:extLst>
-          </p:cNvPr>
-          <p:cNvCxnSpPr>
-            <a:cxnSpLocks/>
-            <a:stCxn id="3" idx="3"/>
-            <a:endCxn id="80" idx="1"/>
-          </p:cNvCxnSpPr>
-          <p:nvPr/>
-        </p:nvCxnSpPr>
-        <p:spPr>
-          <a:xfrm flipV="1">
-            <a:off x="5684798" y="2000375"/>
-            <a:ext cx="1715462" cy="689970"/>
-          </a:xfrm>
-          <a:prstGeom prst="bentConnector3">
-            <a:avLst>
-              <a:gd name="adj1" fmla="val 50000"/>
-            </a:avLst>
-          </a:prstGeom>
-          <a:ln w="57150">
-            <a:solidFill>
-              <a:schemeClr val="accent1">
-                <a:lumMod val="50000"/>
-              </a:schemeClr>
-            </a:solidFill>
-            <a:tailEnd type="triangle"/>
-          </a:ln>
-        </p:spPr>
-        <p:style>
-          <a:lnRef idx="1">
-            <a:schemeClr val="accent1"/>
-          </a:lnRef>
-          <a:fillRef idx="0">
-            <a:schemeClr val="accent1"/>
-          </a:fillRef>
-          <a:effectRef idx="0">
-            <a:schemeClr val="accent1"/>
-          </a:effectRef>
-          <a:fontRef idx="minor">
-            <a:schemeClr val="tx1"/>
-          </a:fontRef>
-        </p:style>
-      </p:cxnSp>
       <p:sp>
         <p:nvSpPr>
           <p:cNvPr id="91" name="Rectangle 90">
@@ -17332,14 +17267,15 @@
             </a:extLst>
           </p:cNvPr>
           <p:cNvCxnSpPr>
-            <a:stCxn id="3" idx="2"/>
+            <a:cxnSpLocks/>
+            <a:endCxn id="25" idx="0"/>
           </p:cNvCxnSpPr>
           <p:nvPr/>
         </p:nvCxnSpPr>
         <p:spPr>
-          <a:xfrm flipH="1">
-            <a:off x="4282375" y="3003648"/>
-            <a:ext cx="1" cy="1149905"/>
+          <a:xfrm>
+            <a:off x="4712498" y="1761352"/>
+            <a:ext cx="0" cy="676177"/>
           </a:xfrm>
           <a:prstGeom prst="straightConnector1">
             <a:avLst/>
@@ -17730,13 +17666,15 @@
               </a:ext>
             </a:extLst>
           </p:cNvPr>
-          <p:cNvCxnSpPr/>
+          <p:cNvCxnSpPr>
+            <a:cxnSpLocks/>
+          </p:cNvCxnSpPr>
           <p:nvPr/>
         </p:nvCxnSpPr>
         <p:spPr>
           <a:xfrm>
-            <a:off x="3008316" y="3003648"/>
-            <a:ext cx="0" cy="2234905"/>
+            <a:off x="3008316" y="1761352"/>
+            <a:ext cx="0" cy="3477201"/>
           </a:xfrm>
           <a:prstGeom prst="line">
             <a:avLst/>
@@ -17764,24 +17702,128 @@
           </a:fontRef>
         </p:style>
       </p:cxnSp>
-      <p:cxnSp>
-        <p:nvCxnSpPr>
-          <p:cNvPr id="107" name="Straight Connector 106">
+      <p:sp>
+        <p:nvSpPr>
+          <p:cNvPr id="25" name="Diamond 24">
             <a:extLst>
               <a:ext uri="{FF2B5EF4-FFF2-40B4-BE49-F238E27FC236}">
-                <a16:creationId xmlns:a16="http://schemas.microsoft.com/office/drawing/2014/main" id="{FFF735D6-288F-21CB-F7FA-53B7DF2A6EB1}"/>
+                <a16:creationId xmlns:a16="http://schemas.microsoft.com/office/drawing/2014/main" id="{14DD1AFE-249A-59AD-A37B-8802B8C4066F}"/>
               </a:ext>
             </a:extLst>
           </p:cNvPr>
-          <p:cNvCxnSpPr/>
+          <p:cNvSpPr/>
+          <p:nvPr/>
+        </p:nvSpPr>
+        <p:spPr>
+          <a:xfrm>
+            <a:off x="3241179" y="2437529"/>
+            <a:ext cx="2942638" cy="1241024"/>
+          </a:xfrm>
+          <a:prstGeom prst="diamond">
+            <a:avLst/>
+          </a:prstGeom>
+          <a:noFill/>
+          <a:ln w="57150">
+            <a:solidFill>
+              <a:schemeClr val="accent1">
+                <a:lumMod val="50000"/>
+              </a:schemeClr>
+            </a:solidFill>
+          </a:ln>
+        </p:spPr>
+        <p:style>
+          <a:lnRef idx="2">
+            <a:schemeClr val="accent1">
+              <a:shade val="15000"/>
+            </a:schemeClr>
+          </a:lnRef>
+          <a:fillRef idx="1">
+            <a:schemeClr val="accent1"/>
+          </a:fillRef>
+          <a:effectRef idx="0">
+            <a:schemeClr val="accent1"/>
+          </a:effectRef>
+          <a:fontRef idx="minor">
+            <a:schemeClr val="lt1"/>
+          </a:fontRef>
+        </p:style>
+        <p:txBody>
+          <a:bodyPr rtlCol="0" anchor="ctr"/>
+          <a:lstStyle/>
+          <a:p>
+            <a:pPr algn="ctr"/>
+            <a:endParaRPr lang="ru-RU" dirty="0"/>
+          </a:p>
+        </p:txBody>
+      </p:sp>
+      <p:sp>
+        <p:nvSpPr>
+          <p:cNvPr id="29" name="TextBox 28">
+            <a:extLst>
+              <a:ext uri="{FF2B5EF4-FFF2-40B4-BE49-F238E27FC236}">
+                <a16:creationId xmlns:a16="http://schemas.microsoft.com/office/drawing/2014/main" id="{40C1B0E6-AFC9-7CC4-AB34-578636AF89E1}"/>
+              </a:ext>
+            </a:extLst>
+          </p:cNvPr>
+          <p:cNvSpPr txBox="1"/>
+          <p:nvPr/>
+        </p:nvSpPr>
+        <p:spPr>
+          <a:xfrm>
+            <a:off x="3728116" y="2576622"/>
+            <a:ext cx="1990287" cy="923330"/>
+          </a:xfrm>
+          <a:prstGeom prst="rect">
+            <a:avLst/>
+          </a:prstGeom>
+          <a:noFill/>
+        </p:spPr>
+        <p:txBody>
+          <a:bodyPr wrap="square" rtlCol="0">
+            <a:spAutoFit/>
+          </a:bodyPr>
+          <a:lstStyle/>
+          <a:p>
+            <a:pPr algn="ctr"/>
+            <a:r>
+              <a:rPr lang="ru-RU" dirty="0">
+                <a:latin typeface="Century Gothic" panose="020B0502020202020204" pitchFamily="34" charset="0"/>
+              </a:rPr>
+              <a:t>Выбран многопоточный</a:t>
+            </a:r>
+          </a:p>
+          <a:p>
+            <a:pPr algn="ctr"/>
+            <a:r>
+              <a:rPr lang="ru-RU" dirty="0">
+                <a:latin typeface="Century Gothic" panose="020B0502020202020204" pitchFamily="34" charset="0"/>
+              </a:rPr>
+              <a:t>режим?</a:t>
+            </a:r>
+          </a:p>
+        </p:txBody>
+      </p:sp>
+      <p:cxnSp>
+        <p:nvCxnSpPr>
+          <p:cNvPr id="31" name="Straight Arrow Connector 30">
+            <a:extLst>
+              <a:ext uri="{FF2B5EF4-FFF2-40B4-BE49-F238E27FC236}">
+                <a16:creationId xmlns:a16="http://schemas.microsoft.com/office/drawing/2014/main" id="{BB18AC2F-7E53-5B88-4503-4EF35FBFDCA0}"/>
+              </a:ext>
+            </a:extLst>
+          </p:cNvPr>
+          <p:cNvCxnSpPr>
+            <a:cxnSpLocks/>
+            <a:stCxn id="25" idx="2"/>
+          </p:cNvCxnSpPr>
           <p:nvPr/>
         </p:nvCxnSpPr>
         <p:spPr>
           <a:xfrm>
-            <a:off x="3860800" y="4780160"/>
-            <a:ext cx="0" cy="458393"/>
-          </a:xfrm>
-          <a:prstGeom prst="line">
+            <a:off x="4712498" y="3678553"/>
+            <a:ext cx="0" cy="475000"/>
+          </a:xfrm>
+          <a:prstGeom prst="straightConnector1">
             <a:avLst/>
           </a:prstGeom>
           <a:ln w="57150">
@@ -17790,6 +17832,7 @@
                 <a:lumMod val="50000"/>
               </a:schemeClr>
             </a:solidFill>
+            <a:tailEnd type="triangle"/>
           </a:ln>
         </p:spPr>
         <p:style>
@@ -17807,6 +17850,252 @@
           </a:fontRef>
         </p:style>
       </p:cxnSp>
+      <p:sp>
+        <p:nvSpPr>
+          <p:cNvPr id="33" name="TextBox 32">
+            <a:extLst>
+              <a:ext uri="{FF2B5EF4-FFF2-40B4-BE49-F238E27FC236}">
+                <a16:creationId xmlns:a16="http://schemas.microsoft.com/office/drawing/2014/main" id="{072F1D6F-85D2-C2A0-2C32-D915D87F653E}"/>
+              </a:ext>
+            </a:extLst>
+          </p:cNvPr>
+          <p:cNvSpPr txBox="1"/>
+          <p:nvPr/>
+        </p:nvSpPr>
+        <p:spPr>
+          <a:xfrm>
+            <a:off x="4759936" y="3678553"/>
+            <a:ext cx="514885" cy="369332"/>
+          </a:xfrm>
+          <a:prstGeom prst="rect">
+            <a:avLst/>
+          </a:prstGeom>
+          <a:noFill/>
+        </p:spPr>
+        <p:txBody>
+          <a:bodyPr wrap="none" rtlCol="0">
+            <a:spAutoFit/>
+          </a:bodyPr>
+          <a:lstStyle/>
+          <a:p>
+            <a:r>
+              <a:rPr lang="ru-RU" dirty="0">
+                <a:latin typeface="Century Gothic" panose="020B0502020202020204" pitchFamily="34" charset="0"/>
+              </a:rPr>
+              <a:t>Да</a:t>
+            </a:r>
+          </a:p>
+        </p:txBody>
+      </p:sp>
+      <p:cxnSp>
+        <p:nvCxnSpPr>
+          <p:cNvPr id="34" name="Connector: Elbow 33">
+            <a:extLst>
+              <a:ext uri="{FF2B5EF4-FFF2-40B4-BE49-F238E27FC236}">
+                <a16:creationId xmlns:a16="http://schemas.microsoft.com/office/drawing/2014/main" id="{AB687399-5727-A428-CE93-675D4D5F9A77}"/>
+              </a:ext>
+            </a:extLst>
+          </p:cNvPr>
+          <p:cNvCxnSpPr>
+            <a:cxnSpLocks/>
+            <a:stCxn id="25" idx="3"/>
+            <a:endCxn id="80" idx="1"/>
+          </p:cNvCxnSpPr>
+          <p:nvPr/>
+        </p:nvCxnSpPr>
+        <p:spPr>
+          <a:xfrm flipV="1">
+            <a:off x="6183817" y="2000375"/>
+            <a:ext cx="1216443" cy="1057666"/>
+          </a:xfrm>
+          <a:prstGeom prst="bentConnector3">
+            <a:avLst>
+              <a:gd name="adj1" fmla="val 73538"/>
+            </a:avLst>
+          </a:prstGeom>
+          <a:ln w="57150">
+            <a:solidFill>
+              <a:schemeClr val="accent1">
+                <a:lumMod val="50000"/>
+              </a:schemeClr>
+            </a:solidFill>
+            <a:tailEnd type="triangle"/>
+          </a:ln>
+        </p:spPr>
+        <p:style>
+          <a:lnRef idx="1">
+            <a:schemeClr val="accent1"/>
+          </a:lnRef>
+          <a:fillRef idx="0">
+            <a:schemeClr val="accent1"/>
+          </a:fillRef>
+          <a:effectRef idx="0">
+            <a:schemeClr val="accent1"/>
+          </a:effectRef>
+          <a:fontRef idx="minor">
+            <a:schemeClr val="tx1"/>
+          </a:fontRef>
+        </p:style>
+      </p:cxnSp>
+      <p:sp>
+        <p:nvSpPr>
+          <p:cNvPr id="38" name="TextBox 37">
+            <a:extLst>
+              <a:ext uri="{FF2B5EF4-FFF2-40B4-BE49-F238E27FC236}">
+                <a16:creationId xmlns:a16="http://schemas.microsoft.com/office/drawing/2014/main" id="{099030D3-5C90-BA20-52A3-22318F268114}"/>
+              </a:ext>
+            </a:extLst>
+          </p:cNvPr>
+          <p:cNvSpPr txBox="1"/>
+          <p:nvPr/>
+        </p:nvSpPr>
+        <p:spPr>
+          <a:xfrm>
+            <a:off x="6336436" y="2688400"/>
+            <a:ext cx="580608" cy="369332"/>
+          </a:xfrm>
+          <a:prstGeom prst="rect">
+            <a:avLst/>
+          </a:prstGeom>
+          <a:noFill/>
+        </p:spPr>
+        <p:txBody>
+          <a:bodyPr wrap="none" rtlCol="0">
+            <a:spAutoFit/>
+          </a:bodyPr>
+          <a:lstStyle/>
+          <a:p>
+            <a:r>
+              <a:rPr lang="ru-RU" dirty="0">
+                <a:latin typeface="Century Gothic" panose="020B0502020202020204" pitchFamily="34" charset="0"/>
+              </a:rPr>
+              <a:t>Нет</a:t>
+            </a:r>
+          </a:p>
+        </p:txBody>
+      </p:sp>
+      <p:sp>
+        <p:nvSpPr>
+          <p:cNvPr id="39" name="Arrow: Right 38">
+            <a:extLst>
+              <a:ext uri="{FF2B5EF4-FFF2-40B4-BE49-F238E27FC236}">
+                <a16:creationId xmlns:a16="http://schemas.microsoft.com/office/drawing/2014/main" id="{43C73299-7EBB-77A6-93C2-33085FB3DA32}"/>
+              </a:ext>
+            </a:extLst>
+          </p:cNvPr>
+          <p:cNvSpPr/>
+          <p:nvPr/>
+        </p:nvSpPr>
+        <p:spPr>
+          <a:xfrm rot="16200000">
+            <a:off x="7837365" y="5035126"/>
+            <a:ext cx="491254" cy="406853"/>
+          </a:xfrm>
+          <a:prstGeom prst="rightArrow">
+            <a:avLst/>
+          </a:prstGeom>
+          <a:noFill/>
+          <a:ln w="28575">
+            <a:solidFill>
+              <a:schemeClr val="tx1">
+                <a:lumMod val="65000"/>
+                <a:lumOff val="35000"/>
+              </a:schemeClr>
+            </a:solidFill>
+          </a:ln>
+        </p:spPr>
+        <p:style>
+          <a:lnRef idx="2">
+            <a:schemeClr val="accent1">
+              <a:shade val="15000"/>
+            </a:schemeClr>
+          </a:lnRef>
+          <a:fillRef idx="1">
+            <a:schemeClr val="accent1"/>
+          </a:fillRef>
+          <a:effectRef idx="0">
+            <a:schemeClr val="accent1"/>
+          </a:effectRef>
+          <a:fontRef idx="minor">
+            <a:schemeClr val="lt1"/>
+          </a:fontRef>
+        </p:style>
+        <p:txBody>
+          <a:bodyPr rtlCol="0" anchor="ctr"/>
+          <a:lstStyle/>
+          <a:p>
+            <a:pPr algn="ctr"/>
+            <a:endParaRPr lang="ru-RU">
+              <a:ln w="57150">
+                <a:solidFill>
+                  <a:schemeClr val="tx1"/>
+                </a:solidFill>
+              </a:ln>
+            </a:endParaRPr>
+          </a:p>
+        </p:txBody>
+      </p:sp>
+      <p:sp>
+        <p:nvSpPr>
+          <p:cNvPr id="40" name="Arrow: Right 39">
+            <a:extLst>
+              <a:ext uri="{FF2B5EF4-FFF2-40B4-BE49-F238E27FC236}">
+                <a16:creationId xmlns:a16="http://schemas.microsoft.com/office/drawing/2014/main" id="{592F9ADA-1F8D-C074-801B-522FE9A5D752}"/>
+              </a:ext>
+            </a:extLst>
+          </p:cNvPr>
+          <p:cNvSpPr/>
+          <p:nvPr/>
+        </p:nvSpPr>
+        <p:spPr>
+          <a:xfrm rot="5400000">
+            <a:off x="9208961" y="5067455"/>
+            <a:ext cx="491254" cy="406853"/>
+          </a:xfrm>
+          <a:prstGeom prst="rightArrow">
+            <a:avLst/>
+          </a:prstGeom>
+          <a:noFill/>
+          <a:ln w="28575">
+            <a:solidFill>
+              <a:schemeClr val="tx1">
+                <a:lumMod val="65000"/>
+                <a:lumOff val="35000"/>
+              </a:schemeClr>
+            </a:solidFill>
+          </a:ln>
+        </p:spPr>
+        <p:style>
+          <a:lnRef idx="2">
+            <a:schemeClr val="accent1">
+              <a:shade val="15000"/>
+            </a:schemeClr>
+          </a:lnRef>
+          <a:fillRef idx="1">
+            <a:schemeClr val="accent1"/>
+          </a:fillRef>
+          <a:effectRef idx="0">
+            <a:schemeClr val="accent1"/>
+          </a:effectRef>
+          <a:fontRef idx="minor">
+            <a:schemeClr val="lt1"/>
+          </a:fontRef>
+        </p:style>
+        <p:txBody>
+          <a:bodyPr rtlCol="0" anchor="ctr"/>
+          <a:lstStyle/>
+          <a:p>
+            <a:pPr algn="ctr"/>
+            <a:endParaRPr lang="ru-RU">
+              <a:ln w="57150">
+                <a:solidFill>
+                  <a:schemeClr val="tx1"/>
+                </a:solidFill>
+              </a:ln>
+            </a:endParaRPr>
+          </a:p>
+        </p:txBody>
+      </p:sp>
     </p:spTree>
     <p:extLst>
       <p:ext uri="{BB962C8B-B14F-4D97-AF65-F5344CB8AC3E}">

</xml_diff>

<commit_message>
Minor changes to presentation.
</commit_message>
<xml_diff>
--- a/Presentation/NMSTU_Presentation.pptx
+++ b/Presentation/NMSTU_Presentation.pptx
@@ -227,7 +227,7 @@
           <a:p>
             <a:fld id="{1E26F5DA-879A-4326-91CA-0B965521B3A2}" type="datetimeFigureOut">
               <a:rPr lang="ru-RU" smtClean="0"/>
-              <a:t>17.06.2025</a:t>
+              <a:t>19.06.2025</a:t>
             </a:fld>
             <a:endParaRPr lang="ru-RU"/>
           </a:p>
@@ -404,7 +404,7 @@
           <a:p>
             <a:fld id="{536AE87B-970E-4FB6-80B1-2A90D9E8F8EA}" type="datetimeFigureOut">
               <a:rPr lang="en-US" smtClean="0"/>
-              <a:t>6/17/2025</a:t>
+              <a:t>6/19/2025</a:t>
             </a:fld>
             <a:endParaRPr lang="en-US"/>
           </a:p>
@@ -2673,7 +2673,7 @@
           <a:p>
             <a:fld id="{2BA16B55-A083-400A-A53D-83CD673D7AB5}" type="datetime1">
               <a:rPr lang="ru-RU" smtClean="0"/>
-              <a:t>17.06.2025</a:t>
+              <a:t>19.06.2025</a:t>
             </a:fld>
             <a:endParaRPr lang="ru-RU"/>
           </a:p>
@@ -2846,7 +2846,7 @@
           <a:p>
             <a:fld id="{E2DC6F81-D76A-46BC-82B2-E452FF2CA9C5}" type="datetime1">
               <a:rPr lang="ru-RU" smtClean="0"/>
-              <a:t>17.06.2025</a:t>
+              <a:t>19.06.2025</a:t>
             </a:fld>
             <a:endParaRPr lang="ru-RU"/>
           </a:p>
@@ -3024,7 +3024,7 @@
           <a:p>
             <a:fld id="{48484A5D-C6EA-476C-B204-F5D11ADE9E0C}" type="datetime1">
               <a:rPr lang="ru-RU" smtClean="0"/>
-              <a:t>17.06.2025</a:t>
+              <a:t>19.06.2025</a:t>
             </a:fld>
             <a:endParaRPr lang="ru-RU"/>
           </a:p>
@@ -3192,7 +3192,7 @@
           <a:p>
             <a:fld id="{EB2C1C20-8488-406D-BEC1-3EBBFF7F0C88}" type="datetime1">
               <a:rPr lang="ru-RU" smtClean="0"/>
-              <a:t>17.06.2025</a:t>
+              <a:t>19.06.2025</a:t>
             </a:fld>
             <a:endParaRPr lang="ru-RU"/>
           </a:p>
@@ -3442,7 +3442,7 @@
           <a:p>
             <a:fld id="{B64FA3E3-1B09-48E4-B3AA-C803D5E16A77}" type="datetime1">
               <a:rPr lang="ru-RU" smtClean="0"/>
-              <a:t>17.06.2025</a:t>
+              <a:t>19.06.2025</a:t>
             </a:fld>
             <a:endParaRPr lang="ru-RU"/>
           </a:p>
@@ -3671,7 +3671,7 @@
           <a:p>
             <a:fld id="{62A63F76-3CA2-4748-A29D-2AB22D0BEB5B}" type="datetime1">
               <a:rPr lang="ru-RU" smtClean="0"/>
-              <a:t>17.06.2025</a:t>
+              <a:t>19.06.2025</a:t>
             </a:fld>
             <a:endParaRPr lang="ru-RU"/>
           </a:p>
@@ -4035,7 +4035,7 @@
           <a:p>
             <a:fld id="{A544ED6F-8BE4-4669-B0A3-175B5B131B11}" type="datetime1">
               <a:rPr lang="ru-RU" smtClean="0"/>
-              <a:t>17.06.2025</a:t>
+              <a:t>19.06.2025</a:t>
             </a:fld>
             <a:endParaRPr lang="ru-RU"/>
           </a:p>
@@ -4157,7 +4157,7 @@
           <a:p>
             <a:fld id="{4737DC02-F460-4FDC-95DB-DC6352A1EE94}" type="datetime1">
               <a:rPr lang="ru-RU" smtClean="0"/>
-              <a:t>17.06.2025</a:t>
+              <a:t>19.06.2025</a:t>
             </a:fld>
             <a:endParaRPr lang="ru-RU"/>
           </a:p>
@@ -4257,7 +4257,7 @@
           <a:p>
             <a:fld id="{6EB7CF50-D4ED-4F06-9251-EFB3C02E6C46}" type="datetime1">
               <a:rPr lang="ru-RU" smtClean="0"/>
-              <a:t>17.06.2025</a:t>
+              <a:t>19.06.2025</a:t>
             </a:fld>
             <a:endParaRPr lang="ru-RU"/>
           </a:p>
@@ -4537,7 +4537,7 @@
           <a:p>
             <a:fld id="{FA48FBA7-1AD2-4D2B-BCA1-27950A33E466}" type="datetime1">
               <a:rPr lang="ru-RU" smtClean="0"/>
-              <a:t>17.06.2025</a:t>
+              <a:t>19.06.2025</a:t>
             </a:fld>
             <a:endParaRPr lang="ru-RU"/>
           </a:p>
@@ -4789,7 +4789,7 @@
           <a:p>
             <a:fld id="{E233C2C1-A2CA-49E6-9101-CA7FFB180E53}" type="datetime1">
               <a:rPr lang="ru-RU" smtClean="0"/>
-              <a:t>17.06.2025</a:t>
+              <a:t>19.06.2025</a:t>
             </a:fld>
             <a:endParaRPr lang="ru-RU"/>
           </a:p>
@@ -5000,7 +5000,7 @@
           <a:p>
             <a:fld id="{642239AA-F603-409E-949B-21A349D872FF}" type="datetime1">
               <a:rPr lang="ru-RU" smtClean="0"/>
-              <a:t>17.06.2025</a:t>
+              <a:t>19.06.2025</a:t>
             </a:fld>
             <a:endParaRPr lang="ru-RU"/>
           </a:p>
@@ -7649,8 +7649,8 @@
         </p:nvGrpSpPr>
         <p:grpSpPr>
           <a:xfrm>
-            <a:off x="4134526" y="2873570"/>
-            <a:ext cx="1250190" cy="744867"/>
+            <a:off x="4119564" y="2864457"/>
+            <a:ext cx="1250190" cy="868777"/>
             <a:chOff x="3051580" y="2997200"/>
             <a:chExt cx="1486171" cy="885465"/>
           </a:xfrm>

</xml_diff>